<commit_message>
Outfit Lab: final version for Git week
- 7 steps; one Next button runs the class; the projector is the slide deck
- Hands-on rebase (author time kept, new committer time), fast-forward then
  branch -d, revert vs reset, squash + force push; one technical card per tool
- Integration paths and code velocity from the class's own data (paper §6)
- Student tour, hints, in-app answers and takeaways; balanced groups for any
  class size; practice lab for 1-3 students; Rehearse with bots
- Live updates work through tunnels (fallback polling)
- Demo video (4:50), storyboard, GIF; README: covered, run, host, demo
- Tests: 81/81 unit, full class + 2-student + blocked-stream e2e, bots rehearsal

Co-Authored-By: Claude Opus 5.5 <noreply@anthropic.com>
</commit_message>
<xml_diff>
--- a/slides/tuesday_app.pptx
+++ b/slides/tuesday_app.pptx
@@ -512,7 +512,7 @@
           <a:lstStyle/>
           <a:p>
             <a:r>
-              <a:t>No Git lecture today. You'll hit seven problems; your lab invents a fix for each, then we show how Git does the same thing. Every button runs real Git.</a:t>
+              <a:t>In class the projector page runs the lesson, and the console's Next button moves through it. This deck is the record: one technical card per Git tool, the same text as the app.</a:t>
             </a:r>
           </a:p>
         </p:txBody>
@@ -582,7 +582,19 @@
           <a:lstStyle/>
           <a:p>
             <a:r>
-              <a:t>Say: you just lived this paper. Microsoft moved its teams to Git, and the paper says flat history is data loss: fast-forward forgets the branch, rebase rewrites the change, squash drops the cards, even who made them, so Microsoft had to rebuild how it traces a change's path to main. Pairs, 2 min: one rule so the boss gets a clean history and the auditor can still say who added the tentacles.</a:t>
+              <a:t>Say: You just lived this paper. Teams at Microsoft moved to Git. It measures code velocity: how long a change takes to reach main, along its integration path. After the squash, the Wall has no path left. The paper says: flat history is data loss.</a:t>
+            </a:r>
+          </a:p>
+          <a:p/>
+          <a:p>
+            <a:r>
+              <a:t>Ask: You run your company's Wall. Give one rule: the boss gets a clean history, and the auditor still knows who added the boots.</a:t>
+            </a:r>
+          </a:p>
+          <a:p/>
+          <a:p>
+            <a:r>
+              <a:t>Hope to hear: No force push to main. Or: squash only your own branch, before you share it.</a:t>
             </a:r>
           </a:p>
         </p:txBody>
@@ -652,7 +664,7 @@
           <a:lstStyle/>
           <a:p>
             <a:r>
-              <a:t>Read one lab's counts. Point at the seven board lines and say: Cards never change. Sticky notes move. The Wall copies cards. That's Git. Homework: Yang et al., Sections 3.2 to 3.5; for one finding, write down what they measured.</a:t>
+              <a:t>Say: Cards never change. Sticky notes move. The Wall copies cards. That's Git. Homework: Yang et al., Sections 3.2 to 3.5. For one finding, write down what they measured.</a:t>
             </a:r>
           </a:p>
         </p:txBody>
@@ -722,7 +734,7 @@
           <a:lstStyle/>
           <a:p>
             <a:r>
-              <a:t>Scan the QR or type the address, then your name, then Lab 1, 2 or 3. Labs can change only before Step 1, so wait until the count matches the room. Then Step 0: 90 seconds of chaos, then "Hands off."</a:t>
+              <a:t>Say: No Git lecture today. You'll hit seven problems, and your lab invents a fix for each. Every button runs real Git.</a:t>
             </a:r>
           </a:p>
         </p:txBody>
@@ -792,7 +804,19 @@
           <a:lstStyle/>
           <a:p>
             <a:r>
-              <a:t>Ask, then wait 10 seconds. Say: git commit saves the whole monster, the card before, your name and the time; the ID is a hash of all of it, so any change makes a new card, and git log follows the parents back. Board: "1. Card (commit): a full snapshot + its parent. Never changes."</a:t>
+              <a:t>Say: git commit stores the whole outfit, the card before, your name, the time and a message. The ID is computed from all of it, so any change makes a new card. The name and the time are whatever your laptop says.</a:t>
+            </a:r>
+          </a:p>
+          <a:p/>
+          <a:p>
+            <a:r>
+              <a:t>Ask: Why do arrows point back, never forward?</a:t>
+            </a:r>
+          </a:p>
+          <a:p/>
+          <a:p>
+            <a:r>
+              <a:t>Hope to hear: The next card doesn't exist yet. Cards never change.</a:t>
             </a:r>
           </a:p>
         </p:txBody>
@@ -862,7 +886,19 @@
           <a:lstStyle/>
           <a:p>
             <a:r>
-              <a:t>Ask, then wait 10 seconds. Say: a branch is a tiny file holding one card's ID; your pin (HEAD) says which note you're on, and saving moves only that note. Board: "2. Sticky note (branch): a label on one card. Saving moves it."</a:t>
+              <a:t>Say: A branch is a tiny file holding one card's ID. Your pin (HEAD) says which note you're on. Saving moves only that note.</a:t>
+            </a:r>
+          </a:p>
+          <a:p/>
+          <a:p>
+            <a:r>
+              <a:t>Ask: Where is the original outfit now? Did anything get copied?</a:t>
+            </a:r>
+          </a:p>
+          <a:p/>
+          <a:p>
+            <a:r>
+              <a:t>Hope to hear: Still on main's card. Nothing was copied.</a:t>
             </a:r>
           </a:p>
         </p:txBody>
@@ -932,7 +968,19 @@
           <a:lstStyle/>
           <a:p>
             <a:r>
-              <a:t>First ask why the first merge only moved the note: main had nothing new, so it was a fast-forward, no new card. Say: otherwise Git compares each side with the newest card both share; changed on both, differently, is a conflict, and the merge card has two parents. Board: "3. Merge: compare both sides with the card they share."</a:t>
+              <a:t>Say: The first merge only slid the note: a fast-forward, no new card. Then Git compared each side with the card where you split. Only TOP changed on both sides, so only TOP needed you.</a:t>
+            </a:r>
+          </a:p>
+          <a:p/>
+          <a:p>
+            <a:r>
+              <a:t>Ask: Which cards were made on fancy?</a:t>
+            </a:r>
+          </a:p>
+          <a:p/>
+          <a:p>
+            <a:r>
+              <a:t>Hope to hear: No way to tell. Git does not record the branch a commit was made on.</a:t>
             </a:r>
           </a:p>
         </p:txBody>
@@ -1002,7 +1050,7 @@
           <a:lstStyle/>
           <a:p>
             <a:r>
-              <a:t>Say: git clone copies every card, and a card's ID is a hash of everything on it, parent included, so the same card has the same ID on every laptop. Blue wall/main is the Wall's main at your last check. Board: "4. The Wall (remote): a full copy. Same card, same ID everywhere."</a:t>
+              <a:t>Say: The Wall is the class's shared copy, like GitHub. Your lab already has a full copy of it (that is git clone). It starts as the first lab's outfit. Put your outfit on the Wall. The first lab there wins.</a:t>
             </a:r>
           </a:p>
         </p:txBody>
@@ -1072,7 +1120,19 @@
           <a:lstStyle/>
           <a:p>
             <a:r>
-              <a:t>Say: git push asks the Wall to move its main to yours, and it allows only a fast-forward: the Wall's newest card must already be in your history. git pull is git fetch + git merge; a push never merges, so you combine on your laptop and send again. Board: "5. Send (push) only moves the Wall forward. Behind? Get &amp; combine (pull) first."</a:t>
+              <a:t>Say: The Wall only moves forward, so a refused lab gets the Wall's cards first. Combine makes a merge card with two parents (Step 3 made one too). Replay on top makes a straight line: a copy of the card with the same change, author and author time, but a new parent, snapshot, committer time and ID.</a:t>
+            </a:r>
+          </a:p>
+          <a:p/>
+          <a:p>
+            <a:r>
+              <a:t>Ask: The replayed card has the same change, author and author time. Why does it have a new ID?</a:t>
+            </a:r>
+          </a:p>
+          <a:p/>
+          <a:p>
+            <a:r>
+              <a:t>Hope to hear: Its parent is new, so its snapshot is too: it now includes the Wall's change. Its committer time is new. The ID is a hash of all of it.</a:t>
             </a:r>
           </a:p>
         </p:txBody>
@@ -1142,7 +1202,19 @@
           <a:lstStyle/>
           <a:p>
             <a:r>
-              <a:t>Say: git revert adds a card that undoes the old one, so history only grows and it sends like any card. git reset --hard moves your note back, so the Wall's newest card leaves your history and the send is refused; git reflog lists every card your note was on. Board: "6. Shared mistake: add a fix card (revert). Move back (reset) only if nobody has the card."</a:t>
+              <a:t>Say: git revert adds a card that undoes the old one, so it sends like any card. git reset moves your note back, but the Wall still has the card.</a:t>
+            </a:r>
+          </a:p>
+          <a:p/>
+          <a:p>
+            <a:r>
+              <a:t>Ask: Why is adding a fix card safe, but moving back is not?</a:t>
+            </a:r>
+          </a:p>
+          <a:p/>
+          <a:p>
+            <a:r>
+              <a:t>Hope to hear: A fix card only adds. Moving back drops a shared card.</a:t>
             </a:r>
           </a:p>
         </p:txBody>
@@ -1212,7 +1284,19 @@
           <a:lstStyle/>
           <a:p>
             <a:r>
-              <a:t>Say: squash writes one new card with Start as its parent, so it gets a new ID; git push --force skips the fast-forward check, and git gc --prune=now deletes the old cards from the Wall. The labs kept theirs, so they can still name who added the tentacles. Board: "7. Rewrite (squash, rebase): new cards. Force push + gc: the old ones are gone."</a:t>
+              <a:t>Say: The Wall no longer knows who added the boots. The other labs still do. The old cards wait in the Wall's bin.</a:t>
+            </a:r>
+          </a:p>
+          <a:p/>
+          <a:p>
+            <a:r>
+              <a:t>Ask: Who added the boots? Where does that answer still exist?</a:t>
+            </a:r>
+          </a:p>
+          <a:p/>
+          <a:p>
+            <a:r>
+              <a:t>Hope to hear: Not on the Wall. Only in the labs that kept the old cards.</a:t>
             </a:r>
           </a:p>
         </p:txBody>
@@ -4258,7 +4342,7 @@
                 </a:solidFill>
                 <a:latin typeface="Inter"/>
               </a:rPr>
-              <a:t>Monster Lab</a:t>
+              <a:t>Outfit Lab</a:t>
             </a:r>
           </a:p>
         </p:txBody>
@@ -4295,7 +4379,23 @@
                 </a:solidFill>
                 <a:latin typeface="Inter"/>
               </a:rPr>
-              <a:t>Build Git, one problem at a time</a:t>
+              <a:t>Dress one character together.</a:t>
+            </a:r>
+          </a:p>
+          <a:p>
+            <a:pPr algn="l">
+              <a:lnSpc>
+                <a:spcPct val="110000"/>
+              </a:lnSpc>
+            </a:pPr>
+            <a:r>
+              <a:rPr sz="3200" b="0">
+                <a:solidFill>
+                  <a:srgbClr val="707078"/>
+                </a:solidFill>
+                <a:latin typeface="Inter"/>
+              </a:rPr>
+              <a:t>Every button runs real Git.</a:t>
             </a:r>
           </a:p>
         </p:txBody>
@@ -4374,8 +4474,8 @@
         </p:nvSpPr>
         <p:spPr>
           <a:xfrm>
-            <a:off x="9631375" y="1600200"/>
-            <a:ext cx="1737360" cy="914400"/>
+            <a:off x="9631375" y="1252728"/>
+            <a:ext cx="1737360" cy="868680"/>
           </a:xfrm>
           <a:prstGeom prst="roundRect">
             <a:avLst>
@@ -4404,8 +4504,8 @@
         </p:nvSpPr>
         <p:spPr>
           <a:xfrm>
-            <a:off x="9631375" y="1600200"/>
-            <a:ext cx="1737360" cy="914400"/>
+            <a:off x="9631375" y="1252728"/>
+            <a:ext cx="1737360" cy="868680"/>
           </a:xfrm>
           <a:prstGeom prst="rect">
             <a:avLst/>
@@ -4422,13 +4522,13 @@
               </a:lnSpc>
             </a:pPr>
             <a:r>
-              <a:rPr sz="4800" b="0">
+              <a:rPr sz="4400" b="0">
                 <a:solidFill>
                   <a:srgbClr val="111111"/>
                 </a:solidFill>
                 <a:latin typeface="Inter"/>
               </a:rPr>
-              <a:t>🙂</a:t>
+              <a:t>🧢</a:t>
             </a:r>
           </a:p>
         </p:txBody>
@@ -4441,8 +4541,8 @@
         </p:nvSpPr>
         <p:spPr>
           <a:xfrm>
-            <a:off x="9631375" y="2642616"/>
-            <a:ext cx="1737360" cy="914400"/>
+            <a:off x="9631375" y="2231136"/>
+            <a:ext cx="1737360" cy="868680"/>
           </a:xfrm>
           <a:prstGeom prst="roundRect">
             <a:avLst>
@@ -4471,8 +4571,8 @@
         </p:nvSpPr>
         <p:spPr>
           <a:xfrm>
-            <a:off x="9631375" y="2642616"/>
-            <a:ext cx="1737360" cy="914400"/>
+            <a:off x="9631375" y="2231136"/>
+            <a:ext cx="1737360" cy="868680"/>
           </a:xfrm>
           <a:prstGeom prst="rect">
             <a:avLst/>
@@ -4489,13 +4589,13 @@
               </a:lnSpc>
             </a:pPr>
             <a:r>
-              <a:rPr sz="4800" b="0">
+              <a:rPr sz="4400" b="0">
                 <a:solidFill>
                   <a:srgbClr val="111111"/>
                 </a:solidFill>
                 <a:latin typeface="Inter"/>
               </a:rPr>
-              <a:t>📦</a:t>
+              <a:t>👓</a:t>
             </a:r>
           </a:p>
         </p:txBody>
@@ -4508,8 +4608,8 @@
         </p:nvSpPr>
         <p:spPr>
           <a:xfrm>
-            <a:off x="9631375" y="3685032"/>
-            <a:ext cx="1737360" cy="914400"/>
+            <a:off x="9631375" y="3209544"/>
+            <a:ext cx="1737360" cy="868680"/>
           </a:xfrm>
           <a:prstGeom prst="roundRect">
             <a:avLst>
@@ -4538,8 +4638,8 @@
         </p:nvSpPr>
         <p:spPr>
           <a:xfrm>
-            <a:off x="9631375" y="3685032"/>
-            <a:ext cx="1737360" cy="914400"/>
+            <a:off x="9631375" y="3209544"/>
+            <a:ext cx="1737360" cy="868680"/>
           </a:xfrm>
           <a:prstGeom prst="rect">
             <a:avLst/>
@@ -4556,13 +4656,80 @@
               </a:lnSpc>
             </a:pPr>
             <a:r>
-              <a:rPr sz="4800" b="0">
+              <a:rPr sz="4400" b="0">
                 <a:solidFill>
                   <a:srgbClr val="111111"/>
                 </a:solidFill>
                 <a:latin typeface="Inter"/>
               </a:rPr>
-              <a:t>🦵</a:t>
+              <a:t>👕</a:t>
+            </a:r>
+          </a:p>
+        </p:txBody>
+      </p:sp>
+      <p:sp>
+        <p:nvSpPr>
+          <p:cNvPr id="12" name="Rounded Rectangle 11"/>
+          <p:cNvSpPr/>
+          <p:nvPr/>
+        </p:nvSpPr>
+        <p:spPr>
+          <a:xfrm>
+            <a:off x="9631375" y="4187952"/>
+            <a:ext cx="1737360" cy="868680"/>
+          </a:xfrm>
+          <a:prstGeom prst="roundRect">
+            <a:avLst>
+              <a:gd name="adj" fmla="val 14000"/>
+            </a:avLst>
+          </a:prstGeom>
+          <a:solidFill>
+            <a:srgbClr val="F6F6F8"/>
+          </a:solidFill>
+          <a:ln>
+            <a:noFill/>
+          </a:ln>
+          <a:effectLst/>
+        </p:spPr>
+        <p:txBody>
+          <a:bodyPr rtlCol="0" anchor="ctr"/>
+          <a:lstStyle/>
+          <a:p/>
+        </p:txBody>
+      </p:sp>
+      <p:sp>
+        <p:nvSpPr>
+          <p:cNvPr id="13" name="TextBox 12"/>
+          <p:cNvSpPr txBox="1"/>
+          <p:nvPr/>
+        </p:nvSpPr>
+        <p:spPr>
+          <a:xfrm>
+            <a:off x="9631375" y="4187952"/>
+            <a:ext cx="1737360" cy="868680"/>
+          </a:xfrm>
+          <a:prstGeom prst="rect">
+            <a:avLst/>
+          </a:prstGeom>
+          <a:noFill/>
+        </p:spPr>
+        <p:txBody>
+          <a:bodyPr wrap="square" anchor="ctr" lIns="0" rIns="0" tIns="0" bIns="0"/>
+          <a:lstStyle/>
+          <a:p>
+            <a:pPr algn="ctr">
+              <a:lnSpc>
+                <a:spcPct val="110000"/>
+              </a:lnSpc>
+            </a:pPr>
+            <a:r>
+              <a:rPr sz="4400" b="0">
+                <a:solidFill>
+                  <a:srgbClr val="111111"/>
+                </a:solidFill>
+                <a:latin typeface="Inter"/>
+              </a:rPr>
+              <a:t>👟</a:t>
             </a:r>
           </a:p>
         </p:txBody>
@@ -4601,7 +4768,7 @@
         </p:nvSpPr>
         <p:spPr>
           <a:xfrm>
-            <a:off x="822960" y="502920"/>
+            <a:off x="822960" y="411480"/>
             <a:ext cx="10545775" cy="365760"/>
           </a:xfrm>
           <a:prstGeom prst="rect">
@@ -4619,7 +4786,7 @@
               </a:lnSpc>
             </a:pPr>
             <a:r>
-              <a:rPr sz="2000" b="0">
+              <a:rPr sz="1800" b="0">
                 <a:solidFill>
                   <a:srgbClr val="707078"/>
                 </a:solidFill>
@@ -4638,8 +4805,8 @@
         </p:nvSpPr>
         <p:spPr>
           <a:xfrm>
-            <a:off x="822960" y="868680"/>
-            <a:ext cx="10545775" cy="731520"/>
+            <a:off x="822960" y="731520"/>
+            <a:ext cx="10545775" cy="548640"/>
           </a:xfrm>
           <a:prstGeom prst="rect">
             <a:avLst/>
@@ -4656,13 +4823,13 @@
               </a:lnSpc>
             </a:pPr>
             <a:r>
-              <a:rPr sz="4000" b="1">
+              <a:rPr sz="3200" b="1">
                 <a:solidFill>
                   <a:srgbClr val="111111"/>
                 </a:solidFill>
                 <a:latin typeface="Inter"/>
               </a:rPr>
-              <a:t>Switching to Git: Good, Bad, Ugly</a:t>
+              <a:t>Switching to Git: the Good, the Bad, and the Ugly</a:t>
             </a:r>
           </a:p>
         </p:txBody>
@@ -4675,8 +4842,8 @@
         </p:nvSpPr>
         <p:spPr>
           <a:xfrm>
-            <a:off x="822960" y="1828800"/>
-            <a:ext cx="3271418" cy="64008"/>
+            <a:off x="822960" y="1463040"/>
+            <a:ext cx="3271418" cy="54864"/>
           </a:xfrm>
           <a:prstGeom prst="rect">
             <a:avLst/>
@@ -4704,8 +4871,8 @@
         </p:nvSpPr>
         <p:spPr>
           <a:xfrm>
-            <a:off x="822960" y="2011680"/>
-            <a:ext cx="3271418" cy="411480"/>
+            <a:off x="822960" y="1600200"/>
+            <a:ext cx="3271418" cy="274320"/>
           </a:xfrm>
           <a:prstGeom prst="rect">
             <a:avLst/>
@@ -4722,7 +4889,7 @@
               </a:lnSpc>
             </a:pPr>
             <a:r>
-              <a:rPr sz="2200" b="1">
+              <a:rPr sz="1800" b="1">
                 <a:solidFill>
                   <a:srgbClr val="16A34A"/>
                 </a:solidFill>
@@ -4741,8 +4908,8 @@
         </p:nvSpPr>
         <p:spPr>
           <a:xfrm>
-            <a:off x="822960" y="2560320"/>
-            <a:ext cx="3271418" cy="2194560"/>
+            <a:off x="822960" y="1965960"/>
+            <a:ext cx="3271418" cy="1029328"/>
           </a:xfrm>
           <a:prstGeom prst="rect">
             <a:avLst/>
@@ -4755,14 +4922,14 @@
           <a:p>
             <a:pPr algn="l">
               <a:lnSpc>
-                <a:spcPct val="110000"/>
+                <a:spcPct val="112000"/>
               </a:lnSpc>
               <a:spcBef>
                 <a:spcPts val="0"/>
               </a:spcBef>
             </a:pPr>
             <a:r>
-              <a:rPr sz="2000" b="0">
+              <a:rPr sz="1600" b="0">
                 <a:solidFill>
                   <a:srgbClr val="111111"/>
                 </a:solidFill>
@@ -4772,16 +4939,16 @@
             </a:r>
           </a:p>
           <a:p>
-            <a:pPr>
+            <a:pPr algn="l">
               <a:lnSpc>
-                <a:spcPct val="110000"/>
+                <a:spcPct val="112000"/>
               </a:lnSpc>
               <a:spcBef>
-                <a:spcPts val="1200"/>
+                <a:spcPts val="800"/>
               </a:spcBef>
             </a:pPr>
             <a:r>
-              <a:rPr sz="2000" b="0">
+              <a:rPr sz="1600" b="0">
                 <a:solidFill>
                   <a:srgbClr val="111111"/>
                 </a:solidFill>
@@ -4791,22 +4958,22 @@
             </a:r>
           </a:p>
           <a:p>
-            <a:pPr>
+            <a:pPr algn="l">
               <a:lnSpc>
-                <a:spcPct val="110000"/>
+                <a:spcPct val="112000"/>
               </a:lnSpc>
               <a:spcBef>
-                <a:spcPts val="1200"/>
+                <a:spcPts val="800"/>
               </a:spcBef>
             </a:pPr>
             <a:r>
-              <a:rPr sz="2000" b="0">
+              <a:rPr sz="1600" b="0">
                 <a:solidFill>
                   <a:srgbClr val="111111"/>
                 </a:solidFill>
                 <a:latin typeface="Inter"/>
               </a:rPr>
-              <a:t>Developers prefer flat history.</a:t>
+              <a:t>Developers prefer a flat history.</a:t>
             </a:r>
           </a:p>
         </p:txBody>
@@ -4819,8 +4986,8 @@
         </p:nvSpPr>
         <p:spPr>
           <a:xfrm>
-            <a:off x="4460138" y="1828800"/>
-            <a:ext cx="3271418" cy="64008"/>
+            <a:off x="4460138" y="1463040"/>
+            <a:ext cx="3271418" cy="54864"/>
           </a:xfrm>
           <a:prstGeom prst="rect">
             <a:avLst/>
@@ -4848,8 +5015,8 @@
         </p:nvSpPr>
         <p:spPr>
           <a:xfrm>
-            <a:off x="4460138" y="2011680"/>
-            <a:ext cx="3271418" cy="411480"/>
+            <a:off x="4460138" y="1600200"/>
+            <a:ext cx="3271418" cy="274320"/>
           </a:xfrm>
           <a:prstGeom prst="rect">
             <a:avLst/>
@@ -4866,7 +5033,7 @@
               </a:lnSpc>
             </a:pPr>
             <a:r>
-              <a:rPr sz="2200" b="1">
+              <a:rPr sz="1800" b="1">
                 <a:solidFill>
                   <a:srgbClr val="E08A00"/>
                 </a:solidFill>
@@ -4885,8 +5052,8 @@
         </p:nvSpPr>
         <p:spPr>
           <a:xfrm>
-            <a:off x="4460138" y="2560320"/>
-            <a:ext cx="3271418" cy="2194560"/>
+            <a:off x="4460138" y="1965960"/>
+            <a:ext cx="3271418" cy="1855459"/>
           </a:xfrm>
           <a:prstGeom prst="rect">
             <a:avLst/>
@@ -4899,85 +5066,58 @@
           <a:p>
             <a:pPr algn="l">
               <a:lnSpc>
-                <a:spcPct val="110000"/>
+                <a:spcPct val="112000"/>
               </a:lnSpc>
               <a:spcBef>
                 <a:spcPts val="0"/>
               </a:spcBef>
             </a:pPr>
             <a:r>
-              <a:rPr sz="2000" b="1">
+              <a:rPr sz="1600" b="0">
                 <a:solidFill>
                   <a:srgbClr val="111111"/>
                 </a:solidFill>
                 <a:latin typeface="Inter"/>
               </a:rPr>
-              <a:t>Fast-forward: </a:t>
-            </a:r>
-            <a:r>
-              <a:rPr sz="2000" b="0">
-                <a:solidFill>
-                  <a:srgbClr val="111111"/>
-                </a:solidFill>
-                <a:latin typeface="Inter"/>
-              </a:rPr>
-              <a:t>no merge commit, branch forgotten.</a:t>
-            </a:r>
-          </a:p>
-          <a:p>
-            <a:pPr>
+              <a:t>Fast-forward forgets which branch a change came from.</a:t>
+            </a:r>
+          </a:p>
+          <a:p>
+            <a:pPr algn="l">
               <a:lnSpc>
-                <a:spcPct val="110000"/>
+                <a:spcPct val="112000"/>
               </a:lnSpc>
               <a:spcBef>
-                <a:spcPts val="1200"/>
+                <a:spcPts val="800"/>
               </a:spcBef>
             </a:pPr>
             <a:r>
-              <a:rPr sz="2000" b="1">
+              <a:rPr sz="1600" b="0">
                 <a:solidFill>
                   <a:srgbClr val="111111"/>
                 </a:solidFill>
                 <a:latin typeface="Inter"/>
               </a:rPr>
-              <a:t>Rebase: </a:t>
-            </a:r>
-            <a:r>
-              <a:rPr sz="2000" b="0">
-                <a:solidFill>
-                  <a:srgbClr val="111111"/>
-                </a:solidFill>
-                <a:latin typeface="Inter"/>
-              </a:rPr>
-              <a:t>the change itself is rewritten.</a:t>
-            </a:r>
-          </a:p>
-          <a:p>
-            <a:pPr>
+              <a:t>Rebase rewrites the commit; the patch can change too.</a:t>
+            </a:r>
+          </a:p>
+          <a:p>
+            <a:pPr algn="l">
               <a:lnSpc>
-                <a:spcPct val="110000"/>
+                <a:spcPct val="112000"/>
               </a:lnSpc>
               <a:spcBef>
-                <a:spcPts val="1200"/>
+                <a:spcPts val="800"/>
               </a:spcBef>
             </a:pPr>
             <a:r>
-              <a:rPr sz="2000" b="1">
+              <a:rPr sz="1600" b="0">
                 <a:solidFill>
                   <a:srgbClr val="111111"/>
                 </a:solidFill>
                 <a:latin typeface="Inter"/>
               </a:rPr>
-              <a:t>Squash: </a:t>
-            </a:r>
-            <a:r>
-              <a:rPr sz="2000" b="0">
-                <a:solidFill>
-                  <a:srgbClr val="111111"/>
-                </a:solidFill>
-                <a:latin typeface="Inter"/>
-              </a:rPr>
-              <a:t>commits gone, even who made them.</a:t>
+              <a:t>Squash drops the cards, even who made them.</a:t>
             </a:r>
           </a:p>
         </p:txBody>
@@ -4990,8 +5130,8 @@
         </p:nvSpPr>
         <p:spPr>
           <a:xfrm>
-            <a:off x="8097316" y="1828800"/>
-            <a:ext cx="3271418" cy="64008"/>
+            <a:off x="8097316" y="1463040"/>
+            <a:ext cx="3271418" cy="54864"/>
           </a:xfrm>
           <a:prstGeom prst="rect">
             <a:avLst/>
@@ -5019,8 +5159,8 @@
         </p:nvSpPr>
         <p:spPr>
           <a:xfrm>
-            <a:off x="8097316" y="2011680"/>
-            <a:ext cx="3271418" cy="411480"/>
+            <a:off x="8097316" y="1600200"/>
+            <a:ext cx="3271418" cy="274320"/>
           </a:xfrm>
           <a:prstGeom prst="rect">
             <a:avLst/>
@@ -5037,7 +5177,7 @@
               </a:lnSpc>
             </a:pPr>
             <a:r>
-              <a:rPr sz="2200" b="1">
+              <a:rPr sz="1800" b="1">
                 <a:solidFill>
                   <a:srgbClr val="DC2626"/>
                 </a:solidFill>
@@ -5056,8 +5196,8 @@
         </p:nvSpPr>
         <p:spPr>
           <a:xfrm>
-            <a:off x="8097316" y="2560320"/>
-            <a:ext cx="3271418" cy="2194560"/>
+            <a:off x="8097316" y="1965960"/>
+            <a:ext cx="3271418" cy="1855458"/>
           </a:xfrm>
           <a:prstGeom prst="rect">
             <a:avLst/>
@@ -5070,67 +5210,58 @@
           <a:p>
             <a:pPr algn="l">
               <a:lnSpc>
-                <a:spcPct val="110000"/>
+                <a:spcPct val="112000"/>
               </a:lnSpc>
               <a:spcBef>
                 <a:spcPts val="0"/>
               </a:spcBef>
             </a:pPr>
             <a:r>
-              <a:rPr sz="2000" b="1">
+              <a:rPr sz="1600" b="0">
                 <a:solidFill>
                   <a:srgbClr val="111111"/>
                 </a:solidFill>
                 <a:latin typeface="Inter"/>
               </a:rPr>
-              <a:t>Integration path: </a:t>
-            </a:r>
-            <a:r>
-              <a:rPr sz="2000" b="0">
-                <a:solidFill>
-                  <a:srgbClr val="111111"/>
-                </a:solidFill>
-                <a:latin typeface="Inter"/>
-              </a:rPr>
-              <a:t>a change's route to main.</a:t>
-            </a:r>
-          </a:p>
-          <a:p>
-            <a:pPr>
+              <a:t>Microsoft traces each change's route to main: its integration path.</a:t>
+            </a:r>
+          </a:p>
+          <a:p>
+            <a:pPr algn="l">
               <a:lnSpc>
-                <a:spcPct val="110000"/>
+                <a:spcPct val="112000"/>
               </a:lnSpc>
               <a:spcBef>
-                <a:spcPts val="1200"/>
+                <a:spcPts val="800"/>
               </a:spcBef>
             </a:pPr>
             <a:r>
-              <a:rPr sz="2000" b="0">
+              <a:rPr sz="1600" b="0">
                 <a:solidFill>
                   <a:srgbClr val="111111"/>
                 </a:solidFill>
                 <a:latin typeface="Inter"/>
               </a:rPr>
-              <a:t>Microsoft rebuilt its tracing for Git.</a:t>
-            </a:r>
-          </a:p>
-          <a:p>
-            <a:pPr>
+              <a:t>For Git, that tracing had to be redesigned from scratch.</a:t>
+            </a:r>
+          </a:p>
+          <a:p>
+            <a:pPr algn="l">
               <a:lnSpc>
-                <a:spcPct val="110000"/>
+                <a:spcPct val="112000"/>
               </a:lnSpc>
               <a:spcBef>
-                <a:spcPts val="1200"/>
+                <a:spcPts val="800"/>
               </a:spcBef>
             </a:pPr>
             <a:r>
-              <a:rPr sz="2000" b="0">
+              <a:rPr sz="1600" b="0">
                 <a:solidFill>
                   <a:srgbClr val="111111"/>
                 </a:solidFill>
                 <a:latin typeface="Inter"/>
               </a:rPr>
-              <a:t>Some loss can't be recovered.</a:t>
+              <a:t>Some loss cannot be recovered.</a:t>
             </a:r>
           </a:p>
         </p:txBody>
@@ -5143,8 +5274,8 @@
         </p:nvSpPr>
         <p:spPr>
           <a:xfrm>
-            <a:off x="822960" y="5257800"/>
-            <a:ext cx="10545775" cy="640080"/>
+            <a:off x="822960" y="4095739"/>
+            <a:ext cx="10545775" cy="274320"/>
           </a:xfrm>
           <a:prstGeom prst="rect">
             <a:avLst/>
@@ -5161,13 +5292,13 @@
               </a:lnSpc>
             </a:pPr>
             <a:r>
-              <a:rPr sz="4000" b="1">
-                <a:solidFill>
-                  <a:srgbClr val="8B3DFF"/>
+              <a:rPr sz="1400" b="1">
+                <a:solidFill>
+                  <a:srgbClr val="707078"/>
                 </a:solidFill>
                 <a:latin typeface="Inter"/>
               </a:rPr>
-              <a:t>Flat history is data loss.</a:t>
+              <a:t>WHAT YOU LIVED</a:t>
             </a:r>
           </a:p>
         </p:txBody>
@@ -5180,8 +5311,105 @@
         </p:nvSpPr>
         <p:spPr>
           <a:xfrm>
-            <a:off x="822960" y="5943600"/>
-            <a:ext cx="10545775" cy="365760"/>
+            <a:off x="822960" y="4370059"/>
+            <a:ext cx="10545775" cy="1215804"/>
+          </a:xfrm>
+          <a:prstGeom prst="rect">
+            <a:avLst/>
+          </a:prstGeom>
+          <a:noFill/>
+        </p:spPr>
+        <p:txBody>
+          <a:bodyPr wrap="square" anchor="t" lIns="0" rIns="0" tIns="0" bIns="0"/>
+          <a:lstStyle/>
+          <a:p>
+            <a:pPr algn="l">
+              <a:lnSpc>
+                <a:spcPct val="112000"/>
+              </a:lnSpc>
+              <a:spcBef>
+                <a:spcPts val="0"/>
+              </a:spcBef>
+            </a:pPr>
+            <a:r>
+              <a:rPr sz="1600" b="0">
+                <a:solidFill>
+                  <a:srgbClr val="111111"/>
+                </a:solidFill>
+                <a:latin typeface="Inter"/>
+              </a:rPr>
+              <a:t>Step 3: after the fast-forward, you deleted fancy. No card says which cards were made on it.</a:t>
+            </a:r>
+          </a:p>
+          <a:p>
+            <a:pPr algn="l">
+              <a:lnSpc>
+                <a:spcPct val="112000"/>
+              </a:lnSpc>
+              <a:spcBef>
+                <a:spcPts val="300"/>
+              </a:spcBef>
+            </a:pPr>
+            <a:r>
+              <a:rPr sz="1600" b="0">
+                <a:solidFill>
+                  <a:srgbClr val="111111"/>
+                </a:solidFill>
+                <a:latin typeface="Inter"/>
+              </a:rPr>
+              <a:t>Step 4: Rebase rewrites the change and gives it a new ID. The original card is not on the Wall.</a:t>
+            </a:r>
+          </a:p>
+          <a:p>
+            <a:pPr algn="l">
+              <a:lnSpc>
+                <a:spcPct val="112000"/>
+              </a:lnSpc>
+              <a:spcBef>
+                <a:spcPts val="300"/>
+              </a:spcBef>
+            </a:pPr>
+            <a:r>
+              <a:rPr sz="1600" b="0">
+                <a:solidFill>
+                  <a:srgbClr val="111111"/>
+                </a:solidFill>
+                <a:latin typeface="Inter"/>
+              </a:rPr>
+              <a:t>Step 6: the squash dropped the cards, and who made them.</a:t>
+            </a:r>
+          </a:p>
+          <a:p>
+            <a:pPr algn="l">
+              <a:lnSpc>
+                <a:spcPct val="112000"/>
+              </a:lnSpc>
+              <a:spcBef>
+                <a:spcPts val="300"/>
+              </a:spcBef>
+            </a:pPr>
+            <a:r>
+              <a:rPr sz="1600" b="0">
+                <a:solidFill>
+                  <a:srgbClr val="111111"/>
+                </a:solidFill>
+                <a:latin typeface="Inter"/>
+              </a:rPr>
+              <a:t>Step 6: the 🥾 audit failed. The Wall no longer knows who added the boots.</a:t>
+            </a:r>
+          </a:p>
+        </p:txBody>
+      </p:sp>
+      <p:sp>
+        <p:nvSpPr>
+          <p:cNvPr id="15" name="TextBox 14"/>
+          <p:cNvSpPr txBox="1"/>
+          <p:nvPr/>
+        </p:nvSpPr>
+        <p:spPr>
+          <a:xfrm>
+            <a:off x="822960" y="5814463"/>
+            <a:ext cx="10545775" cy="548640"/>
           </a:xfrm>
           <a:prstGeom prst="rect">
             <a:avLst/>
@@ -5198,13 +5426,13 @@
               </a:lnSpc>
             </a:pPr>
             <a:r>
-              <a:rPr sz="2000" b="0">
-                <a:solidFill>
-                  <a:srgbClr val="707078"/>
+              <a:rPr sz="3600" b="1">
+                <a:solidFill>
+                  <a:srgbClr val="8B3DFF"/>
                 </a:solidFill>
                 <a:latin typeface="Inter"/>
               </a:rPr>
-              <a:t>You saw it in Step 7: squash, then force push. The Wall forgot who added 🐙.</a:t>
+              <a:t>Flat history is data loss.</a:t>
             </a:r>
           </a:p>
         </p:txBody>
@@ -5727,8 +5955,8 @@
         </p:nvSpPr>
         <p:spPr>
           <a:xfrm>
-            <a:off x="822960" y="1920240"/>
-            <a:ext cx="6156655" cy="822960"/>
+            <a:off x="822960" y="1737360"/>
+            <a:ext cx="6156655" cy="457200"/>
           </a:xfrm>
           <a:prstGeom prst="rect">
             <a:avLst/>
@@ -5745,13 +5973,13 @@
               </a:lnSpc>
             </a:pPr>
             <a:r>
-              <a:rPr sz="4800" b="1">
-                <a:solidFill>
-                  <a:srgbClr val="111111"/>
+              <a:rPr sz="2200" b="1">
+                <a:solidFill>
+                  <a:srgbClr val="8B3DFF"/>
                 </a:solidFill>
                 <a:latin typeface="Inter"/>
               </a:rPr>
-              <a:t>Open: ________</a:t>
+              <a:t>Outfit Lab</a:t>
             </a:r>
           </a:p>
         </p:txBody>
@@ -5764,8 +5992,45 @@
         </p:nvSpPr>
         <p:spPr>
           <a:xfrm>
-            <a:off x="822960" y="2971800"/>
-            <a:ext cx="6156655" cy="1280160"/>
+            <a:off x="822960" y="2286000"/>
+            <a:ext cx="6156655" cy="822960"/>
+          </a:xfrm>
+          <a:prstGeom prst="rect">
+            <a:avLst/>
+          </a:prstGeom>
+          <a:noFill/>
+        </p:spPr>
+        <p:txBody>
+          <a:bodyPr wrap="square" anchor="t" lIns="0" rIns="0" tIns="0" bIns="0"/>
+          <a:lstStyle/>
+          <a:p>
+            <a:pPr algn="l">
+              <a:lnSpc>
+                <a:spcPct val="110000"/>
+              </a:lnSpc>
+            </a:pPr>
+            <a:r>
+              <a:rPr sz="4800" b="1">
+                <a:solidFill>
+                  <a:srgbClr val="111111"/>
+                </a:solidFill>
+                <a:latin typeface="Inter"/>
+              </a:rPr>
+              <a:t>Open: ________</a:t>
+            </a:r>
+          </a:p>
+        </p:txBody>
+      </p:sp>
+      <p:sp>
+        <p:nvSpPr>
+          <p:cNvPr id="6" name="TextBox 5"/>
+          <p:cNvSpPr txBox="1"/>
+          <p:nvPr/>
+        </p:nvSpPr>
+        <p:spPr>
+          <a:xfrm>
+            <a:off x="822960" y="3383280"/>
+            <a:ext cx="6156655" cy="1463040"/>
           </a:xfrm>
           <a:prstGeom prst="rect">
             <a:avLst/>
@@ -5782,13 +6047,13 @@
               </a:lnSpc>
             </a:pPr>
             <a:r>
-              <a:rPr sz="3600" b="0">
+              <a:rPr sz="2800" b="0">
                 <a:solidFill>
                   <a:srgbClr val="707078"/>
                 </a:solidFill>
                 <a:latin typeface="Inter"/>
               </a:rPr>
-              <a:t>Type your name.</a:t>
+              <a:t>Open the link and type your name.</a:t>
             </a:r>
           </a:p>
           <a:p>
@@ -5798,136 +6063,13 @@
               </a:lnSpc>
             </a:pPr>
             <a:r>
-              <a:rPr sz="3600" b="0">
+              <a:rPr sz="2800" b="0">
                 <a:solidFill>
                   <a:srgbClr val="707078"/>
                 </a:solidFill>
                 <a:latin typeface="Inter"/>
               </a:rPr>
-              <a:t>Pick your lab.</a:t>
-            </a:r>
-          </a:p>
-        </p:txBody>
-      </p:sp>
-      <p:sp>
-        <p:nvSpPr>
-          <p:cNvPr id="6" name="Rounded Rectangle 5"/>
-          <p:cNvSpPr/>
-          <p:nvPr/>
-        </p:nvSpPr>
-        <p:spPr>
-          <a:xfrm>
-            <a:off x="822960" y="4663440"/>
-            <a:ext cx="1371600" cy="457200"/>
-          </a:xfrm>
-          <a:prstGeom prst="roundRect">
-            <a:avLst>
-              <a:gd name="adj" fmla="val 50000"/>
-            </a:avLst>
-          </a:prstGeom>
-          <a:solidFill>
-            <a:srgbClr val="8B3DFF"/>
-          </a:solidFill>
-          <a:ln>
-            <a:noFill/>
-          </a:ln>
-          <a:effectLst/>
-        </p:spPr>
-        <p:txBody>
-          <a:bodyPr rtlCol="0" anchor="ctr" lIns="0" rIns="0" tIns="0" bIns="0"/>
-          <a:lstStyle/>
-          <a:p>
-            <a:pPr algn="ctr"/>
-            <a:r>
-              <a:rPr sz="2200" b="1">
-                <a:solidFill>
-                  <a:srgbClr val="FFFFFF"/>
-                </a:solidFill>
-                <a:latin typeface="Inter"/>
-              </a:rPr>
-              <a:t>Lab 1</a:t>
-            </a:r>
-          </a:p>
-        </p:txBody>
-      </p:sp>
-      <p:sp>
-        <p:nvSpPr>
-          <p:cNvPr id="7" name="Rounded Rectangle 6"/>
-          <p:cNvSpPr/>
-          <p:nvPr/>
-        </p:nvSpPr>
-        <p:spPr>
-          <a:xfrm>
-            <a:off x="2423160" y="4663440"/>
-            <a:ext cx="1371600" cy="457200"/>
-          </a:xfrm>
-          <a:prstGeom prst="roundRect">
-            <a:avLst>
-              <a:gd name="adj" fmla="val 50000"/>
-            </a:avLst>
-          </a:prstGeom>
-          <a:solidFill>
-            <a:srgbClr val="0EA5E9"/>
-          </a:solidFill>
-          <a:ln>
-            <a:noFill/>
-          </a:ln>
-          <a:effectLst/>
-        </p:spPr>
-        <p:txBody>
-          <a:bodyPr rtlCol="0" anchor="ctr" lIns="0" rIns="0" tIns="0" bIns="0"/>
-          <a:lstStyle/>
-          <a:p>
-            <a:pPr algn="ctr"/>
-            <a:r>
-              <a:rPr sz="2200" b="1">
-                <a:solidFill>
-                  <a:srgbClr val="FFFFFF"/>
-                </a:solidFill>
-                <a:latin typeface="Inter"/>
-              </a:rPr>
-              <a:t>Lab 2</a:t>
-            </a:r>
-          </a:p>
-        </p:txBody>
-      </p:sp>
-      <p:sp>
-        <p:nvSpPr>
-          <p:cNvPr id="8" name="Rounded Rectangle 7"/>
-          <p:cNvSpPr/>
-          <p:nvPr/>
-        </p:nvSpPr>
-        <p:spPr>
-          <a:xfrm>
-            <a:off x="4023360" y="4663440"/>
-            <a:ext cx="1371600" cy="457200"/>
-          </a:xfrm>
-          <a:prstGeom prst="roundRect">
-            <a:avLst>
-              <a:gd name="adj" fmla="val 50000"/>
-            </a:avLst>
-          </a:prstGeom>
-          <a:solidFill>
-            <a:srgbClr val="F97316"/>
-          </a:solidFill>
-          <a:ln>
-            <a:noFill/>
-          </a:ln>
-          <a:effectLst/>
-        </p:spPr>
-        <p:txBody>
-          <a:bodyPr rtlCol="0" anchor="ctr" lIns="0" rIns="0" tIns="0" bIns="0"/>
-          <a:lstStyle/>
-          <a:p>
-            <a:pPr algn="ctr"/>
-            <a:r>
-              <a:rPr sz="2200" b="1">
-                <a:solidFill>
-                  <a:srgbClr val="FFFFFF"/>
-                </a:solidFill>
-                <a:latin typeface="Inter"/>
-              </a:rPr>
-              <a:t>Lab 3</a:t>
+              <a:t>The app picks your lab.</a:t>
             </a:r>
           </a:p>
         </p:txBody>
@@ -5966,7 +6108,7 @@
         </p:nvSpPr>
         <p:spPr>
           <a:xfrm>
-            <a:off x="822960" y="594360"/>
+            <a:off x="822960" y="502920"/>
             <a:ext cx="1344168" cy="457200"/>
           </a:xfrm>
           <a:prstGeom prst="roundRect">
@@ -6007,7 +6149,7 @@
         </p:nvSpPr>
         <p:spPr>
           <a:xfrm>
-            <a:off x="2423160" y="594360"/>
+            <a:off x="2441448" y="502920"/>
             <a:ext cx="8229600" cy="457200"/>
           </a:xfrm>
           <a:prstGeom prst="rect">
@@ -6044,8 +6186,74 @@
         </p:nvSpPr>
         <p:spPr>
           <a:xfrm>
-            <a:off x="822960" y="1280160"/>
-            <a:ext cx="10545775" cy="822960"/>
+            <a:off x="822960" y="1143000"/>
+            <a:ext cx="10545775" cy="914400"/>
+          </a:xfrm>
+          <a:prstGeom prst="rect">
+            <a:avLst/>
+          </a:prstGeom>
+          <a:noFill/>
+        </p:spPr>
+        <p:txBody>
+          <a:bodyPr wrap="square" anchor="b" lIns="0" rIns="0" tIns="0" bIns="0"/>
+          <a:lstStyle/>
+          <a:p>
+            <a:pPr algn="l">
+              <a:lnSpc>
+                <a:spcPct val="100000"/>
+              </a:lnSpc>
+            </a:pPr>
+            <a:r>
+              <a:rPr sz="6600" b="1">
+                <a:solidFill>
+                  <a:srgbClr val="8B3DFF"/>
+                </a:solidFill>
+                <a:latin typeface="Noto Sans Mono"/>
+              </a:rPr>
+              <a:t>git commit</a:t>
+            </a:r>
+          </a:p>
+        </p:txBody>
+      </p:sp>
+      <p:sp>
+        <p:nvSpPr>
+          <p:cNvPr id="5" name="Rectangle 4"/>
+          <p:cNvSpPr/>
+          <p:nvPr/>
+        </p:nvSpPr>
+        <p:spPr>
+          <a:xfrm>
+            <a:off x="822960" y="2286000"/>
+            <a:ext cx="10545775" cy="12700"/>
+          </a:xfrm>
+          <a:prstGeom prst="rect">
+            <a:avLst/>
+          </a:prstGeom>
+          <a:solidFill>
+            <a:srgbClr val="D9D9DE"/>
+          </a:solidFill>
+          <a:ln>
+            <a:noFill/>
+          </a:ln>
+        </p:spPr>
+        <p:txBody>
+          <a:bodyPr rtlCol="0" anchor="ctr"/>
+          <a:lstStyle/>
+          <a:p>
+            <a:pPr algn="ctr"/>
+          </a:p>
+        </p:txBody>
+      </p:sp>
+      <p:sp>
+        <p:nvSpPr>
+          <p:cNvPr id="6" name="TextBox 5"/>
+          <p:cNvSpPr txBox="1"/>
+          <p:nvPr/>
+        </p:nvSpPr>
+        <p:spPr>
+          <a:xfrm>
+            <a:off x="1051560" y="2521712"/>
+            <a:ext cx="1645920" cy="274320"/>
           </a:xfrm>
           <a:prstGeom prst="rect">
             <a:avLst/>
@@ -6062,27 +6270,27 @@
               </a:lnSpc>
             </a:pPr>
             <a:r>
-              <a:rPr sz="2400" b="0" i="1">
+              <a:rPr sz="1400" b="1">
                 <a:solidFill>
                   <a:srgbClr val="707078"/>
                 </a:solidFill>
                 <a:latin typeface="Inter"/>
               </a:rPr>
-              <a:t>Why do arrows point back, never forward?</a:t>
-            </a:r>
-          </a:p>
-        </p:txBody>
-      </p:sp>
-      <p:sp>
-        <p:nvSpPr>
-          <p:cNvPr id="5" name="TextBox 4"/>
+              <a:t>WHAT IT IS</a:t>
+            </a:r>
+          </a:p>
+        </p:txBody>
+      </p:sp>
+      <p:sp>
+        <p:nvSpPr>
+          <p:cNvPr id="7" name="TextBox 6"/>
           <p:cNvSpPr txBox="1"/>
           <p:nvPr/>
         </p:nvSpPr>
         <p:spPr>
           <a:xfrm>
-            <a:off x="822960" y="2011680"/>
-            <a:ext cx="10545775" cy="1371600"/>
+            <a:off x="3017520" y="2423160"/>
+            <a:ext cx="8122615" cy="378642"/>
           </a:xfrm>
           <a:prstGeom prst="rect">
             <a:avLst/>
@@ -6090,7 +6298,73 @@
           <a:noFill/>
         </p:spPr>
         <p:txBody>
-          <a:bodyPr wrap="square" anchor="ctr" lIns="0" rIns="0" tIns="0" bIns="0"/>
+          <a:bodyPr wrap="square" anchor="t" lIns="0" rIns="0" tIns="0" bIns="0"/>
+          <a:lstStyle/>
+          <a:p>
+            <a:pPr algn="l">
+              <a:lnSpc>
+                <a:spcPct val="112000"/>
+              </a:lnSpc>
+            </a:pPr>
+            <a:r>
+              <a:rPr sz="2200" b="0">
+                <a:solidFill>
+                  <a:srgbClr val="111111"/>
+                </a:solidFill>
+                <a:latin typeface="Inter"/>
+              </a:rPr>
+              <a:t>a saved snapshot of the whole project.</a:t>
+            </a:r>
+          </a:p>
+        </p:txBody>
+      </p:sp>
+      <p:sp>
+        <p:nvSpPr>
+          <p:cNvPr id="8" name="Rectangle 7"/>
+          <p:cNvSpPr/>
+          <p:nvPr/>
+        </p:nvSpPr>
+        <p:spPr>
+          <a:xfrm>
+            <a:off x="822960" y="2938962"/>
+            <a:ext cx="10545775" cy="12700"/>
+          </a:xfrm>
+          <a:prstGeom prst="rect">
+            <a:avLst/>
+          </a:prstGeom>
+          <a:solidFill>
+            <a:srgbClr val="D9D9DE"/>
+          </a:solidFill>
+          <a:ln>
+            <a:noFill/>
+          </a:ln>
+        </p:spPr>
+        <p:txBody>
+          <a:bodyPr rtlCol="0" anchor="ctr"/>
+          <a:lstStyle/>
+          <a:p>
+            <a:pPr algn="ctr"/>
+          </a:p>
+        </p:txBody>
+      </p:sp>
+      <p:sp>
+        <p:nvSpPr>
+          <p:cNvPr id="9" name="TextBox 8"/>
+          <p:cNvSpPr txBox="1"/>
+          <p:nvPr/>
+        </p:nvSpPr>
+        <p:spPr>
+          <a:xfrm>
+            <a:off x="1051560" y="3174674"/>
+            <a:ext cx="1645920" cy="274320"/>
+          </a:xfrm>
+          <a:prstGeom prst="rect">
+            <a:avLst/>
+          </a:prstGeom>
+          <a:noFill/>
+        </p:spPr>
+        <p:txBody>
+          <a:bodyPr wrap="square" anchor="t" lIns="0" rIns="0" tIns="0" bIns="0"/>
           <a:lstStyle/>
           <a:p>
             <a:pPr algn="l">
@@ -6099,27 +6373,27 @@
               </a:lnSpc>
             </a:pPr>
             <a:r>
-              <a:rPr sz="9600" b="1">
-                <a:solidFill>
-                  <a:srgbClr val="8B3DFF"/>
-                </a:solidFill>
-                <a:latin typeface="Noto Sans Mono"/>
-              </a:rPr>
-              <a:t>git commit</a:t>
-            </a:r>
-          </a:p>
-        </p:txBody>
-      </p:sp>
-      <p:sp>
-        <p:nvSpPr>
-          <p:cNvPr id="6" name="TextBox 5"/>
+              <a:rPr sz="1400" b="1">
+                <a:solidFill>
+                  <a:srgbClr val="707078"/>
+                </a:solidFill>
+                <a:latin typeface="Inter"/>
+              </a:rPr>
+              <a:t>WHAT IT DOES</a:t>
+            </a:r>
+          </a:p>
+        </p:txBody>
+      </p:sp>
+      <p:sp>
+        <p:nvSpPr>
+          <p:cNvPr id="10" name="TextBox 9"/>
           <p:cNvSpPr txBox="1"/>
           <p:nvPr/>
         </p:nvSpPr>
         <p:spPr>
           <a:xfrm>
-            <a:off x="822960" y="3840480"/>
-            <a:ext cx="10545775" cy="640080"/>
+            <a:off x="3017520" y="3076122"/>
+            <a:ext cx="8122615" cy="757285"/>
           </a:xfrm>
           <a:prstGeom prst="rect">
             <a:avLst/>
@@ -6132,35 +6406,35 @@
           <a:p>
             <a:pPr algn="l">
               <a:lnSpc>
-                <a:spcPct val="110000"/>
+                <a:spcPct val="112000"/>
               </a:lnSpc>
             </a:pPr>
             <a:r>
-              <a:rPr sz="3400" b="0">
+              <a:rPr sz="2200" b="0">
                 <a:solidFill>
                   <a:srgbClr val="111111"/>
                 </a:solidFill>
                 <a:latin typeface="Inter"/>
               </a:rPr>
-              <a:t>Each save makes a new card that never changes.</a:t>
-            </a:r>
-          </a:p>
-        </p:txBody>
-      </p:sp>
-      <p:sp>
-        <p:nvSpPr>
-          <p:cNvPr id="7" name="Rounded Rectangle 6"/>
+              <a:t>records the exact state, who saved it, when, and the commit before it.</a:t>
+            </a:r>
+          </a:p>
+        </p:txBody>
+      </p:sp>
+      <p:sp>
+        <p:nvSpPr>
+          <p:cNvPr id="11" name="Rounded Rectangle 10"/>
           <p:cNvSpPr/>
           <p:nvPr/>
         </p:nvSpPr>
         <p:spPr>
           <a:xfrm>
-            <a:off x="822960" y="5029200"/>
-            <a:ext cx="10545775" cy="1005840"/>
+            <a:off x="822960" y="4043719"/>
+            <a:ext cx="10545775" cy="1779219"/>
           </a:xfrm>
           <a:prstGeom prst="roundRect">
             <a:avLst>
-              <a:gd name="adj" fmla="val 20000"/>
+              <a:gd name="adj" fmla="val 12000"/>
             </a:avLst>
           </a:prstGeom>
           <a:solidFill>
@@ -6179,14 +6453,14 @@
       </p:sp>
       <p:sp>
         <p:nvSpPr>
-          <p:cNvPr id="8" name="TextBox 7"/>
+          <p:cNvPr id="12" name="TextBox 11"/>
           <p:cNvSpPr txBox="1"/>
           <p:nvPr/>
         </p:nvSpPr>
         <p:spPr>
           <a:xfrm>
-            <a:off x="1188720" y="5193792"/>
-            <a:ext cx="9814255" cy="274320"/>
+            <a:off x="1051560" y="4318801"/>
+            <a:ext cx="1645920" cy="274320"/>
           </a:xfrm>
           <a:prstGeom prst="rect">
             <a:avLst/>
@@ -6203,27 +6477,27 @@
               </a:lnSpc>
             </a:pPr>
             <a:r>
-              <a:rPr sz="1300" b="1">
+              <a:rPr sz="1400" b="1">
                 <a:solidFill>
                   <a:srgbClr val="8B3DFF"/>
                 </a:solidFill>
                 <a:latin typeface="Inter"/>
               </a:rPr>
-              <a:t>BEHIND THE DOOR</a:t>
-            </a:r>
-          </a:p>
-        </p:txBody>
-      </p:sp>
-      <p:sp>
-        <p:nvSpPr>
-          <p:cNvPr id="9" name="TextBox 8"/>
+              <a:t>HOW GIT DOES IT</a:t>
+            </a:r>
+          </a:p>
+        </p:txBody>
+      </p:sp>
+      <p:sp>
+        <p:nvSpPr>
+          <p:cNvPr id="13" name="TextBox 12"/>
           <p:cNvSpPr txBox="1"/>
           <p:nvPr/>
         </p:nvSpPr>
         <p:spPr>
           <a:xfrm>
-            <a:off x="1188720" y="5486400"/>
-            <a:ext cx="9814255" cy="365760"/>
+            <a:off x="3017520" y="4244887"/>
+            <a:ext cx="8122615" cy="1376883"/>
           </a:xfrm>
           <a:prstGeom prst="rect">
             <a:avLst/>
@@ -6236,17 +6510,83 @@
           <a:p>
             <a:pPr algn="l">
               <a:lnSpc>
-                <a:spcPct val="110000"/>
+                <a:spcPct val="112000"/>
               </a:lnSpc>
             </a:pPr>
             <a:r>
-              <a:rPr sz="1700" b="0">
+              <a:rPr sz="2000" b="0">
                 <a:solidFill>
                   <a:srgbClr val="111111"/>
                 </a:solidFill>
-                <a:latin typeface="Noto Sans Mono"/>
-              </a:rPr>
-              <a:t>commit = tree + parent + author + time + message -&gt; SHA-1 ID</a:t>
+                <a:latin typeface="Inter"/>
+              </a:rPr>
+              <a:t>each file is stored as a blob, the folder as a tree. A commit object = tree ID + parent ID(s) + author + committer + message. Its ID is the SHA-1 of that object, so any change gives a new ID. Nothing is edited in place.</a:t>
+            </a:r>
+          </a:p>
+        </p:txBody>
+      </p:sp>
+      <p:sp>
+        <p:nvSpPr>
+          <p:cNvPr id="14" name="Rectangle 13"/>
+          <p:cNvSpPr/>
+          <p:nvPr/>
+        </p:nvSpPr>
+        <p:spPr>
+          <a:xfrm>
+            <a:off x="822960" y="6024106"/>
+            <a:ext cx="73152" cy="378642"/>
+          </a:xfrm>
+          <a:prstGeom prst="rect">
+            <a:avLst/>
+          </a:prstGeom>
+          <a:solidFill>
+            <a:srgbClr val="F5A524"/>
+          </a:solidFill>
+          <a:ln>
+            <a:noFill/>
+          </a:ln>
+        </p:spPr>
+        <p:txBody>
+          <a:bodyPr rtlCol="0" anchor="ctr"/>
+          <a:lstStyle/>
+          <a:p>
+            <a:pPr algn="ctr"/>
+          </a:p>
+        </p:txBody>
+      </p:sp>
+      <p:sp>
+        <p:nvSpPr>
+          <p:cNvPr id="15" name="TextBox 14"/>
+          <p:cNvSpPr txBox="1"/>
+          <p:nvPr/>
+        </p:nvSpPr>
+        <p:spPr>
+          <a:xfrm>
+            <a:off x="1188720" y="6024106"/>
+            <a:ext cx="10180015" cy="378642"/>
+          </a:xfrm>
+          <a:prstGeom prst="rect">
+            <a:avLst/>
+          </a:prstGeom>
+          <a:noFill/>
+        </p:spPr>
+        <p:txBody>
+          <a:bodyPr wrap="square" anchor="t" lIns="0" rIns="0" tIns="0" bIns="0"/>
+          <a:lstStyle/>
+          <a:p>
+            <a:pPr algn="l">
+              <a:lnSpc>
+                <a:spcPct val="112000"/>
+              </a:lnSpc>
+            </a:pPr>
+            <a:r>
+              <a:rPr sz="2200" b="1">
+                <a:solidFill>
+                  <a:srgbClr val="111111"/>
+                </a:solidFill>
+                <a:latin typeface="Inter"/>
+              </a:rPr>
+              <a:t>Git stores the name and clock your laptop gives it. It checks neither.</a:t>
             </a:r>
           </a:p>
         </p:txBody>
@@ -6285,7 +6625,7 @@
         </p:nvSpPr>
         <p:spPr>
           <a:xfrm>
-            <a:off x="822960" y="594360"/>
+            <a:off x="822960" y="502920"/>
             <a:ext cx="1344168" cy="457200"/>
           </a:xfrm>
           <a:prstGeom prst="roundRect">
@@ -6326,7 +6666,7 @@
         </p:nvSpPr>
         <p:spPr>
           <a:xfrm>
-            <a:off x="2423160" y="594360"/>
+            <a:off x="2441448" y="502920"/>
             <a:ext cx="8229600" cy="457200"/>
           </a:xfrm>
           <a:prstGeom prst="rect">
@@ -6363,8 +6703,74 @@
         </p:nvSpPr>
         <p:spPr>
           <a:xfrm>
-            <a:off x="822960" y="1280160"/>
-            <a:ext cx="10545775" cy="822960"/>
+            <a:off x="822960" y="1143000"/>
+            <a:ext cx="10545775" cy="914400"/>
+          </a:xfrm>
+          <a:prstGeom prst="rect">
+            <a:avLst/>
+          </a:prstGeom>
+          <a:noFill/>
+        </p:spPr>
+        <p:txBody>
+          <a:bodyPr wrap="square" anchor="b" lIns="0" rIns="0" tIns="0" bIns="0"/>
+          <a:lstStyle/>
+          <a:p>
+            <a:pPr algn="l">
+              <a:lnSpc>
+                <a:spcPct val="100000"/>
+              </a:lnSpc>
+            </a:pPr>
+            <a:r>
+              <a:rPr sz="6600" b="1">
+                <a:solidFill>
+                  <a:srgbClr val="8B3DFF"/>
+                </a:solidFill>
+                <a:latin typeface="Noto Sans Mono"/>
+              </a:rPr>
+              <a:t>git branch</a:t>
+            </a:r>
+          </a:p>
+        </p:txBody>
+      </p:sp>
+      <p:sp>
+        <p:nvSpPr>
+          <p:cNvPr id="5" name="Rectangle 4"/>
+          <p:cNvSpPr/>
+          <p:nvPr/>
+        </p:nvSpPr>
+        <p:spPr>
+          <a:xfrm>
+            <a:off x="822960" y="2286000"/>
+            <a:ext cx="10545775" cy="12700"/>
+          </a:xfrm>
+          <a:prstGeom prst="rect">
+            <a:avLst/>
+          </a:prstGeom>
+          <a:solidFill>
+            <a:srgbClr val="D9D9DE"/>
+          </a:solidFill>
+          <a:ln>
+            <a:noFill/>
+          </a:ln>
+        </p:spPr>
+        <p:txBody>
+          <a:bodyPr rtlCol="0" anchor="ctr"/>
+          <a:lstStyle/>
+          <a:p>
+            <a:pPr algn="ctr"/>
+          </a:p>
+        </p:txBody>
+      </p:sp>
+      <p:sp>
+        <p:nvSpPr>
+          <p:cNvPr id="6" name="TextBox 5"/>
+          <p:cNvSpPr txBox="1"/>
+          <p:nvPr/>
+        </p:nvSpPr>
+        <p:spPr>
+          <a:xfrm>
+            <a:off x="1051560" y="2521712"/>
+            <a:ext cx="1645920" cy="274320"/>
           </a:xfrm>
           <a:prstGeom prst="rect">
             <a:avLst/>
@@ -6381,27 +6787,27 @@
               </a:lnSpc>
             </a:pPr>
             <a:r>
-              <a:rPr sz="2400" b="0" i="1">
+              <a:rPr sz="1400" b="1">
                 <a:solidFill>
                   <a:srgbClr val="707078"/>
                 </a:solidFill>
                 <a:latin typeface="Inter"/>
               </a:rPr>
-              <a:t>Where is the original monster now? Did anything get copied?</a:t>
-            </a:r>
-          </a:p>
-        </p:txBody>
-      </p:sp>
-      <p:sp>
-        <p:nvSpPr>
-          <p:cNvPr id="5" name="TextBox 4"/>
+              <a:t>WHAT IT IS</a:t>
+            </a:r>
+          </a:p>
+        </p:txBody>
+      </p:sp>
+      <p:sp>
+        <p:nvSpPr>
+          <p:cNvPr id="7" name="TextBox 6"/>
           <p:cNvSpPr txBox="1"/>
           <p:nvPr/>
         </p:nvSpPr>
         <p:spPr>
           <a:xfrm>
-            <a:off x="822960" y="2011680"/>
-            <a:ext cx="10545775" cy="1371600"/>
+            <a:off x="3017520" y="2423160"/>
+            <a:ext cx="8122615" cy="378642"/>
           </a:xfrm>
           <a:prstGeom prst="rect">
             <a:avLst/>
@@ -6409,7 +6815,73 @@
           <a:noFill/>
         </p:spPr>
         <p:txBody>
-          <a:bodyPr wrap="square" anchor="ctr" lIns="0" rIns="0" tIns="0" bIns="0"/>
+          <a:bodyPr wrap="square" anchor="t" lIns="0" rIns="0" tIns="0" bIns="0"/>
+          <a:lstStyle/>
+          <a:p>
+            <a:pPr algn="l">
+              <a:lnSpc>
+                <a:spcPct val="112000"/>
+              </a:lnSpc>
+            </a:pPr>
+            <a:r>
+              <a:rPr sz="2200" b="0">
+                <a:solidFill>
+                  <a:srgbClr val="111111"/>
+                </a:solidFill>
+                <a:latin typeface="Inter"/>
+              </a:rPr>
+              <a:t>a movable label on one commit.</a:t>
+            </a:r>
+          </a:p>
+        </p:txBody>
+      </p:sp>
+      <p:sp>
+        <p:nvSpPr>
+          <p:cNvPr id="8" name="Rectangle 7"/>
+          <p:cNvSpPr/>
+          <p:nvPr/>
+        </p:nvSpPr>
+        <p:spPr>
+          <a:xfrm>
+            <a:off x="822960" y="2938962"/>
+            <a:ext cx="10545775" cy="12700"/>
+          </a:xfrm>
+          <a:prstGeom prst="rect">
+            <a:avLst/>
+          </a:prstGeom>
+          <a:solidFill>
+            <a:srgbClr val="D9D9DE"/>
+          </a:solidFill>
+          <a:ln>
+            <a:noFill/>
+          </a:ln>
+        </p:spPr>
+        <p:txBody>
+          <a:bodyPr rtlCol="0" anchor="ctr"/>
+          <a:lstStyle/>
+          <a:p>
+            <a:pPr algn="ctr"/>
+          </a:p>
+        </p:txBody>
+      </p:sp>
+      <p:sp>
+        <p:nvSpPr>
+          <p:cNvPr id="9" name="TextBox 8"/>
+          <p:cNvSpPr txBox="1"/>
+          <p:nvPr/>
+        </p:nvSpPr>
+        <p:spPr>
+          <a:xfrm>
+            <a:off x="1051560" y="3174674"/>
+            <a:ext cx="1645920" cy="274320"/>
+          </a:xfrm>
+          <a:prstGeom prst="rect">
+            <a:avLst/>
+          </a:prstGeom>
+          <a:noFill/>
+        </p:spPr>
+        <p:txBody>
+          <a:bodyPr wrap="square" anchor="t" lIns="0" rIns="0" tIns="0" bIns="0"/>
           <a:lstStyle/>
           <a:p>
             <a:pPr algn="l">
@@ -6418,27 +6890,27 @@
               </a:lnSpc>
             </a:pPr>
             <a:r>
-              <a:rPr sz="5800" b="1">
-                <a:solidFill>
-                  <a:srgbClr val="8B3DFF"/>
-                </a:solidFill>
-                <a:latin typeface="Noto Sans Mono"/>
-              </a:rPr>
-              <a:t>git switch -c cat-robot</a:t>
-            </a:r>
-          </a:p>
-        </p:txBody>
-      </p:sp>
-      <p:sp>
-        <p:nvSpPr>
-          <p:cNvPr id="6" name="TextBox 5"/>
+              <a:rPr sz="1400" b="1">
+                <a:solidFill>
+                  <a:srgbClr val="707078"/>
+                </a:solidFill>
+                <a:latin typeface="Inter"/>
+              </a:rPr>
+              <a:t>WHAT IT DOES</a:t>
+            </a:r>
+          </a:p>
+        </p:txBody>
+      </p:sp>
+      <p:sp>
+        <p:nvSpPr>
+          <p:cNvPr id="10" name="TextBox 9"/>
           <p:cNvSpPr txBox="1"/>
           <p:nvPr/>
         </p:nvSpPr>
         <p:spPr>
           <a:xfrm>
-            <a:off x="822960" y="3840480"/>
-            <a:ext cx="10545775" cy="640080"/>
+            <a:off x="3017520" y="3076122"/>
+            <a:ext cx="8122615" cy="378642"/>
           </a:xfrm>
           <a:prstGeom prst="rect">
             <a:avLst/>
@@ -6451,35 +6923,35 @@
           <a:p>
             <a:pPr algn="l">
               <a:lnSpc>
-                <a:spcPct val="110000"/>
+                <a:spcPct val="112000"/>
               </a:lnSpc>
             </a:pPr>
             <a:r>
-              <a:rPr sz="3400" b="0">
+              <a:rPr sz="2200" b="0">
                 <a:solidFill>
                   <a:srgbClr val="111111"/>
                 </a:solidFill>
                 <a:latin typeface="Inter"/>
               </a:rPr>
-              <a:t>A sticky note is a label, not a copy.</a:t>
-            </a:r>
-          </a:p>
-        </p:txBody>
-      </p:sp>
-      <p:sp>
-        <p:nvSpPr>
-          <p:cNvPr id="7" name="Rounded Rectangle 6"/>
+              <a:t>lets you try an idea without touching main.</a:t>
+            </a:r>
+          </a:p>
+        </p:txBody>
+      </p:sp>
+      <p:sp>
+        <p:nvSpPr>
+          <p:cNvPr id="11" name="Rounded Rectangle 10"/>
           <p:cNvSpPr/>
           <p:nvPr/>
         </p:nvSpPr>
         <p:spPr>
           <a:xfrm>
-            <a:off x="822960" y="5029200"/>
-            <a:ext cx="10545775" cy="1005840"/>
+            <a:off x="822960" y="3665076"/>
+            <a:ext cx="10545775" cy="1434998"/>
           </a:xfrm>
           <a:prstGeom prst="roundRect">
             <a:avLst>
-              <a:gd name="adj" fmla="val 20000"/>
+              <a:gd name="adj" fmla="val 12000"/>
             </a:avLst>
           </a:prstGeom>
           <a:solidFill>
@@ -6498,14 +6970,14 @@
       </p:sp>
       <p:sp>
         <p:nvSpPr>
-          <p:cNvPr id="8" name="TextBox 7"/>
+          <p:cNvPr id="12" name="TextBox 11"/>
           <p:cNvSpPr txBox="1"/>
           <p:nvPr/>
         </p:nvSpPr>
         <p:spPr>
           <a:xfrm>
-            <a:off x="1188720" y="5193792"/>
-            <a:ext cx="9814255" cy="274320"/>
+            <a:off x="1051560" y="3940158"/>
+            <a:ext cx="1645920" cy="274320"/>
           </a:xfrm>
           <a:prstGeom prst="rect">
             <a:avLst/>
@@ -6522,27 +6994,27 @@
               </a:lnSpc>
             </a:pPr>
             <a:r>
-              <a:rPr sz="1300" b="1">
+              <a:rPr sz="1400" b="1">
                 <a:solidFill>
                   <a:srgbClr val="8B3DFF"/>
                 </a:solidFill>
                 <a:latin typeface="Inter"/>
               </a:rPr>
-              <a:t>BEHIND THE DOOR</a:t>
-            </a:r>
-          </a:p>
-        </p:txBody>
-      </p:sp>
-      <p:sp>
-        <p:nvSpPr>
-          <p:cNvPr id="9" name="TextBox 8"/>
+              <a:t>HOW GIT DOES IT</a:t>
+            </a:r>
+          </a:p>
+        </p:txBody>
+      </p:sp>
+      <p:sp>
+        <p:nvSpPr>
+          <p:cNvPr id="13" name="TextBox 12"/>
           <p:cNvSpPr txBox="1"/>
           <p:nvPr/>
         </p:nvSpPr>
         <p:spPr>
           <a:xfrm>
-            <a:off x="1188720" y="5486400"/>
-            <a:ext cx="9814255" cy="365760"/>
+            <a:off x="3017520" y="3866244"/>
+            <a:ext cx="8122615" cy="1032662"/>
           </a:xfrm>
           <a:prstGeom prst="rect">
             <a:avLst/>
@@ -6555,17 +7027,35 @@
           <a:p>
             <a:pPr algn="l">
               <a:lnSpc>
-                <a:spcPct val="110000"/>
+                <a:spcPct val="112000"/>
               </a:lnSpc>
             </a:pPr>
             <a:r>
-              <a:rPr sz="1700" b="0">
+              <a:rPr sz="2000" b="0">
                 <a:solidFill>
                   <a:srgbClr val="111111"/>
                 </a:solidFill>
+                <a:latin typeface="Inter"/>
+              </a:rPr>
+              <a:t>a branch is a tiny file (</a:t>
+            </a:r>
+            <a:r>
+              <a:rPr sz="2000" b="0">
+                <a:solidFill>
+                  <a:srgbClr val="111111"/>
+                </a:solidFill>
                 <a:latin typeface="Noto Sans Mono"/>
               </a:rPr>
-              <a:t>.git/refs/heads/cat-robot holds one commit ID · HEAD points to it</a:t>
+              <a:t>.git/⁠refs/⁠heads/⁠&lt;name&gt;</a:t>
+            </a:r>
+            <a:r>
+              <a:rPr sz="2000" b="0">
+                <a:solidFill>
+                  <a:srgbClr val="111111"/>
+                </a:solidFill>
+                <a:latin typeface="Inter"/>
+              </a:rPr>
+              <a:t>) holding one commit ID. Committing moves it forward. HEAD records which branch you are on. Creating a branch copies nothing.</a:t>
             </a:r>
           </a:p>
         </p:txBody>
@@ -6604,7 +7094,7 @@
         </p:nvSpPr>
         <p:spPr>
           <a:xfrm>
-            <a:off x="822960" y="594360"/>
+            <a:off x="822960" y="502920"/>
             <a:ext cx="1344168" cy="457200"/>
           </a:xfrm>
           <a:prstGeom prst="roundRect">
@@ -6645,7 +7135,7 @@
         </p:nvSpPr>
         <p:spPr>
           <a:xfrm>
-            <a:off x="2423160" y="594360"/>
+            <a:off x="2441448" y="502920"/>
             <a:ext cx="8229600" cy="457200"/>
           </a:xfrm>
           <a:prstGeom prst="rect">
@@ -6669,7 +7159,7 @@
                 </a:solidFill>
                 <a:latin typeface="Inter"/>
               </a:rPr>
-              <a:t>Make one monster from both</a:t>
+              <a:t>Make one outfit from both</a:t>
             </a:r>
           </a:p>
         </p:txBody>
@@ -6682,8 +7172,74 @@
         </p:nvSpPr>
         <p:spPr>
           <a:xfrm>
-            <a:off x="822960" y="1280160"/>
-            <a:ext cx="10545775" cy="822960"/>
+            <a:off x="822960" y="1143000"/>
+            <a:ext cx="10545775" cy="914400"/>
+          </a:xfrm>
+          <a:prstGeom prst="rect">
+            <a:avLst/>
+          </a:prstGeom>
+          <a:noFill/>
+        </p:spPr>
+        <p:txBody>
+          <a:bodyPr wrap="square" anchor="b" lIns="0" rIns="0" tIns="0" bIns="0"/>
+          <a:lstStyle/>
+          <a:p>
+            <a:pPr algn="l">
+              <a:lnSpc>
+                <a:spcPct val="100000"/>
+              </a:lnSpc>
+            </a:pPr>
+            <a:r>
+              <a:rPr sz="6600" b="1">
+                <a:solidFill>
+                  <a:srgbClr val="8B3DFF"/>
+                </a:solidFill>
+                <a:latin typeface="Noto Sans Mono"/>
+              </a:rPr>
+              <a:t>git merge</a:t>
+            </a:r>
+          </a:p>
+        </p:txBody>
+      </p:sp>
+      <p:sp>
+        <p:nvSpPr>
+          <p:cNvPr id="5" name="Rectangle 4"/>
+          <p:cNvSpPr/>
+          <p:nvPr/>
+        </p:nvSpPr>
+        <p:spPr>
+          <a:xfrm>
+            <a:off x="822960" y="2286000"/>
+            <a:ext cx="10545775" cy="12700"/>
+          </a:xfrm>
+          <a:prstGeom prst="rect">
+            <a:avLst/>
+          </a:prstGeom>
+          <a:solidFill>
+            <a:srgbClr val="D9D9DE"/>
+          </a:solidFill>
+          <a:ln>
+            <a:noFill/>
+          </a:ln>
+        </p:spPr>
+        <p:txBody>
+          <a:bodyPr rtlCol="0" anchor="ctr"/>
+          <a:lstStyle/>
+          <a:p>
+            <a:pPr algn="ctr"/>
+          </a:p>
+        </p:txBody>
+      </p:sp>
+      <p:sp>
+        <p:nvSpPr>
+          <p:cNvPr id="6" name="TextBox 5"/>
+          <p:cNvSpPr txBox="1"/>
+          <p:nvPr/>
+        </p:nvSpPr>
+        <p:spPr>
+          <a:xfrm>
+            <a:off x="1051560" y="2521712"/>
+            <a:ext cx="1645920" cy="274320"/>
           </a:xfrm>
           <a:prstGeom prst="rect">
             <a:avLst/>
@@ -6700,27 +7256,27 @@
               </a:lnSpc>
             </a:pPr>
             <a:r>
-              <a:rPr sz="2400" b="0" i="1">
+              <a:rPr sz="1400" b="1">
                 <a:solidFill>
                   <a:srgbClr val="707078"/>
                 </a:solidFill>
                 <a:latin typeface="Inter"/>
               </a:rPr>
-              <a:t>Why did FACE and LEGS combine alone, but BODY needed you?</a:t>
-            </a:r>
-          </a:p>
-        </p:txBody>
-      </p:sp>
-      <p:sp>
-        <p:nvSpPr>
-          <p:cNvPr id="5" name="TextBox 4"/>
+              <a:t>WHAT IT IS</a:t>
+            </a:r>
+          </a:p>
+        </p:txBody>
+      </p:sp>
+      <p:sp>
+        <p:nvSpPr>
+          <p:cNvPr id="7" name="TextBox 6"/>
           <p:cNvSpPr txBox="1"/>
           <p:nvPr/>
         </p:nvSpPr>
         <p:spPr>
           <a:xfrm>
-            <a:off x="822960" y="2011680"/>
-            <a:ext cx="10545775" cy="1371600"/>
+            <a:off x="3017520" y="2423160"/>
+            <a:ext cx="8122615" cy="378642"/>
           </a:xfrm>
           <a:prstGeom prst="rect">
             <a:avLst/>
@@ -6728,7 +7284,73 @@
           <a:noFill/>
         </p:spPr>
         <p:txBody>
-          <a:bodyPr wrap="square" anchor="ctr" lIns="0" rIns="0" tIns="0" bIns="0"/>
+          <a:bodyPr wrap="square" anchor="t" lIns="0" rIns="0" tIns="0" bIns="0"/>
+          <a:lstStyle/>
+          <a:p>
+            <a:pPr algn="l">
+              <a:lnSpc>
+                <a:spcPct val="112000"/>
+              </a:lnSpc>
+            </a:pPr>
+            <a:r>
+              <a:rPr sz="2200" b="0">
+                <a:solidFill>
+                  <a:srgbClr val="111111"/>
+                </a:solidFill>
+                <a:latin typeface="Inter"/>
+              </a:rPr>
+              <a:t>combining two lines of work.</a:t>
+            </a:r>
+          </a:p>
+        </p:txBody>
+      </p:sp>
+      <p:sp>
+        <p:nvSpPr>
+          <p:cNvPr id="8" name="Rectangle 7"/>
+          <p:cNvSpPr/>
+          <p:nvPr/>
+        </p:nvSpPr>
+        <p:spPr>
+          <a:xfrm>
+            <a:off x="822960" y="2938962"/>
+            <a:ext cx="10545775" cy="12700"/>
+          </a:xfrm>
+          <a:prstGeom prst="rect">
+            <a:avLst/>
+          </a:prstGeom>
+          <a:solidFill>
+            <a:srgbClr val="D9D9DE"/>
+          </a:solidFill>
+          <a:ln>
+            <a:noFill/>
+          </a:ln>
+        </p:spPr>
+        <p:txBody>
+          <a:bodyPr rtlCol="0" anchor="ctr"/>
+          <a:lstStyle/>
+          <a:p>
+            <a:pPr algn="ctr"/>
+          </a:p>
+        </p:txBody>
+      </p:sp>
+      <p:sp>
+        <p:nvSpPr>
+          <p:cNvPr id="9" name="TextBox 8"/>
+          <p:cNvSpPr txBox="1"/>
+          <p:nvPr/>
+        </p:nvSpPr>
+        <p:spPr>
+          <a:xfrm>
+            <a:off x="1051560" y="3174674"/>
+            <a:ext cx="1645920" cy="274320"/>
+          </a:xfrm>
+          <a:prstGeom prst="rect">
+            <a:avLst/>
+          </a:prstGeom>
+          <a:noFill/>
+        </p:spPr>
+        <p:txBody>
+          <a:bodyPr wrap="square" anchor="t" lIns="0" rIns="0" tIns="0" bIns="0"/>
           <a:lstStyle/>
           <a:p>
             <a:pPr algn="l">
@@ -6737,27 +7359,27 @@
               </a:lnSpc>
             </a:pPr>
             <a:r>
-              <a:rPr sz="7000" b="1">
-                <a:solidFill>
-                  <a:srgbClr val="8B3DFF"/>
-                </a:solidFill>
-                <a:latin typeface="Noto Sans Mono"/>
-              </a:rPr>
-              <a:t>git merge superhero</a:t>
-            </a:r>
-          </a:p>
-        </p:txBody>
-      </p:sp>
-      <p:sp>
-        <p:nvSpPr>
-          <p:cNvPr id="6" name="TextBox 5"/>
+              <a:rPr sz="1400" b="1">
+                <a:solidFill>
+                  <a:srgbClr val="707078"/>
+                </a:solidFill>
+                <a:latin typeface="Inter"/>
+              </a:rPr>
+              <a:t>WHAT IT DOES</a:t>
+            </a:r>
+          </a:p>
+        </p:txBody>
+      </p:sp>
+      <p:sp>
+        <p:nvSpPr>
+          <p:cNvPr id="10" name="TextBox 9"/>
           <p:cNvSpPr txBox="1"/>
           <p:nvPr/>
         </p:nvSpPr>
         <p:spPr>
           <a:xfrm>
-            <a:off x="822960" y="3840480"/>
-            <a:ext cx="10545775" cy="640080"/>
+            <a:off x="3017520" y="3076122"/>
+            <a:ext cx="8122615" cy="757285"/>
           </a:xfrm>
           <a:prstGeom prst="rect">
             <a:avLst/>
@@ -6770,35 +7392,35 @@
           <a:p>
             <a:pPr algn="l">
               <a:lnSpc>
-                <a:spcPct val="110000"/>
+                <a:spcPct val="112000"/>
               </a:lnSpc>
             </a:pPr>
             <a:r>
-              <a:rPr sz="3400" b="0">
+              <a:rPr sz="2200" b="0">
                 <a:solidFill>
                   <a:srgbClr val="111111"/>
                 </a:solidFill>
                 <a:latin typeface="Inter"/>
               </a:rPr>
-              <a:t>Compare both sides with the card they share.</a:t>
-            </a:r>
-          </a:p>
-        </p:txBody>
-      </p:sp>
-      <p:sp>
-        <p:nvSpPr>
-          <p:cNvPr id="7" name="Rounded Rectangle 6"/>
+              <a:t>keeps a change made on one side. It stops for a person when both sides changed the same lines.</a:t>
+            </a:r>
+          </a:p>
+        </p:txBody>
+      </p:sp>
+      <p:sp>
+        <p:nvSpPr>
+          <p:cNvPr id="11" name="Rounded Rectangle 10"/>
           <p:cNvSpPr/>
           <p:nvPr/>
         </p:nvSpPr>
         <p:spPr>
           <a:xfrm>
-            <a:off x="822960" y="5029200"/>
-            <a:ext cx="10545775" cy="1005840"/>
+            <a:off x="822960" y="4043719"/>
+            <a:ext cx="10545775" cy="1779219"/>
           </a:xfrm>
           <a:prstGeom prst="roundRect">
             <a:avLst>
-              <a:gd name="adj" fmla="val 20000"/>
+              <a:gd name="adj" fmla="val 12000"/>
             </a:avLst>
           </a:prstGeom>
           <a:solidFill>
@@ -6817,14 +7439,14 @@
       </p:sp>
       <p:sp>
         <p:nvSpPr>
-          <p:cNvPr id="8" name="TextBox 7"/>
+          <p:cNvPr id="12" name="TextBox 11"/>
           <p:cNvSpPr txBox="1"/>
           <p:nvPr/>
         </p:nvSpPr>
         <p:spPr>
           <a:xfrm>
-            <a:off x="1188720" y="5193792"/>
-            <a:ext cx="9814255" cy="274320"/>
+            <a:off x="1051560" y="4318801"/>
+            <a:ext cx="1645920" cy="274320"/>
           </a:xfrm>
           <a:prstGeom prst="rect">
             <a:avLst/>
@@ -6841,27 +7463,27 @@
               </a:lnSpc>
             </a:pPr>
             <a:r>
-              <a:rPr sz="1300" b="1">
+              <a:rPr sz="1400" b="1">
                 <a:solidFill>
                   <a:srgbClr val="8B3DFF"/>
                 </a:solidFill>
                 <a:latin typeface="Inter"/>
               </a:rPr>
-              <a:t>BEHIND THE DOOR</a:t>
-            </a:r>
-          </a:p>
-        </p:txBody>
-      </p:sp>
-      <p:sp>
-        <p:nvSpPr>
-          <p:cNvPr id="9" name="TextBox 8"/>
+              <a:t>HOW GIT DOES IT</a:t>
+            </a:r>
+          </a:p>
+        </p:txBody>
+      </p:sp>
+      <p:sp>
+        <p:nvSpPr>
+          <p:cNvPr id="13" name="TextBox 12"/>
           <p:cNvSpPr txBox="1"/>
           <p:nvPr/>
         </p:nvSpPr>
         <p:spPr>
           <a:xfrm>
-            <a:off x="1188720" y="5486400"/>
-            <a:ext cx="9814255" cy="365760"/>
+            <a:off x="3017520" y="4244887"/>
+            <a:ext cx="8122615" cy="1376883"/>
           </a:xfrm>
           <a:prstGeom prst="rect">
             <a:avLst/>
@@ -6874,17 +7496,17 @@
           <a:p>
             <a:pPr algn="l">
               <a:lnSpc>
-                <a:spcPct val="110000"/>
+                <a:spcPct val="112000"/>
               </a:lnSpc>
             </a:pPr>
             <a:r>
-              <a:rPr sz="1700" b="0">
+              <a:rPr sz="2000" b="0">
                 <a:solidFill>
                   <a:srgbClr val="111111"/>
                 </a:solidFill>
-                <a:latin typeface="Noto Sans Mono"/>
-              </a:rPr>
-              <a:t>3-way merge vs merge-base · both changed, differently -&gt; CONFLICT</a:t>
+                <a:latin typeface="Inter"/>
+              </a:rPr>
+              <a:t>Git finds the merge base (the last common commit) and compares each side with it (a 3-way merge). Then it writes a merge commit with two parents. If one side is ahead, it fast-forwards: only the label moves, and no merge commit is made.</a:t>
             </a:r>
           </a:p>
         </p:txBody>
@@ -6923,7 +7545,7 @@
         </p:nvSpPr>
         <p:spPr>
           <a:xfrm>
-            <a:off x="822960" y="594360"/>
+            <a:off x="822960" y="502920"/>
             <a:ext cx="1344168" cy="457200"/>
           </a:xfrm>
           <a:prstGeom prst="roundRect">
@@ -6964,7 +7586,7 @@
         </p:nvSpPr>
         <p:spPr>
           <a:xfrm>
-            <a:off x="2423160" y="594360"/>
+            <a:off x="2441448" y="502920"/>
             <a:ext cx="8229600" cy="457200"/>
           </a:xfrm>
           <a:prstGeom prst="rect">
@@ -6988,7 +7610,7 @@
                 </a:solidFill>
                 <a:latin typeface="Inter"/>
               </a:rPr>
-              <a:t>Meet the Wall</a:t>
+              <a:t>Put your outfit on the Wall</a:t>
             </a:r>
           </a:p>
         </p:txBody>
@@ -7001,8 +7623,74 @@
         </p:nvSpPr>
         <p:spPr>
           <a:xfrm>
-            <a:off x="822960" y="1280160"/>
-            <a:ext cx="10545775" cy="822960"/>
+            <a:off x="822960" y="1143000"/>
+            <a:ext cx="10545775" cy="914400"/>
+          </a:xfrm>
+          <a:prstGeom prst="rect">
+            <a:avLst/>
+          </a:prstGeom>
+          <a:noFill/>
+        </p:spPr>
+        <p:txBody>
+          <a:bodyPr wrap="square" anchor="b" lIns="0" rIns="0" tIns="0" bIns="0"/>
+          <a:lstStyle/>
+          <a:p>
+            <a:pPr algn="l">
+              <a:lnSpc>
+                <a:spcPct val="100000"/>
+              </a:lnSpc>
+            </a:pPr>
+            <a:r>
+              <a:rPr sz="6600" b="1">
+                <a:solidFill>
+                  <a:srgbClr val="8B3DFF"/>
+                </a:solidFill>
+                <a:latin typeface="Noto Sans Mono"/>
+              </a:rPr>
+              <a:t>git push / git pull</a:t>
+            </a:r>
+          </a:p>
+        </p:txBody>
+      </p:sp>
+      <p:sp>
+        <p:nvSpPr>
+          <p:cNvPr id="5" name="Rectangle 4"/>
+          <p:cNvSpPr/>
+          <p:nvPr/>
+        </p:nvSpPr>
+        <p:spPr>
+          <a:xfrm>
+            <a:off x="822960" y="2286000"/>
+            <a:ext cx="10545775" cy="12700"/>
+          </a:xfrm>
+          <a:prstGeom prst="rect">
+            <a:avLst/>
+          </a:prstGeom>
+          <a:solidFill>
+            <a:srgbClr val="D9D9DE"/>
+          </a:solidFill>
+          <a:ln>
+            <a:noFill/>
+          </a:ln>
+        </p:spPr>
+        <p:txBody>
+          <a:bodyPr rtlCol="0" anchor="ctr"/>
+          <a:lstStyle/>
+          <a:p>
+            <a:pPr algn="ctr"/>
+          </a:p>
+        </p:txBody>
+      </p:sp>
+      <p:sp>
+        <p:nvSpPr>
+          <p:cNvPr id="6" name="TextBox 5"/>
+          <p:cNvSpPr txBox="1"/>
+          <p:nvPr/>
+        </p:nvSpPr>
+        <p:spPr>
+          <a:xfrm>
+            <a:off x="1051560" y="2521712"/>
+            <a:ext cx="1645920" cy="274320"/>
           </a:xfrm>
           <a:prstGeom prst="rect">
             <a:avLst/>
@@ -7019,27 +7707,27 @@
               </a:lnSpc>
             </a:pPr>
             <a:r>
-              <a:rPr sz="2400" b="0" i="1">
+              <a:rPr sz="1400" b="1">
                 <a:solidFill>
                   <a:srgbClr val="707078"/>
                 </a:solidFill>
                 <a:latin typeface="Inter"/>
               </a:rPr>
-              <a:t>Two labs never made that card. Why does their copy have the same ID?</a:t>
-            </a:r>
-          </a:p>
-        </p:txBody>
-      </p:sp>
-      <p:sp>
-        <p:nvSpPr>
-          <p:cNvPr id="5" name="TextBox 4"/>
+              <a:t>WHAT IT IS</a:t>
+            </a:r>
+          </a:p>
+        </p:txBody>
+      </p:sp>
+      <p:sp>
+        <p:nvSpPr>
+          <p:cNvPr id="7" name="TextBox 6"/>
           <p:cNvSpPr txBox="1"/>
           <p:nvPr/>
         </p:nvSpPr>
         <p:spPr>
           <a:xfrm>
-            <a:off x="822960" y="2011680"/>
-            <a:ext cx="10545775" cy="1371600"/>
+            <a:off x="3017520" y="2423160"/>
+            <a:ext cx="8122615" cy="378642"/>
           </a:xfrm>
           <a:prstGeom prst="rect">
             <a:avLst/>
@@ -7047,7 +7735,73 @@
           <a:noFill/>
         </p:spPr>
         <p:txBody>
-          <a:bodyPr wrap="square" anchor="ctr" lIns="0" rIns="0" tIns="0" bIns="0"/>
+          <a:bodyPr wrap="square" anchor="t" lIns="0" rIns="0" tIns="0" bIns="0"/>
+          <a:lstStyle/>
+          <a:p>
+            <a:pPr algn="l">
+              <a:lnSpc>
+                <a:spcPct val="112000"/>
+              </a:lnSpc>
+            </a:pPr>
+            <a:r>
+              <a:rPr sz="2200" b="0">
+                <a:solidFill>
+                  <a:srgbClr val="111111"/>
+                </a:solidFill>
+                <a:latin typeface="Inter"/>
+              </a:rPr>
+              <a:t>sharing commits with a copy elsewhere (the Wall).</a:t>
+            </a:r>
+          </a:p>
+        </p:txBody>
+      </p:sp>
+      <p:sp>
+        <p:nvSpPr>
+          <p:cNvPr id="8" name="Rectangle 7"/>
+          <p:cNvSpPr/>
+          <p:nvPr/>
+        </p:nvSpPr>
+        <p:spPr>
+          <a:xfrm>
+            <a:off x="822960" y="2938962"/>
+            <a:ext cx="10545775" cy="12700"/>
+          </a:xfrm>
+          <a:prstGeom prst="rect">
+            <a:avLst/>
+          </a:prstGeom>
+          <a:solidFill>
+            <a:srgbClr val="D9D9DE"/>
+          </a:solidFill>
+          <a:ln>
+            <a:noFill/>
+          </a:ln>
+        </p:spPr>
+        <p:txBody>
+          <a:bodyPr rtlCol="0" anchor="ctr"/>
+          <a:lstStyle/>
+          <a:p>
+            <a:pPr algn="ctr"/>
+          </a:p>
+        </p:txBody>
+      </p:sp>
+      <p:sp>
+        <p:nvSpPr>
+          <p:cNvPr id="9" name="TextBox 8"/>
+          <p:cNvSpPr txBox="1"/>
+          <p:nvPr/>
+        </p:nvSpPr>
+        <p:spPr>
+          <a:xfrm>
+            <a:off x="1051560" y="3174674"/>
+            <a:ext cx="1645920" cy="274320"/>
+          </a:xfrm>
+          <a:prstGeom prst="rect">
+            <a:avLst/>
+          </a:prstGeom>
+          <a:noFill/>
+        </p:spPr>
+        <p:txBody>
+          <a:bodyPr wrap="square" anchor="t" lIns="0" rIns="0" tIns="0" bIns="0"/>
           <a:lstStyle/>
           <a:p>
             <a:pPr algn="l">
@@ -7056,27 +7810,27 @@
               </a:lnSpc>
             </a:pPr>
             <a:r>
-              <a:rPr sz="9600" b="1">
-                <a:solidFill>
-                  <a:srgbClr val="8B3DFF"/>
-                </a:solidFill>
-                <a:latin typeface="Noto Sans Mono"/>
-              </a:rPr>
-              <a:t>git clone</a:t>
-            </a:r>
-          </a:p>
-        </p:txBody>
-      </p:sp>
-      <p:sp>
-        <p:nvSpPr>
-          <p:cNvPr id="6" name="TextBox 5"/>
+              <a:rPr sz="1400" b="1">
+                <a:solidFill>
+                  <a:srgbClr val="707078"/>
+                </a:solidFill>
+                <a:latin typeface="Inter"/>
+              </a:rPr>
+              <a:t>WHAT IT DOES</a:t>
+            </a:r>
+          </a:p>
+        </p:txBody>
+      </p:sp>
+      <p:sp>
+        <p:nvSpPr>
+          <p:cNvPr id="10" name="TextBox 9"/>
           <p:cNvSpPr txBox="1"/>
           <p:nvPr/>
         </p:nvSpPr>
         <p:spPr>
           <a:xfrm>
-            <a:off x="822960" y="3840480"/>
-            <a:ext cx="10545775" cy="640080"/>
+            <a:off x="3017520" y="3076122"/>
+            <a:ext cx="8122615" cy="757285"/>
           </a:xfrm>
           <a:prstGeom prst="rect">
             <a:avLst/>
@@ -7089,35 +7843,35 @@
           <a:p>
             <a:pPr algn="l">
               <a:lnSpc>
-                <a:spcPct val="110000"/>
+                <a:spcPct val="112000"/>
               </a:lnSpc>
             </a:pPr>
             <a:r>
-              <a:rPr sz="3400" b="0">
+              <a:rPr sz="2200" b="0">
                 <a:solidFill>
                   <a:srgbClr val="111111"/>
                 </a:solidFill>
                 <a:latin typeface="Inter"/>
               </a:rPr>
-              <a:t>Every lab has a full copy with the same IDs.</a:t>
-            </a:r>
-          </a:p>
-        </p:txBody>
-      </p:sp>
-      <p:sp>
-        <p:nvSpPr>
-          <p:cNvPr id="7" name="Rounded Rectangle 6"/>
+              <a:t>push sends your new commits and moves the remote branch. pull brings theirs in.</a:t>
+            </a:r>
+          </a:p>
+        </p:txBody>
+      </p:sp>
+      <p:sp>
+        <p:nvSpPr>
+          <p:cNvPr id="11" name="Rounded Rectangle 10"/>
           <p:cNvSpPr/>
           <p:nvPr/>
         </p:nvSpPr>
         <p:spPr>
           <a:xfrm>
-            <a:off x="822960" y="5029200"/>
-            <a:ext cx="10545775" cy="1005840"/>
+            <a:off x="822960" y="4043719"/>
+            <a:ext cx="10545775" cy="1779219"/>
           </a:xfrm>
           <a:prstGeom prst="roundRect">
             <a:avLst>
-              <a:gd name="adj" fmla="val 20000"/>
+              <a:gd name="adj" fmla="val 12000"/>
             </a:avLst>
           </a:prstGeom>
           <a:solidFill>
@@ -7136,14 +7890,14 @@
       </p:sp>
       <p:sp>
         <p:nvSpPr>
-          <p:cNvPr id="8" name="TextBox 7"/>
+          <p:cNvPr id="12" name="TextBox 11"/>
           <p:cNvSpPr txBox="1"/>
           <p:nvPr/>
         </p:nvSpPr>
         <p:spPr>
           <a:xfrm>
-            <a:off x="1188720" y="5193792"/>
-            <a:ext cx="9814255" cy="274320"/>
+            <a:off x="1051560" y="4318801"/>
+            <a:ext cx="1645920" cy="274320"/>
           </a:xfrm>
           <a:prstGeom prst="rect">
             <a:avLst/>
@@ -7160,27 +7914,27 @@
               </a:lnSpc>
             </a:pPr>
             <a:r>
-              <a:rPr sz="1300" b="1">
+              <a:rPr sz="1400" b="1">
                 <a:solidFill>
                   <a:srgbClr val="8B3DFF"/>
                 </a:solidFill>
                 <a:latin typeface="Inter"/>
               </a:rPr>
-              <a:t>BEHIND THE DOOR</a:t>
-            </a:r>
-          </a:p>
-        </p:txBody>
-      </p:sp>
-      <p:sp>
-        <p:nvSpPr>
-          <p:cNvPr id="9" name="TextBox 8"/>
+              <a:t>HOW GIT DOES IT</a:t>
+            </a:r>
+          </a:p>
+        </p:txBody>
+      </p:sp>
+      <p:sp>
+        <p:nvSpPr>
+          <p:cNvPr id="13" name="TextBox 12"/>
           <p:cNvSpPr txBox="1"/>
           <p:nvPr/>
         </p:nvSpPr>
         <p:spPr>
           <a:xfrm>
-            <a:off x="1188720" y="5486400"/>
-            <a:ext cx="9814255" cy="365760"/>
+            <a:off x="3017520" y="4244887"/>
+            <a:ext cx="8122615" cy="1376883"/>
           </a:xfrm>
           <a:prstGeom prst="rect">
             <a:avLst/>
@@ -7193,17 +7947,17 @@
           <a:p>
             <a:pPr algn="l">
               <a:lnSpc>
-                <a:spcPct val="110000"/>
+                <a:spcPct val="112000"/>
               </a:lnSpc>
             </a:pPr>
             <a:r>
-              <a:rPr sz="1700" b="0">
+              <a:rPr sz="2000" b="0">
                 <a:solidFill>
                   <a:srgbClr val="111111"/>
                 </a:solidFill>
-                <a:latin typeface="Noto Sans Mono"/>
-              </a:rPr>
-              <a:t>ID = SHA-1 of the commit's bytes · same bytes -&gt; same ID everywhere</a:t>
+                <a:latin typeface="Inter"/>
+              </a:rPr>
+              <a:t>copies exchange only the objects the other side lacks; IDs come from content, so copies agree without coordination. A push is accepted only if it is a fast-forward of the remote branch. Otherwise fetch first, then merge or rebase.</a:t>
             </a:r>
           </a:p>
         </p:txBody>
@@ -7242,7 +7996,7 @@
         </p:nvSpPr>
         <p:spPr>
           <a:xfrm>
-            <a:off x="822960" y="594360"/>
+            <a:off x="822960" y="502920"/>
             <a:ext cx="1344168" cy="457200"/>
           </a:xfrm>
           <a:prstGeom prst="roundRect">
@@ -7270,7 +8024,7 @@
                 </a:solidFill>
                 <a:latin typeface="Inter"/>
               </a:rPr>
-              <a:t>STEP 5</a:t>
+              <a:t>STEP 4</a:t>
             </a:r>
           </a:p>
         </p:txBody>
@@ -7283,7 +8037,7 @@
         </p:nvSpPr>
         <p:spPr>
           <a:xfrm>
-            <a:off x="2423160" y="594360"/>
+            <a:off x="2441448" y="502920"/>
             <a:ext cx="8229600" cy="457200"/>
           </a:xfrm>
           <a:prstGeom prst="rect">
@@ -7307,7 +8061,7 @@
                 </a:solidFill>
                 <a:latin typeface="Inter"/>
               </a:rPr>
-              <a:t>Put your monster on the Wall</a:t>
+              <a:t>Put your outfit on the Wall</a:t>
             </a:r>
           </a:p>
         </p:txBody>
@@ -7320,8 +8074,74 @@
         </p:nvSpPr>
         <p:spPr>
           <a:xfrm>
-            <a:off x="822960" y="1280160"/>
-            <a:ext cx="10545775" cy="822960"/>
+            <a:off x="822960" y="1143000"/>
+            <a:ext cx="10545775" cy="914400"/>
+          </a:xfrm>
+          <a:prstGeom prst="rect">
+            <a:avLst/>
+          </a:prstGeom>
+          <a:noFill/>
+        </p:spPr>
+        <p:txBody>
+          <a:bodyPr wrap="square" anchor="b" lIns="0" rIns="0" tIns="0" bIns="0"/>
+          <a:lstStyle/>
+          <a:p>
+            <a:pPr algn="l">
+              <a:lnSpc>
+                <a:spcPct val="100000"/>
+              </a:lnSpc>
+            </a:pPr>
+            <a:r>
+              <a:rPr sz="6600" b="1">
+                <a:solidFill>
+                  <a:srgbClr val="8B3DFF"/>
+                </a:solidFill>
+                <a:latin typeface="Noto Sans Mono"/>
+              </a:rPr>
+              <a:t>git rebase</a:t>
+            </a:r>
+          </a:p>
+        </p:txBody>
+      </p:sp>
+      <p:sp>
+        <p:nvSpPr>
+          <p:cNvPr id="5" name="Rectangle 4"/>
+          <p:cNvSpPr/>
+          <p:nvPr/>
+        </p:nvSpPr>
+        <p:spPr>
+          <a:xfrm>
+            <a:off x="822960" y="2286000"/>
+            <a:ext cx="10545775" cy="12700"/>
+          </a:xfrm>
+          <a:prstGeom prst="rect">
+            <a:avLst/>
+          </a:prstGeom>
+          <a:solidFill>
+            <a:srgbClr val="D9D9DE"/>
+          </a:solidFill>
+          <a:ln>
+            <a:noFill/>
+          </a:ln>
+        </p:spPr>
+        <p:txBody>
+          <a:bodyPr rtlCol="0" anchor="ctr"/>
+          <a:lstStyle/>
+          <a:p>
+            <a:pPr algn="ctr"/>
+          </a:p>
+        </p:txBody>
+      </p:sp>
+      <p:sp>
+        <p:nvSpPr>
+          <p:cNvPr id="6" name="TextBox 5"/>
+          <p:cNvSpPr txBox="1"/>
+          <p:nvPr/>
+        </p:nvSpPr>
+        <p:spPr>
+          <a:xfrm>
+            <a:off x="1051560" y="2521712"/>
+            <a:ext cx="1645920" cy="274320"/>
           </a:xfrm>
           <a:prstGeom prst="rect">
             <a:avLst/>
@@ -7338,27 +8158,27 @@
               </a:lnSpc>
             </a:pPr>
             <a:r>
-              <a:rPr sz="2400" b="0" i="1">
+              <a:rPr sz="1400" b="1">
                 <a:solidFill>
                   <a:srgbClr val="707078"/>
                 </a:solidFill>
                 <a:latin typeface="Inter"/>
               </a:rPr>
-              <a:t>Why did the Wall refuse your card instead of adding it?</a:t>
-            </a:r>
-          </a:p>
-        </p:txBody>
-      </p:sp>
-      <p:sp>
-        <p:nvSpPr>
-          <p:cNvPr id="5" name="TextBox 4"/>
+              <a:t>WHAT IT IS</a:t>
+            </a:r>
+          </a:p>
+        </p:txBody>
+      </p:sp>
+      <p:sp>
+        <p:nvSpPr>
+          <p:cNvPr id="7" name="TextBox 6"/>
           <p:cNvSpPr txBox="1"/>
           <p:nvPr/>
         </p:nvSpPr>
         <p:spPr>
           <a:xfrm>
-            <a:off x="822960" y="2011680"/>
-            <a:ext cx="10545775" cy="1371600"/>
+            <a:off x="3017520" y="2423160"/>
+            <a:ext cx="8122615" cy="378642"/>
           </a:xfrm>
           <a:prstGeom prst="rect">
             <a:avLst/>
@@ -7366,7 +8186,73 @@
           <a:noFill/>
         </p:spPr>
         <p:txBody>
-          <a:bodyPr wrap="square" anchor="ctr" lIns="0" rIns="0" tIns="0" bIns="0"/>
+          <a:bodyPr wrap="square" anchor="t" lIns="0" rIns="0" tIns="0" bIns="0"/>
+          <a:lstStyle/>
+          <a:p>
+            <a:pPr algn="l">
+              <a:lnSpc>
+                <a:spcPct val="112000"/>
+              </a:lnSpc>
+            </a:pPr>
+            <a:r>
+              <a:rPr sz="2200" b="0">
+                <a:solidFill>
+                  <a:srgbClr val="111111"/>
+                </a:solidFill>
+                <a:latin typeface="Inter"/>
+              </a:rPr>
+              <a:t>replaying your commits on top of another branch.</a:t>
+            </a:r>
+          </a:p>
+        </p:txBody>
+      </p:sp>
+      <p:sp>
+        <p:nvSpPr>
+          <p:cNvPr id="8" name="Rectangle 7"/>
+          <p:cNvSpPr/>
+          <p:nvPr/>
+        </p:nvSpPr>
+        <p:spPr>
+          <a:xfrm>
+            <a:off x="822960" y="2938962"/>
+            <a:ext cx="10545775" cy="12700"/>
+          </a:xfrm>
+          <a:prstGeom prst="rect">
+            <a:avLst/>
+          </a:prstGeom>
+          <a:solidFill>
+            <a:srgbClr val="D9D9DE"/>
+          </a:solidFill>
+          <a:ln>
+            <a:noFill/>
+          </a:ln>
+        </p:spPr>
+        <p:txBody>
+          <a:bodyPr rtlCol="0" anchor="ctr"/>
+          <a:lstStyle/>
+          <a:p>
+            <a:pPr algn="ctr"/>
+          </a:p>
+        </p:txBody>
+      </p:sp>
+      <p:sp>
+        <p:nvSpPr>
+          <p:cNvPr id="9" name="TextBox 8"/>
+          <p:cNvSpPr txBox="1"/>
+          <p:nvPr/>
+        </p:nvSpPr>
+        <p:spPr>
+          <a:xfrm>
+            <a:off x="1051560" y="3174674"/>
+            <a:ext cx="1645920" cy="274320"/>
+          </a:xfrm>
+          <a:prstGeom prst="rect">
+            <a:avLst/>
+          </a:prstGeom>
+          <a:noFill/>
+        </p:spPr>
+        <p:txBody>
+          <a:bodyPr wrap="square" anchor="t" lIns="0" rIns="0" tIns="0" bIns="0"/>
           <a:lstStyle/>
           <a:p>
             <a:pPr algn="l">
@@ -7375,27 +8261,27 @@
               </a:lnSpc>
             </a:pPr>
             <a:r>
-              <a:rPr sz="7000" b="1">
-                <a:solidFill>
-                  <a:srgbClr val="8B3DFF"/>
-                </a:solidFill>
-                <a:latin typeface="Noto Sans Mono"/>
-              </a:rPr>
-              <a:t>git push · git pull</a:t>
-            </a:r>
-          </a:p>
-        </p:txBody>
-      </p:sp>
-      <p:sp>
-        <p:nvSpPr>
-          <p:cNvPr id="6" name="TextBox 5"/>
+              <a:rPr sz="1400" b="1">
+                <a:solidFill>
+                  <a:srgbClr val="707078"/>
+                </a:solidFill>
+                <a:latin typeface="Inter"/>
+              </a:rPr>
+              <a:t>WHAT IT DOES</a:t>
+            </a:r>
+          </a:p>
+        </p:txBody>
+      </p:sp>
+      <p:sp>
+        <p:nvSpPr>
+          <p:cNvPr id="10" name="TextBox 9"/>
           <p:cNvSpPr txBox="1"/>
           <p:nvPr/>
         </p:nvSpPr>
         <p:spPr>
           <a:xfrm>
-            <a:off x="822960" y="3840480"/>
-            <a:ext cx="10545775" cy="640080"/>
+            <a:off x="3017520" y="3076122"/>
+            <a:ext cx="8122615" cy="378642"/>
           </a:xfrm>
           <a:prstGeom prst="rect">
             <a:avLst/>
@@ -7408,35 +8294,35 @@
           <a:p>
             <a:pPr algn="l">
               <a:lnSpc>
-                <a:spcPct val="110000"/>
+                <a:spcPct val="112000"/>
               </a:lnSpc>
             </a:pPr>
             <a:r>
-              <a:rPr sz="3400" b="0">
+              <a:rPr sz="2200" b="0">
                 <a:solidFill>
                   <a:srgbClr val="111111"/>
                 </a:solidFill>
                 <a:latin typeface="Inter"/>
               </a:rPr>
-              <a:t>The Wall only moves forward, so combine first.</a:t>
-            </a:r>
-          </a:p>
-        </p:txBody>
-      </p:sp>
-      <p:sp>
-        <p:nvSpPr>
-          <p:cNvPr id="7" name="Rounded Rectangle 6"/>
+              <a:t>gives a straight history with no merge commit.</a:t>
+            </a:r>
+          </a:p>
+        </p:txBody>
+      </p:sp>
+      <p:sp>
+        <p:nvSpPr>
+          <p:cNvPr id="11" name="Rounded Rectangle 10"/>
           <p:cNvSpPr/>
           <p:nvPr/>
         </p:nvSpPr>
         <p:spPr>
           <a:xfrm>
-            <a:off x="822960" y="5029200"/>
-            <a:ext cx="10545775" cy="1005840"/>
+            <a:off x="822960" y="3665076"/>
+            <a:ext cx="10545775" cy="1779219"/>
           </a:xfrm>
           <a:prstGeom prst="roundRect">
             <a:avLst>
-              <a:gd name="adj" fmla="val 20000"/>
+              <a:gd name="adj" fmla="val 12000"/>
             </a:avLst>
           </a:prstGeom>
           <a:solidFill>
@@ -7455,14 +8341,14 @@
       </p:sp>
       <p:sp>
         <p:nvSpPr>
-          <p:cNvPr id="8" name="TextBox 7"/>
+          <p:cNvPr id="12" name="TextBox 11"/>
           <p:cNvSpPr txBox="1"/>
           <p:nvPr/>
         </p:nvSpPr>
         <p:spPr>
           <a:xfrm>
-            <a:off x="1188720" y="5193792"/>
-            <a:ext cx="9814255" cy="274320"/>
+            <a:off x="1051560" y="3940158"/>
+            <a:ext cx="1645920" cy="274320"/>
           </a:xfrm>
           <a:prstGeom prst="rect">
             <a:avLst/>
@@ -7479,27 +8365,27 @@
               </a:lnSpc>
             </a:pPr>
             <a:r>
-              <a:rPr sz="1300" b="1">
+              <a:rPr sz="1400" b="1">
                 <a:solidFill>
                   <a:srgbClr val="8B3DFF"/>
                 </a:solidFill>
                 <a:latin typeface="Inter"/>
               </a:rPr>
-              <a:t>BEHIND THE DOOR</a:t>
-            </a:r>
-          </a:p>
-        </p:txBody>
-      </p:sp>
-      <p:sp>
-        <p:nvSpPr>
-          <p:cNvPr id="9" name="TextBox 8"/>
+              <a:t>HOW GIT DOES IT</a:t>
+            </a:r>
+          </a:p>
+        </p:txBody>
+      </p:sp>
+      <p:sp>
+        <p:nvSpPr>
+          <p:cNvPr id="13" name="TextBox 12"/>
           <p:cNvSpPr txBox="1"/>
           <p:nvPr/>
         </p:nvSpPr>
         <p:spPr>
           <a:xfrm>
-            <a:off x="1188720" y="5486400"/>
-            <a:ext cx="9814255" cy="365760"/>
+            <a:off x="3017520" y="3866244"/>
+            <a:ext cx="8122615" cy="1376883"/>
           </a:xfrm>
           <a:prstGeom prst="rect">
             <a:avLst/>
@@ -7512,17 +8398,17 @@
           <a:p>
             <a:pPr algn="l">
               <a:lnSpc>
-                <a:spcPct val="110000"/>
+                <a:spcPct val="112000"/>
               </a:lnSpc>
             </a:pPr>
             <a:r>
-              <a:rPr sz="1700" b="0">
+              <a:rPr sz="2000" b="0">
                 <a:solidFill>
                   <a:srgbClr val="111111"/>
                 </a:solidFill>
-                <a:latin typeface="Noto Sans Mono"/>
-              </a:rPr>
-              <a:t>push: fast-forward only, else ! [rejected] · pull = fetch + merge</a:t>
+                <a:latin typeface="Inter"/>
+              </a:rPr>
+              <a:t>for each of your commits, Git applies its change to the new base and writes a new commit. The new parent gives it a new ID. Author and author date are kept. The originals become unreachable and stay in your reflog for a while.</a:t>
             </a:r>
           </a:p>
         </p:txBody>
@@ -7561,7 +8447,7 @@
         </p:nvSpPr>
         <p:spPr>
           <a:xfrm>
-            <a:off x="822960" y="594360"/>
+            <a:off x="822960" y="502920"/>
             <a:ext cx="1344168" cy="457200"/>
           </a:xfrm>
           <a:prstGeom prst="roundRect">
@@ -7589,7 +8475,7 @@
                 </a:solidFill>
                 <a:latin typeface="Inter"/>
               </a:rPr>
-              <a:t>STEP 6</a:t>
+              <a:t>STEP 5</a:t>
             </a:r>
           </a:p>
         </p:txBody>
@@ -7602,7 +8488,7 @@
         </p:nvSpPr>
         <p:spPr>
           <a:xfrm>
-            <a:off x="2423160" y="594360"/>
+            <a:off x="2441448" y="502920"/>
             <a:ext cx="8229600" cy="457200"/>
           </a:xfrm>
           <a:prstGeom prst="rect">
@@ -7639,8 +8525,74 @@
         </p:nvSpPr>
         <p:spPr>
           <a:xfrm>
-            <a:off x="822960" y="1280160"/>
-            <a:ext cx="10545775" cy="822960"/>
+            <a:off x="822960" y="1143000"/>
+            <a:ext cx="10545775" cy="914400"/>
+          </a:xfrm>
+          <a:prstGeom prst="rect">
+            <a:avLst/>
+          </a:prstGeom>
+          <a:noFill/>
+        </p:spPr>
+        <p:txBody>
+          <a:bodyPr wrap="square" anchor="b" lIns="0" rIns="0" tIns="0" bIns="0"/>
+          <a:lstStyle/>
+          <a:p>
+            <a:pPr algn="l">
+              <a:lnSpc>
+                <a:spcPct val="100000"/>
+              </a:lnSpc>
+            </a:pPr>
+            <a:r>
+              <a:rPr sz="6100" b="1">
+                <a:solidFill>
+                  <a:srgbClr val="8B3DFF"/>
+                </a:solidFill>
+                <a:latin typeface="Noto Sans Mono"/>
+              </a:rPr>
+              <a:t>git revert / git reset</a:t>
+            </a:r>
+          </a:p>
+        </p:txBody>
+      </p:sp>
+      <p:sp>
+        <p:nvSpPr>
+          <p:cNvPr id="5" name="Rectangle 4"/>
+          <p:cNvSpPr/>
+          <p:nvPr/>
+        </p:nvSpPr>
+        <p:spPr>
+          <a:xfrm>
+            <a:off x="822960" y="2286000"/>
+            <a:ext cx="10545775" cy="12700"/>
+          </a:xfrm>
+          <a:prstGeom prst="rect">
+            <a:avLst/>
+          </a:prstGeom>
+          <a:solidFill>
+            <a:srgbClr val="D9D9DE"/>
+          </a:solidFill>
+          <a:ln>
+            <a:noFill/>
+          </a:ln>
+        </p:spPr>
+        <p:txBody>
+          <a:bodyPr rtlCol="0" anchor="ctr"/>
+          <a:lstStyle/>
+          <a:p>
+            <a:pPr algn="ctr"/>
+          </a:p>
+        </p:txBody>
+      </p:sp>
+      <p:sp>
+        <p:nvSpPr>
+          <p:cNvPr id="6" name="TextBox 5"/>
+          <p:cNvSpPr txBox="1"/>
+          <p:nvPr/>
+        </p:nvSpPr>
+        <p:spPr>
+          <a:xfrm>
+            <a:off x="1051560" y="2521712"/>
+            <a:ext cx="1645920" cy="274320"/>
           </a:xfrm>
           <a:prstGeom prst="rect">
             <a:avLst/>
@@ -7657,27 +8609,27 @@
               </a:lnSpc>
             </a:pPr>
             <a:r>
-              <a:rPr sz="2400" b="0" i="1">
+              <a:rPr sz="1400" b="1">
                 <a:solidFill>
                   <a:srgbClr val="707078"/>
                 </a:solidFill>
                 <a:latin typeface="Inter"/>
               </a:rPr>
-              <a:t>Why is adding a fix card safe, but moving back is not?</a:t>
-            </a:r>
-          </a:p>
-        </p:txBody>
-      </p:sp>
-      <p:sp>
-        <p:nvSpPr>
-          <p:cNvPr id="5" name="TextBox 4"/>
+              <a:t>WHAT IT IS</a:t>
+            </a:r>
+          </a:p>
+        </p:txBody>
+      </p:sp>
+      <p:sp>
+        <p:nvSpPr>
+          <p:cNvPr id="7" name="TextBox 6"/>
           <p:cNvSpPr txBox="1"/>
           <p:nvPr/>
         </p:nvSpPr>
         <p:spPr>
           <a:xfrm>
-            <a:off x="822960" y="2011680"/>
-            <a:ext cx="10545775" cy="1371600"/>
+            <a:off x="3017520" y="2423160"/>
+            <a:ext cx="8122615" cy="378642"/>
           </a:xfrm>
           <a:prstGeom prst="rect">
             <a:avLst/>
@@ -7685,7 +8637,73 @@
           <a:noFill/>
         </p:spPr>
         <p:txBody>
-          <a:bodyPr wrap="square" anchor="ctr" lIns="0" rIns="0" tIns="0" bIns="0"/>
+          <a:bodyPr wrap="square" anchor="t" lIns="0" rIns="0" tIns="0" bIns="0"/>
+          <a:lstStyle/>
+          <a:p>
+            <a:pPr algn="l">
+              <a:lnSpc>
+                <a:spcPct val="112000"/>
+              </a:lnSpc>
+            </a:pPr>
+            <a:r>
+              <a:rPr sz="2200" b="0">
+                <a:solidFill>
+                  <a:srgbClr val="111111"/>
+                </a:solidFill>
+                <a:latin typeface="Inter"/>
+              </a:rPr>
+              <a:t>two kinds of undo.</a:t>
+            </a:r>
+          </a:p>
+        </p:txBody>
+      </p:sp>
+      <p:sp>
+        <p:nvSpPr>
+          <p:cNvPr id="8" name="Rectangle 7"/>
+          <p:cNvSpPr/>
+          <p:nvPr/>
+        </p:nvSpPr>
+        <p:spPr>
+          <a:xfrm>
+            <a:off x="822960" y="2938962"/>
+            <a:ext cx="10545775" cy="12700"/>
+          </a:xfrm>
+          <a:prstGeom prst="rect">
+            <a:avLst/>
+          </a:prstGeom>
+          <a:solidFill>
+            <a:srgbClr val="D9D9DE"/>
+          </a:solidFill>
+          <a:ln>
+            <a:noFill/>
+          </a:ln>
+        </p:spPr>
+        <p:txBody>
+          <a:bodyPr rtlCol="0" anchor="ctr"/>
+          <a:lstStyle/>
+          <a:p>
+            <a:pPr algn="ctr"/>
+          </a:p>
+        </p:txBody>
+      </p:sp>
+      <p:sp>
+        <p:nvSpPr>
+          <p:cNvPr id="9" name="TextBox 8"/>
+          <p:cNvSpPr txBox="1"/>
+          <p:nvPr/>
+        </p:nvSpPr>
+        <p:spPr>
+          <a:xfrm>
+            <a:off x="1051560" y="3174674"/>
+            <a:ext cx="1645920" cy="274320"/>
+          </a:xfrm>
+          <a:prstGeom prst="rect">
+            <a:avLst/>
+          </a:prstGeom>
+          <a:noFill/>
+        </p:spPr>
+        <p:txBody>
+          <a:bodyPr wrap="square" anchor="t" lIns="0" rIns="0" tIns="0" bIns="0"/>
           <a:lstStyle/>
           <a:p>
             <a:pPr algn="l">
@@ -7694,27 +8712,27 @@
               </a:lnSpc>
             </a:pPr>
             <a:r>
-              <a:rPr sz="9600" b="1">
-                <a:solidFill>
-                  <a:srgbClr val="8B3DFF"/>
-                </a:solidFill>
-                <a:latin typeface="Noto Sans Mono"/>
-              </a:rPr>
-              <a:t>git revert</a:t>
-            </a:r>
-          </a:p>
-        </p:txBody>
-      </p:sp>
-      <p:sp>
-        <p:nvSpPr>
-          <p:cNvPr id="6" name="TextBox 5"/>
+              <a:rPr sz="1400" b="1">
+                <a:solidFill>
+                  <a:srgbClr val="707078"/>
+                </a:solidFill>
+                <a:latin typeface="Inter"/>
+              </a:rPr>
+              <a:t>WHAT IT DOES</a:t>
+            </a:r>
+          </a:p>
+        </p:txBody>
+      </p:sp>
+      <p:sp>
+        <p:nvSpPr>
+          <p:cNvPr id="10" name="TextBox 9"/>
           <p:cNvSpPr txBox="1"/>
           <p:nvPr/>
         </p:nvSpPr>
         <p:spPr>
           <a:xfrm>
-            <a:off x="822960" y="3840480"/>
-            <a:ext cx="10545775" cy="640080"/>
+            <a:off x="3017520" y="3076122"/>
+            <a:ext cx="8122615" cy="1135928"/>
           </a:xfrm>
           <a:prstGeom prst="rect">
             <a:avLst/>
@@ -7727,35 +8745,35 @@
           <a:p>
             <a:pPr algn="l">
               <a:lnSpc>
-                <a:spcPct val="110000"/>
+                <a:spcPct val="112000"/>
               </a:lnSpc>
             </a:pPr>
             <a:r>
-              <a:rPr sz="3400" b="0">
+              <a:rPr sz="2200" b="0">
                 <a:solidFill>
                   <a:srgbClr val="111111"/>
                 </a:solidFill>
                 <a:latin typeface="Inter"/>
               </a:rPr>
-              <a:t>Don't rip out a shared card; add a fix card.</a:t>
-            </a:r>
-          </a:p>
-        </p:txBody>
-      </p:sp>
-      <p:sp>
-        <p:nvSpPr>
-          <p:cNvPr id="7" name="Rounded Rectangle 6"/>
+              <a:t>revert adds a commit that undoes an old one, and is safe on shared history. reset moves your branch label back, and is only safe if nobody else has those commits.</a:t>
+            </a:r>
+          </a:p>
+        </p:txBody>
+      </p:sp>
+      <p:sp>
+        <p:nvSpPr>
+          <p:cNvPr id="11" name="Rounded Rectangle 10"/>
           <p:cNvSpPr/>
           <p:nvPr/>
         </p:nvSpPr>
         <p:spPr>
           <a:xfrm>
-            <a:off x="822960" y="5029200"/>
-            <a:ext cx="10545775" cy="1005840"/>
+            <a:off x="822960" y="4422362"/>
+            <a:ext cx="10545775" cy="1779219"/>
           </a:xfrm>
           <a:prstGeom prst="roundRect">
             <a:avLst>
-              <a:gd name="adj" fmla="val 20000"/>
+              <a:gd name="adj" fmla="val 12000"/>
             </a:avLst>
           </a:prstGeom>
           <a:solidFill>
@@ -7774,14 +8792,14 @@
       </p:sp>
       <p:sp>
         <p:nvSpPr>
-          <p:cNvPr id="8" name="TextBox 7"/>
+          <p:cNvPr id="12" name="TextBox 11"/>
           <p:cNvSpPr txBox="1"/>
           <p:nvPr/>
         </p:nvSpPr>
         <p:spPr>
           <a:xfrm>
-            <a:off x="1188720" y="5193792"/>
-            <a:ext cx="9814255" cy="274320"/>
+            <a:off x="1051560" y="4697444"/>
+            <a:ext cx="1645920" cy="274320"/>
           </a:xfrm>
           <a:prstGeom prst="rect">
             <a:avLst/>
@@ -7798,27 +8816,27 @@
               </a:lnSpc>
             </a:pPr>
             <a:r>
-              <a:rPr sz="1300" b="1">
+              <a:rPr sz="1400" b="1">
                 <a:solidFill>
                   <a:srgbClr val="8B3DFF"/>
                 </a:solidFill>
                 <a:latin typeface="Inter"/>
               </a:rPr>
-              <a:t>BEHIND THE DOOR</a:t>
-            </a:r>
-          </a:p>
-        </p:txBody>
-      </p:sp>
-      <p:sp>
-        <p:nvSpPr>
-          <p:cNvPr id="9" name="TextBox 8"/>
+              <a:t>HOW GIT DOES IT</a:t>
+            </a:r>
+          </a:p>
+        </p:txBody>
+      </p:sp>
+      <p:sp>
+        <p:nvSpPr>
+          <p:cNvPr id="13" name="TextBox 12"/>
           <p:cNvSpPr txBox="1"/>
           <p:nvPr/>
         </p:nvSpPr>
         <p:spPr>
           <a:xfrm>
-            <a:off x="1188720" y="5486400"/>
-            <a:ext cx="9814255" cy="365760"/>
+            <a:off x="3017520" y="4623530"/>
+            <a:ext cx="8122615" cy="1376883"/>
           </a:xfrm>
           <a:prstGeom prst="rect">
             <a:avLst/>
@@ -7831,17 +8849,17 @@
           <a:p>
             <a:pPr algn="l">
               <a:lnSpc>
-                <a:spcPct val="110000"/>
+                <a:spcPct val="112000"/>
               </a:lnSpc>
             </a:pPr>
             <a:r>
-              <a:rPr sz="1700" b="0">
+              <a:rPr sz="2000" b="0">
                 <a:solidFill>
                   <a:srgbClr val="111111"/>
                 </a:solidFill>
-                <a:latin typeface="Noto Sans Mono"/>
-              </a:rPr>
-              <a:t>revert adds an inverse commit · reset moves the branch · reflog logs it</a:t>
+                <a:latin typeface="Inter"/>
+              </a:rPr>
+              <a:t>revert applies the opposite of the commit's change and commits it on top, so history only grows. reset rewrites the branch file. The commits left behind are still listed in the reflog (a local log of where each label pointed) until they expire and gc removes them.</a:t>
             </a:r>
           </a:p>
         </p:txBody>
@@ -7880,7 +8898,7 @@
         </p:nvSpPr>
         <p:spPr>
           <a:xfrm>
-            <a:off x="822960" y="594360"/>
+            <a:off x="822960" y="502920"/>
             <a:ext cx="1344168" cy="457200"/>
           </a:xfrm>
           <a:prstGeom prst="roundRect">
@@ -7908,7 +8926,7 @@
                 </a:solidFill>
                 <a:latin typeface="Inter"/>
               </a:rPr>
-              <a:t>STEP 7</a:t>
+              <a:t>STEP 6</a:t>
             </a:r>
           </a:p>
         </p:txBody>
@@ -7921,7 +8939,7 @@
         </p:nvSpPr>
         <p:spPr>
           <a:xfrm>
-            <a:off x="2423160" y="594360"/>
+            <a:off x="2441448" y="502920"/>
             <a:ext cx="8229600" cy="457200"/>
           </a:xfrm>
           <a:prstGeom prst="rect">
@@ -7958,8 +8976,74 @@
         </p:nvSpPr>
         <p:spPr>
           <a:xfrm>
-            <a:off x="822960" y="1280160"/>
-            <a:ext cx="10545775" cy="822960"/>
+            <a:off x="822960" y="1143000"/>
+            <a:ext cx="10545775" cy="914400"/>
+          </a:xfrm>
+          <a:prstGeom prst="rect">
+            <a:avLst/>
+          </a:prstGeom>
+          <a:noFill/>
+        </p:spPr>
+        <p:txBody>
+          <a:bodyPr wrap="square" anchor="b" lIns="0" rIns="0" tIns="0" bIns="0"/>
+          <a:lstStyle/>
+          <a:p>
+            <a:pPr algn="l">
+              <a:lnSpc>
+                <a:spcPct val="100000"/>
+              </a:lnSpc>
+            </a:pPr>
+            <a:r>
+              <a:rPr sz="5300" b="1">
+                <a:solidFill>
+                  <a:srgbClr val="8B3DFF"/>
+                </a:solidFill>
+                <a:latin typeface="Noto Sans Mono"/>
+              </a:rPr>
+              <a:t>Squash + git push --force</a:t>
+            </a:r>
+          </a:p>
+        </p:txBody>
+      </p:sp>
+      <p:sp>
+        <p:nvSpPr>
+          <p:cNvPr id="5" name="Rectangle 4"/>
+          <p:cNvSpPr/>
+          <p:nvPr/>
+        </p:nvSpPr>
+        <p:spPr>
+          <a:xfrm>
+            <a:off x="822960" y="2286000"/>
+            <a:ext cx="10545775" cy="12700"/>
+          </a:xfrm>
+          <a:prstGeom prst="rect">
+            <a:avLst/>
+          </a:prstGeom>
+          <a:solidFill>
+            <a:srgbClr val="D9D9DE"/>
+          </a:solidFill>
+          <a:ln>
+            <a:noFill/>
+          </a:ln>
+        </p:spPr>
+        <p:txBody>
+          <a:bodyPr rtlCol="0" anchor="ctr"/>
+          <a:lstStyle/>
+          <a:p>
+            <a:pPr algn="ctr"/>
+          </a:p>
+        </p:txBody>
+      </p:sp>
+      <p:sp>
+        <p:nvSpPr>
+          <p:cNvPr id="6" name="TextBox 5"/>
+          <p:cNvSpPr txBox="1"/>
+          <p:nvPr/>
+        </p:nvSpPr>
+        <p:spPr>
+          <a:xfrm>
+            <a:off x="1051560" y="2521712"/>
+            <a:ext cx="1645920" cy="274320"/>
           </a:xfrm>
           <a:prstGeom prst="rect">
             <a:avLst/>
@@ -7976,27 +9060,27 @@
               </a:lnSpc>
             </a:pPr>
             <a:r>
-              <a:rPr sz="2400" b="0" i="1">
+              <a:rPr sz="1400" b="1">
                 <a:solidFill>
                   <a:srgbClr val="707078"/>
                 </a:solidFill>
                 <a:latin typeface="Inter"/>
               </a:rPr>
-              <a:t>Who added the tentacles? Where does that answer still exist?</a:t>
-            </a:r>
-          </a:p>
-        </p:txBody>
-      </p:sp>
-      <p:sp>
-        <p:nvSpPr>
-          <p:cNvPr id="5" name="TextBox 4"/>
+              <a:t>WHAT IT IS</a:t>
+            </a:r>
+          </a:p>
+        </p:txBody>
+      </p:sp>
+      <p:sp>
+        <p:nvSpPr>
+          <p:cNvPr id="7" name="TextBox 6"/>
           <p:cNvSpPr txBox="1"/>
           <p:nvPr/>
         </p:nvSpPr>
         <p:spPr>
           <a:xfrm>
-            <a:off x="822960" y="2011680"/>
-            <a:ext cx="10545775" cy="1371600"/>
+            <a:off x="3017520" y="2423160"/>
+            <a:ext cx="8122615" cy="378642"/>
           </a:xfrm>
           <a:prstGeom prst="rect">
             <a:avLst/>
@@ -8004,7 +9088,73 @@
           <a:noFill/>
         </p:spPr>
         <p:txBody>
-          <a:bodyPr wrap="square" anchor="ctr" lIns="0" rIns="0" tIns="0" bIns="0"/>
+          <a:bodyPr wrap="square" anchor="t" lIns="0" rIns="0" tIns="0" bIns="0"/>
+          <a:lstStyle/>
+          <a:p>
+            <a:pPr algn="l">
+              <a:lnSpc>
+                <a:spcPct val="112000"/>
+              </a:lnSpc>
+            </a:pPr>
+            <a:r>
+              <a:rPr sz="2200" b="0">
+                <a:solidFill>
+                  <a:srgbClr val="111111"/>
+                </a:solidFill>
+                <a:latin typeface="Inter"/>
+              </a:rPr>
+              <a:t>cleaning up history.</a:t>
+            </a:r>
+          </a:p>
+        </p:txBody>
+      </p:sp>
+      <p:sp>
+        <p:nvSpPr>
+          <p:cNvPr id="8" name="Rectangle 7"/>
+          <p:cNvSpPr/>
+          <p:nvPr/>
+        </p:nvSpPr>
+        <p:spPr>
+          <a:xfrm>
+            <a:off x="822960" y="2938962"/>
+            <a:ext cx="10545775" cy="12700"/>
+          </a:xfrm>
+          <a:prstGeom prst="rect">
+            <a:avLst/>
+          </a:prstGeom>
+          <a:solidFill>
+            <a:srgbClr val="D9D9DE"/>
+          </a:solidFill>
+          <a:ln>
+            <a:noFill/>
+          </a:ln>
+        </p:spPr>
+        <p:txBody>
+          <a:bodyPr rtlCol="0" anchor="ctr"/>
+          <a:lstStyle/>
+          <a:p>
+            <a:pPr algn="ctr"/>
+          </a:p>
+        </p:txBody>
+      </p:sp>
+      <p:sp>
+        <p:nvSpPr>
+          <p:cNvPr id="9" name="TextBox 8"/>
+          <p:cNvSpPr txBox="1"/>
+          <p:nvPr/>
+        </p:nvSpPr>
+        <p:spPr>
+          <a:xfrm>
+            <a:off x="1051560" y="3174674"/>
+            <a:ext cx="1645920" cy="274320"/>
+          </a:xfrm>
+          <a:prstGeom prst="rect">
+            <a:avLst/>
+          </a:prstGeom>
+          <a:noFill/>
+        </p:spPr>
+        <p:txBody>
+          <a:bodyPr wrap="square" anchor="t" lIns="0" rIns="0" tIns="0" bIns="0"/>
           <a:lstStyle/>
           <a:p>
             <a:pPr algn="l">
@@ -8013,27 +9163,27 @@
               </a:lnSpc>
             </a:pPr>
             <a:r>
-              <a:rPr sz="8300" b="1">
-                <a:solidFill>
-                  <a:srgbClr val="8B3DFF"/>
-                </a:solidFill>
-                <a:latin typeface="Noto Sans Mono"/>
-              </a:rPr>
-              <a:t>git push --force</a:t>
-            </a:r>
-          </a:p>
-        </p:txBody>
-      </p:sp>
-      <p:sp>
-        <p:nvSpPr>
-          <p:cNvPr id="6" name="TextBox 5"/>
+              <a:rPr sz="1400" b="1">
+                <a:solidFill>
+                  <a:srgbClr val="707078"/>
+                </a:solidFill>
+                <a:latin typeface="Inter"/>
+              </a:rPr>
+              <a:t>WHAT IT DOES</a:t>
+            </a:r>
+          </a:p>
+        </p:txBody>
+      </p:sp>
+      <p:sp>
+        <p:nvSpPr>
+          <p:cNvPr id="10" name="TextBox 9"/>
           <p:cNvSpPr txBox="1"/>
           <p:nvPr/>
         </p:nvSpPr>
         <p:spPr>
           <a:xfrm>
-            <a:off x="822960" y="3840480"/>
-            <a:ext cx="10545775" cy="640080"/>
+            <a:off x="3017520" y="3076122"/>
+            <a:ext cx="8122615" cy="757285"/>
           </a:xfrm>
           <a:prstGeom prst="rect">
             <a:avLst/>
@@ -8046,35 +9196,35 @@
           <a:p>
             <a:pPr algn="l">
               <a:lnSpc>
-                <a:spcPct val="110000"/>
+                <a:spcPct val="112000"/>
               </a:lnSpc>
             </a:pPr>
             <a:r>
-              <a:rPr sz="3400" b="0">
+              <a:rPr sz="2200" b="0">
                 <a:solidFill>
                   <a:srgbClr val="111111"/>
                 </a:solidFill>
                 <a:latin typeface="Inter"/>
               </a:rPr>
-              <a:t>Force the Wall, and it forgets who did what.</a:t>
-            </a:r>
-          </a:p>
-        </p:txBody>
-      </p:sp>
-      <p:sp>
-        <p:nvSpPr>
-          <p:cNvPr id="7" name="Rounded Rectangle 6"/>
+              <a:t>squash turns several commits into one. Force push makes the Wall accept it anyway.</a:t>
+            </a:r>
+          </a:p>
+        </p:txBody>
+      </p:sp>
+      <p:sp>
+        <p:nvSpPr>
+          <p:cNvPr id="11" name="Rounded Rectangle 10"/>
           <p:cNvSpPr/>
           <p:nvPr/>
         </p:nvSpPr>
         <p:spPr>
           <a:xfrm>
-            <a:off x="822960" y="5029200"/>
-            <a:ext cx="10545775" cy="1005840"/>
+            <a:off x="822960" y="4043719"/>
+            <a:ext cx="10545775" cy="1779219"/>
           </a:xfrm>
           <a:prstGeom prst="roundRect">
             <a:avLst>
-              <a:gd name="adj" fmla="val 20000"/>
+              <a:gd name="adj" fmla="val 12000"/>
             </a:avLst>
           </a:prstGeom>
           <a:solidFill>
@@ -8093,14 +9243,14 @@
       </p:sp>
       <p:sp>
         <p:nvSpPr>
-          <p:cNvPr id="8" name="TextBox 7"/>
+          <p:cNvPr id="12" name="TextBox 11"/>
           <p:cNvSpPr txBox="1"/>
           <p:nvPr/>
         </p:nvSpPr>
         <p:spPr>
           <a:xfrm>
-            <a:off x="1188720" y="5193792"/>
-            <a:ext cx="9814255" cy="274320"/>
+            <a:off x="1051560" y="4318801"/>
+            <a:ext cx="1645920" cy="274320"/>
           </a:xfrm>
           <a:prstGeom prst="rect">
             <a:avLst/>
@@ -8117,27 +9267,27 @@
               </a:lnSpc>
             </a:pPr>
             <a:r>
-              <a:rPr sz="1300" b="1">
+              <a:rPr sz="1400" b="1">
                 <a:solidFill>
                   <a:srgbClr val="8B3DFF"/>
                 </a:solidFill>
                 <a:latin typeface="Inter"/>
               </a:rPr>
-              <a:t>BEHIND THE DOOR</a:t>
-            </a:r>
-          </a:p>
-        </p:txBody>
-      </p:sp>
-      <p:sp>
-        <p:nvSpPr>
-          <p:cNvPr id="9" name="TextBox 8"/>
+              <a:t>HOW GIT DOES IT</a:t>
+            </a:r>
+          </a:p>
+        </p:txBody>
+      </p:sp>
+      <p:sp>
+        <p:nvSpPr>
+          <p:cNvPr id="13" name="TextBox 12"/>
           <p:cNvSpPr txBox="1"/>
           <p:nvPr/>
         </p:nvSpPr>
         <p:spPr>
           <a:xfrm>
-            <a:off x="1188720" y="5486400"/>
-            <a:ext cx="9814255" cy="365760"/>
+            <a:off x="3017520" y="4244887"/>
+            <a:ext cx="8122615" cy="1376883"/>
           </a:xfrm>
           <a:prstGeom prst="rect">
             <a:avLst/>
@@ -8150,17 +9300,53 @@
           <a:p>
             <a:pPr algn="l">
               <a:lnSpc>
-                <a:spcPct val="110000"/>
+                <a:spcPct val="112000"/>
               </a:lnSpc>
             </a:pPr>
             <a:r>
-              <a:rPr sz="1700" b="0">
+              <a:rPr sz="2000" b="0">
                 <a:solidFill>
                   <a:srgbClr val="111111"/>
                 </a:solidFill>
+                <a:latin typeface="Inter"/>
+              </a:rPr>
+              <a:t>squash writes one new commit whose tree is the final state. The originals, with their authors and times, become unreachable. </a:t>
+            </a:r>
+            <a:r>
+              <a:rPr sz="2000" b="0">
+                <a:solidFill>
+                  <a:srgbClr val="111111"/>
+                </a:solidFill>
                 <a:latin typeface="Noto Sans Mono"/>
               </a:rPr>
-              <a:t>squash: new ID · --force: no fast-forward check · gc: old commits gone</a:t>
+              <a:t>-⁠-⁠force</a:t>
+            </a:r>
+            <a:r>
+              <a:rPr sz="2000" b="0">
+                <a:solidFill>
+                  <a:srgbClr val="111111"/>
+                </a:solidFill>
+                <a:latin typeface="Inter"/>
+              </a:rPr>
+              <a:t> skips the fast-forward check and moves the remote branch. </a:t>
+            </a:r>
+            <a:r>
+              <a:rPr sz="2000" b="0">
+                <a:solidFill>
+                  <a:srgbClr val="111111"/>
+                </a:solidFill>
+                <a:latin typeface="Noto Sans Mono"/>
+              </a:rPr>
+              <a:t>git gc</a:t>
+            </a:r>
+            <a:r>
+              <a:rPr sz="2000" b="0">
+                <a:solidFill>
+                  <a:srgbClr val="111111"/>
+                </a:solidFill>
+                <a:latin typeface="Inter"/>
+              </a:rPr>
+              <a:t> later deletes unreachable objects.</a:t>
             </a:r>
           </a:p>
         </p:txBody>

</xml_diff>

<commit_message>
Tuesday v2 and the teacher brief: predict, choose, idea-first hints
- Students predict before every merge and send; the reveal shows who was right
- Refused labs choose merge or rebase; labs choose revert or reset
- Stuck? Hint shows the idea first, the exact click second, after 45 s
- Switch refuses unsaved parts; Steps 0-1 shorter; the paper question is the
  real trade-off (squash-merge: easy bisect vs who wrote what)
- Facts: 'for analysts, flat history is data loss' with the trade-off; code
  velocity defined not measured; exit answer: everyone re-clones (tested)
- Key leaves the address bar on both days; Tuesday join links to /thu
- lesson/TEACHER_BRIEF.md: both days in 10 minutes; docs updated
- Tests: 96/96 unit; Tuesday e2e + bots rehearsal; Thursday e2e 6 and 24

Co-Authored-By: Claude Opus 5.5 <noreply@anthropic.com>
</commit_message>
<xml_diff>
--- a/slides/tuesday_app.pptx
+++ b/slides/tuesday_app.pptx
@@ -16,6 +16,7 @@
     <p:sldId id="264" r:id="rId16"/>
     <p:sldId id="265" r:id="rId17"/>
     <p:sldId id="266" r:id="rId18"/>
+    <p:sldId id="267" r:id="rId19"/>
   </p:sldIdLst>
   <p:sldSz cx="12191695" cy="6858000" type="screen4x3"/>
   <p:notesSz cx="6858000" cy="9144000"/>
@@ -582,19 +583,19 @@
           <a:lstStyle/>
           <a:p>
             <a:r>
-              <a:t>Say: You just lived this paper. Teams at Microsoft moved to Git. It measures code velocity: how long a change takes to reach main, along its integration path. After the squash, the Wall has no path left. The paper says: flat history is data loss.</a:t>
+              <a:t>Say: You just lived this paper. Teams at Microsoft moved to Git. Microsoft tracks code velocity: how long a change takes to reach main, along its integration path. After the squash, the Wall has no path left. The paper: for analysts, flat history is data loss. For developers it helps: a bad change is quick to find and revert.</a:t>
             </a:r>
           </a:p>
           <a:p/>
           <a:p>
             <a:r>
-              <a:t>Ask: You run your company's Wall. Give one rule: the boss gets a clean history, and the auditor still knows who added the boots.</a:t>
+              <a:t>Ask: Your team squash-merges every feature branch and deletes it. What do you gain, and what can an auditor no longer answer?</a:t>
             </a:r>
           </a:p>
           <a:p/>
           <a:p>
             <a:r>
-              <a:t>Hope to hear: No force push to main. Or: squash only your own branch, before you share it.</a:t>
+              <a:t>Hope to hear: Gain: one revertable card per feature, easy bisect. Lose: who wrote which part and when, once the branch is deleted.</a:t>
             </a:r>
           </a:p>
         </p:txBody>
@@ -664,6 +665,88 @@
           <a:lstStyle/>
           <a:p>
             <a:r>
+              <a:t>Say: You just lived this paper. Teams at Microsoft moved to Git. Microsoft tracks code velocity: how long a change takes to reach main, along its integration path. After the squash, the Wall has no path left. The paper: for analysts, flat history is data loss. For developers it helps: a bad change is quick to find and revert.</a:t>
+            </a:r>
+          </a:p>
+          <a:p/>
+          <a:p>
+            <a:r>
+              <a:t>Ask: Your team squash-merges every feature branch and deletes it. What do you gain, and what can an auditor no longer answer?</a:t>
+            </a:r>
+          </a:p>
+          <a:p/>
+          <a:p>
+            <a:r>
+              <a:t>Hope to hear: Gain: one revertable card per feature, easy bisect. Lose: who wrote which part and when, once the branch is deleted.</a:t>
+            </a:r>
+          </a:p>
+        </p:txBody>
+      </p:sp>
+      <p:sp>
+        <p:nvSpPr>
+          <p:cNvPr id="4" name="Slide Number Placeholder 3"/>
+          <p:cNvSpPr>
+            <a:spLocks noGrp="1"/>
+          </p:cNvSpPr>
+          <p:nvPr>
+            <p:ph type="sldNum" idx="5" sz="quarter"/>
+          </p:nvPr>
+        </p:nvSpPr>
+        <p:spPr/>
+      </p:sp>
+    </p:spTree>
+  </p:cSld>
+  <p:clrMapOvr>
+    <a:masterClrMapping/>
+  </p:clrMapOvr>
+</p:notes>
+</file>
+
+<file path=ppt/notesSlides/notesSlide12.xml><?xml version="1.0" encoding="utf-8"?>
+<p:notes xmlns:a="http://schemas.openxmlformats.org/drawingml/2006/main" xmlns:p="http://schemas.openxmlformats.org/presentationml/2006/main" xmlns:r="http://schemas.openxmlformats.org/officeDocument/2006/relationships">
+  <p:cSld>
+    <p:spTree>
+      <p:nvGrpSpPr>
+        <p:cNvPr id="1" name=""/>
+        <p:cNvGrpSpPr/>
+        <p:nvPr/>
+      </p:nvGrpSpPr>
+      <p:grpSpPr>
+        <a:xfrm>
+          <a:off x="0" y="0"/>
+          <a:ext cx="0" cy="0"/>
+          <a:chOff x="0" y="0"/>
+          <a:chExt cx="0" cy="0"/>
+        </a:xfrm>
+      </p:grpSpPr>
+      <p:sp>
+        <p:nvSpPr>
+          <p:cNvPr id="2" name="Slide Image Placeholder 1"/>
+          <p:cNvSpPr>
+            <a:spLocks noGrp="1"/>
+          </p:cNvSpPr>
+          <p:nvPr>
+            <p:ph type="sldImg" idx="2"/>
+          </p:nvPr>
+        </p:nvSpPr>
+        <p:spPr/>
+      </p:sp>
+      <p:sp>
+        <p:nvSpPr>
+          <p:cNvPr id="3" name="Notes Placeholder 2"/>
+          <p:cNvSpPr>
+            <a:spLocks noGrp="1"/>
+          </p:cNvSpPr>
+          <p:nvPr>
+            <p:ph type="body" idx="3" sz="quarter"/>
+          </p:nvPr>
+        </p:nvSpPr>
+        <p:spPr/>
+        <p:txBody>
+          <a:bodyPr/>
+          <a:lstStyle/>
+          <a:p>
+            <a:r>
               <a:t>Say: Cards never change. Sticky notes move. The Wall copies cards. That's Git. Homework: Yang et al., Sections 3.2 to 3.5. For one finding, write down what they measured.</a:t>
             </a:r>
           </a:p>
@@ -734,7 +817,7 @@
           <a:lstStyle/>
           <a:p>
             <a:r>
-              <a:t>Say: No Git lecture today. You'll hit seven problems, and your lab invents a fix for each. Every button runs real Git.</a:t>
+              <a:t>Say: No Git lecture today. You'll hit seven problems, and your lab invents a fix for each. Every save, merge, send and undo runs real Git.</a:t>
             </a:r>
           </a:p>
         </p:txBody>
@@ -1050,7 +1133,7 @@
           <a:lstStyle/>
           <a:p>
             <a:r>
-              <a:t>Say: The Wall is the class's shared copy, like GitHub. Your lab already has a full copy of it (that is git clone). It starts as the first lab's outfit. Put your outfit on the Wall. The first lab there wins.</a:t>
+              <a:t>Say: The Wall is the class's shared copy, like GitHub. Your lab already has a full copy of it (that is git clone). It starts as the first lab's outfit. Put your outfit on the Wall. Before each send, predict: will the Wall accept it?</a:t>
             </a:r>
           </a:p>
         </p:txBody>
@@ -4395,7 +4478,7 @@
                 </a:solidFill>
                 <a:latin typeface="Inter"/>
               </a:rPr>
-              <a:t>Every button runs real Git.</a:t>
+              <a:t>Every save, merge, send and undo runs real Git.</a:t>
             </a:r>
           </a:p>
         </p:txBody>
@@ -4909,7 +4992,7 @@
         <p:spPr>
           <a:xfrm>
             <a:off x="822960" y="1965960"/>
-            <a:ext cx="3271418" cy="1029328"/>
+            <a:ext cx="3271418" cy="1442393"/>
           </a:xfrm>
           <a:prstGeom prst="rect">
             <a:avLst/>
@@ -4929,7 +5012,7 @@
               </a:spcBef>
             </a:pPr>
             <a:r>
-              <a:rPr sz="1600" b="0">
+              <a:rPr sz="1800" b="0">
                 <a:solidFill>
                   <a:srgbClr val="111111"/>
                 </a:solidFill>
@@ -4948,7 +5031,7 @@
               </a:spcBef>
             </a:pPr>
             <a:r>
-              <a:rPr sz="1600" b="0">
+              <a:rPr sz="1800" b="0">
                 <a:solidFill>
                   <a:srgbClr val="111111"/>
                 </a:solidFill>
@@ -4967,7 +5050,7 @@
               </a:spcBef>
             </a:pPr>
             <a:r>
-              <a:rPr sz="1600" b="0">
+              <a:rPr sz="1800" b="0">
                 <a:solidFill>
                   <a:srgbClr val="111111"/>
                 </a:solidFill>
@@ -5053,7 +5136,7 @@
         <p:spPr>
           <a:xfrm>
             <a:off x="4460138" y="1965960"/>
-            <a:ext cx="3271418" cy="1855459"/>
+            <a:ext cx="3271418" cy="2681588"/>
           </a:xfrm>
           <a:prstGeom prst="rect">
             <a:avLst/>
@@ -5073,7 +5156,7 @@
               </a:spcBef>
             </a:pPr>
             <a:r>
-              <a:rPr sz="1600" b="0">
+              <a:rPr sz="1800" b="0">
                 <a:solidFill>
                   <a:srgbClr val="111111"/>
                 </a:solidFill>
@@ -5092,7 +5175,7 @@
               </a:spcBef>
             </a:pPr>
             <a:r>
-              <a:rPr sz="1600" b="0">
+              <a:rPr sz="1800" b="0">
                 <a:solidFill>
                   <a:srgbClr val="111111"/>
                 </a:solidFill>
@@ -5111,13 +5194,13 @@
               </a:spcBef>
             </a:pPr>
             <a:r>
-              <a:rPr sz="1600" b="0">
+              <a:rPr sz="1800" b="0">
                 <a:solidFill>
                   <a:srgbClr val="111111"/>
                 </a:solidFill>
                 <a:latin typeface="Inter"/>
               </a:rPr>
-              <a:t>Squash drops the cards, even who made them.</a:t>
+              <a:t>Squash can drop the cards — and, once the branch is deleted, even who made them.</a:t>
             </a:r>
           </a:p>
         </p:txBody>
@@ -5197,7 +5280,7 @@
         <p:spPr>
           <a:xfrm>
             <a:off x="8097316" y="1965960"/>
-            <a:ext cx="3271418" cy="1855458"/>
+            <a:ext cx="3271418" cy="2371790"/>
           </a:xfrm>
           <a:prstGeom prst="rect">
             <a:avLst/>
@@ -5217,7 +5300,7 @@
               </a:spcBef>
             </a:pPr>
             <a:r>
-              <a:rPr sz="1600" b="0">
+              <a:rPr sz="1800" b="0">
                 <a:solidFill>
                   <a:srgbClr val="111111"/>
                 </a:solidFill>
@@ -5236,7 +5319,7 @@
               </a:spcBef>
             </a:pPr>
             <a:r>
-              <a:rPr sz="1600" b="0">
+              <a:rPr sz="1800" b="0">
                 <a:solidFill>
                   <a:srgbClr val="111111"/>
                 </a:solidFill>
@@ -5255,7 +5338,7 @@
               </a:spcBef>
             </a:pPr>
             <a:r>
-              <a:rPr sz="1600" b="0">
+              <a:rPr sz="1800" b="0">
                 <a:solidFill>
                   <a:srgbClr val="111111"/>
                 </a:solidFill>
@@ -5274,8 +5357,8 @@
         </p:nvSpPr>
         <p:spPr>
           <a:xfrm>
-            <a:off x="822960" y="4095739"/>
-            <a:ext cx="10545775" cy="274320"/>
+            <a:off x="822960" y="4967588"/>
+            <a:ext cx="10545775" cy="619597"/>
           </a:xfrm>
           <a:prstGeom prst="rect">
             <a:avLst/>
@@ -5292,13 +5375,13 @@
               </a:lnSpc>
             </a:pPr>
             <a:r>
-              <a:rPr sz="1400" b="1">
-                <a:solidFill>
-                  <a:srgbClr val="707078"/>
+              <a:rPr sz="3600" b="1">
+                <a:solidFill>
+                  <a:srgbClr val="8B3DFF"/>
                 </a:solidFill>
                 <a:latin typeface="Inter"/>
               </a:rPr>
-              <a:t>WHAT YOU LIVED</a:t>
+              <a:t>For analysts, flat history is data loss.</a:t>
             </a:r>
           </a:p>
         </p:txBody>
@@ -5311,8 +5394,8 @@
         </p:nvSpPr>
         <p:spPr>
           <a:xfrm>
-            <a:off x="822960" y="4370059"/>
-            <a:ext cx="10545775" cy="1215804"/>
+            <a:off x="822960" y="5678625"/>
+            <a:ext cx="10545775" cy="688441"/>
           </a:xfrm>
           <a:prstGeom prst="rect">
             <a:avLst/>
@@ -5327,112 +5410,15 @@
               <a:lnSpc>
                 <a:spcPct val="112000"/>
               </a:lnSpc>
-              <a:spcBef>
-                <a:spcPts val="0"/>
-              </a:spcBef>
             </a:pPr>
             <a:r>
-              <a:rPr sz="1600" b="0">
+              <a:rPr sz="2000" b="0">
                 <a:solidFill>
                   <a:srgbClr val="111111"/>
                 </a:solidFill>
                 <a:latin typeface="Inter"/>
               </a:rPr>
-              <a:t>Step 3: after the fast-forward, you deleted fancy. No card says which cards were made on it.</a:t>
-            </a:r>
-          </a:p>
-          <a:p>
-            <a:pPr algn="l">
-              <a:lnSpc>
-                <a:spcPct val="112000"/>
-              </a:lnSpc>
-              <a:spcBef>
-                <a:spcPts val="300"/>
-              </a:spcBef>
-            </a:pPr>
-            <a:r>
-              <a:rPr sz="1600" b="0">
-                <a:solidFill>
-                  <a:srgbClr val="111111"/>
-                </a:solidFill>
-                <a:latin typeface="Inter"/>
-              </a:rPr>
-              <a:t>Step 4: Rebase rewrites the change and gives it a new ID. The original card is not on the Wall.</a:t>
-            </a:r>
-          </a:p>
-          <a:p>
-            <a:pPr algn="l">
-              <a:lnSpc>
-                <a:spcPct val="112000"/>
-              </a:lnSpc>
-              <a:spcBef>
-                <a:spcPts val="300"/>
-              </a:spcBef>
-            </a:pPr>
-            <a:r>
-              <a:rPr sz="1600" b="0">
-                <a:solidFill>
-                  <a:srgbClr val="111111"/>
-                </a:solidFill>
-                <a:latin typeface="Inter"/>
-              </a:rPr>
-              <a:t>Step 6: the squash dropped the cards, and who made them.</a:t>
-            </a:r>
-          </a:p>
-          <a:p>
-            <a:pPr algn="l">
-              <a:lnSpc>
-                <a:spcPct val="112000"/>
-              </a:lnSpc>
-              <a:spcBef>
-                <a:spcPts val="300"/>
-              </a:spcBef>
-            </a:pPr>
-            <a:r>
-              <a:rPr sz="1600" b="0">
-                <a:solidFill>
-                  <a:srgbClr val="111111"/>
-                </a:solidFill>
-                <a:latin typeface="Inter"/>
-              </a:rPr>
-              <a:t>Step 6: the 🥾 audit failed. The Wall no longer knows who added the boots.</a:t>
-            </a:r>
-          </a:p>
-        </p:txBody>
-      </p:sp>
-      <p:sp>
-        <p:nvSpPr>
-          <p:cNvPr id="15" name="TextBox 14"/>
-          <p:cNvSpPr txBox="1"/>
-          <p:nvPr/>
-        </p:nvSpPr>
-        <p:spPr>
-          <a:xfrm>
-            <a:off x="822960" y="5814463"/>
-            <a:ext cx="10545775" cy="548640"/>
-          </a:xfrm>
-          <a:prstGeom prst="rect">
-            <a:avLst/>
-          </a:prstGeom>
-          <a:noFill/>
-        </p:spPr>
-        <p:txBody>
-          <a:bodyPr wrap="square" anchor="t" lIns="0" rIns="0" tIns="0" bIns="0"/>
-          <a:lstStyle/>
-          <a:p>
-            <a:pPr algn="l">
-              <a:lnSpc>
-                <a:spcPct val="110000"/>
-              </a:lnSpc>
-            </a:pPr>
-            <a:r>
-              <a:rPr sz="3600" b="1">
-                <a:solidFill>
-                  <a:srgbClr val="8B3DFF"/>
-                </a:solidFill>
-                <a:latin typeface="Inter"/>
-              </a:rPr>
-              <a:t>Flat history is data loss.</a:t>
+              <a:t>Flat history helps developers find and revert a bad change (bisect, revert). It loses where a change came from and who made it.</a:t>
             </a:r>
           </a:p>
         </p:txBody>
@@ -5446,6 +5432,281 @@
 </file>
 
 <file path=ppt/slides/slide11.xml><?xml version="1.0" encoding="utf-8"?>
+<p:sld xmlns:a="http://schemas.openxmlformats.org/drawingml/2006/main" xmlns:p="http://schemas.openxmlformats.org/presentationml/2006/main" xmlns:r="http://schemas.openxmlformats.org/officeDocument/2006/relationships">
+  <p:cSld>
+    <p:bg>
+      <p:bgPr>
+        <a:solidFill>
+          <a:srgbClr val="FFFFFF"/>
+        </a:solidFill>
+        <a:effectLst/>
+      </p:bgPr>
+    </p:bg>
+    <p:spTree>
+      <p:nvGrpSpPr>
+        <p:cNvPr id="1" name=""/>
+        <p:cNvGrpSpPr/>
+        <p:nvPr/>
+      </p:nvGrpSpPr>
+      <p:grpSpPr/>
+      <p:sp>
+        <p:nvSpPr>
+          <p:cNvPr id="2" name="Rounded Rectangle 1"/>
+          <p:cNvSpPr/>
+          <p:nvPr/>
+        </p:nvSpPr>
+        <p:spPr>
+          <a:xfrm>
+            <a:off x="822960" y="502920"/>
+            <a:ext cx="1810512" cy="457200"/>
+          </a:xfrm>
+          <a:prstGeom prst="roundRect">
+            <a:avLst>
+              <a:gd name="adj" fmla="val 50000"/>
+            </a:avLst>
+          </a:prstGeom>
+          <a:solidFill>
+            <a:srgbClr val="111111"/>
+          </a:solidFill>
+          <a:ln>
+            <a:noFill/>
+          </a:ln>
+          <a:effectLst/>
+        </p:spPr>
+        <p:txBody>
+          <a:bodyPr rtlCol="0" anchor="ctr" lIns="0" rIns="0" tIns="0" bIns="0"/>
+          <a:lstStyle/>
+          <a:p>
+            <a:pPr algn="ctr"/>
+            <a:r>
+              <a:rPr sz="1800" b="1">
+                <a:solidFill>
+                  <a:srgbClr val="FFFFFF"/>
+                </a:solidFill>
+                <a:latin typeface="Inter"/>
+              </a:rPr>
+              <a:t>THE PAPER</a:t>
+            </a:r>
+          </a:p>
+        </p:txBody>
+      </p:sp>
+      <p:sp>
+        <p:nvSpPr>
+          <p:cNvPr id="3" name="TextBox 2"/>
+          <p:cNvSpPr txBox="1"/>
+          <p:nvPr/>
+        </p:nvSpPr>
+        <p:spPr>
+          <a:xfrm>
+            <a:off x="2907792" y="502920"/>
+            <a:ext cx="8229600" cy="457200"/>
+          </a:xfrm>
+          <a:prstGeom prst="rect">
+            <a:avLst/>
+          </a:prstGeom>
+          <a:noFill/>
+        </p:spPr>
+        <p:txBody>
+          <a:bodyPr wrap="square" anchor="ctr" lIns="0" rIns="0" tIns="0" bIns="0"/>
+          <a:lstStyle/>
+          <a:p>
+            <a:pPr algn="l">
+              <a:lnSpc>
+                <a:spcPct val="110000"/>
+              </a:lnSpc>
+            </a:pPr>
+            <a:r>
+              <a:rPr sz="2400" b="1">
+                <a:solidFill>
+                  <a:srgbClr val="111111"/>
+                </a:solidFill>
+                <a:latin typeface="Inter"/>
+              </a:rPr>
+              <a:t>What you lived</a:t>
+            </a:r>
+          </a:p>
+        </p:txBody>
+      </p:sp>
+      <p:sp>
+        <p:nvSpPr>
+          <p:cNvPr id="4" name="TextBox 3"/>
+          <p:cNvSpPr txBox="1"/>
+          <p:nvPr/>
+        </p:nvSpPr>
+        <p:spPr>
+          <a:xfrm>
+            <a:off x="822960" y="1371600"/>
+            <a:ext cx="10545775" cy="2652854"/>
+          </a:xfrm>
+          <a:prstGeom prst="rect">
+            <a:avLst/>
+          </a:prstGeom>
+          <a:noFill/>
+        </p:spPr>
+        <p:txBody>
+          <a:bodyPr wrap="square" anchor="t" lIns="0" rIns="0" tIns="0" bIns="0"/>
+          <a:lstStyle/>
+          <a:p>
+            <a:pPr algn="l">
+              <a:lnSpc>
+                <a:spcPct val="112000"/>
+              </a:lnSpc>
+              <a:spcBef>
+                <a:spcPts val="0"/>
+              </a:spcBef>
+            </a:pPr>
+            <a:r>
+              <a:rPr sz="2200" b="0">
+                <a:solidFill>
+                  <a:srgbClr val="111111"/>
+                </a:solidFill>
+                <a:latin typeface="Inter"/>
+              </a:rPr>
+              <a:t>Step 3: after the fast-forward, you deleted fancy. No card says which cards were made on it.</a:t>
+            </a:r>
+          </a:p>
+          <a:p>
+            <a:pPr algn="l">
+              <a:lnSpc>
+                <a:spcPct val="112000"/>
+              </a:lnSpc>
+              <a:spcBef>
+                <a:spcPts val="1000"/>
+              </a:spcBef>
+            </a:pPr>
+            <a:r>
+              <a:rPr sz="2200" b="0">
+                <a:solidFill>
+                  <a:srgbClr val="111111"/>
+                </a:solidFill>
+                <a:latin typeface="Inter"/>
+              </a:rPr>
+              <a:t>Step 4: Replay on top made a copy with a new ID; the original card is not on the Wall.</a:t>
+            </a:r>
+          </a:p>
+          <a:p>
+            <a:pPr algn="l">
+              <a:lnSpc>
+                <a:spcPct val="112000"/>
+              </a:lnSpc>
+              <a:spcBef>
+                <a:spcPts val="1000"/>
+              </a:spcBef>
+            </a:pPr>
+            <a:r>
+              <a:rPr sz="2200" b="0">
+                <a:solidFill>
+                  <a:srgbClr val="111111"/>
+                </a:solidFill>
+                <a:latin typeface="Inter"/>
+              </a:rPr>
+              <a:t>Step 6: the squash dropped the cards, and who made them.</a:t>
+            </a:r>
+          </a:p>
+          <a:p>
+            <a:pPr algn="l">
+              <a:lnSpc>
+                <a:spcPct val="112000"/>
+              </a:lnSpc>
+              <a:spcBef>
+                <a:spcPts val="1000"/>
+              </a:spcBef>
+            </a:pPr>
+            <a:r>
+              <a:rPr sz="2200" b="0">
+                <a:solidFill>
+                  <a:srgbClr val="111111"/>
+                </a:solidFill>
+                <a:latin typeface="Inter"/>
+              </a:rPr>
+              <a:t>Step 6: the 🥾 audit failed. The Wall no longer knows who added the boots.</a:t>
+            </a:r>
+          </a:p>
+        </p:txBody>
+      </p:sp>
+      <p:sp>
+        <p:nvSpPr>
+          <p:cNvPr id="5" name="TextBox 4"/>
+          <p:cNvSpPr txBox="1"/>
+          <p:nvPr/>
+        </p:nvSpPr>
+        <p:spPr>
+          <a:xfrm>
+            <a:off x="822960" y="4481654"/>
+            <a:ext cx="10545775" cy="274320"/>
+          </a:xfrm>
+          <a:prstGeom prst="rect">
+            <a:avLst/>
+          </a:prstGeom>
+          <a:noFill/>
+        </p:spPr>
+        <p:txBody>
+          <a:bodyPr wrap="square" anchor="t" lIns="0" rIns="0" tIns="0" bIns="0"/>
+          <a:lstStyle/>
+          <a:p>
+            <a:pPr algn="l">
+              <a:lnSpc>
+                <a:spcPct val="110000"/>
+              </a:lnSpc>
+            </a:pPr>
+            <a:r>
+              <a:rPr sz="1400" b="1">
+                <a:solidFill>
+                  <a:srgbClr val="707078"/>
+                </a:solidFill>
+                <a:latin typeface="Inter"/>
+              </a:rPr>
+              <a:t>PAIRS, IN THE APP</a:t>
+            </a:r>
+          </a:p>
+        </p:txBody>
+      </p:sp>
+      <p:sp>
+        <p:nvSpPr>
+          <p:cNvPr id="6" name="TextBox 5"/>
+          <p:cNvSpPr txBox="1"/>
+          <p:nvPr/>
+        </p:nvSpPr>
+        <p:spPr>
+          <a:xfrm>
+            <a:off x="822960" y="4801694"/>
+            <a:ext cx="10545775" cy="826129"/>
+          </a:xfrm>
+          <a:prstGeom prst="rect">
+            <a:avLst/>
+          </a:prstGeom>
+          <a:noFill/>
+        </p:spPr>
+        <p:txBody>
+          <a:bodyPr wrap="square" anchor="t" lIns="0" rIns="0" tIns="0" bIns="0"/>
+          <a:lstStyle/>
+          <a:p>
+            <a:pPr algn="l">
+              <a:lnSpc>
+                <a:spcPct val="112000"/>
+              </a:lnSpc>
+            </a:pPr>
+            <a:r>
+              <a:rPr sz="2400" b="1">
+                <a:solidFill>
+                  <a:srgbClr val="8B3DFF"/>
+                </a:solidFill>
+                <a:latin typeface="Inter"/>
+              </a:rPr>
+              <a:t>Your team squash-merges every feature branch and deletes it. What do you gain, and what can an auditor no longer answer?</a:t>
+            </a:r>
+          </a:p>
+        </p:txBody>
+      </p:sp>
+    </p:spTree>
+  </p:cSld>
+  <p:clrMapOvr>
+    <a:masterClrMapping/>
+  </p:clrMapOvr>
+</p:sld>
+</file>
+
+<file path=ppt/slides/slide12.xml><?xml version="1.0" encoding="utf-8"?>
 <p:sld xmlns:a="http://schemas.openxmlformats.org/drawingml/2006/main" xmlns:p="http://schemas.openxmlformats.org/presentationml/2006/main" xmlns:r="http://schemas.openxmlformats.org/officeDocument/2006/relationships">
   <p:cSld>
     <p:bg>
@@ -7060,6 +7321,72 @@
           </a:p>
         </p:txBody>
       </p:sp>
+      <p:sp>
+        <p:nvSpPr>
+          <p:cNvPr id="14" name="Rectangle 13"/>
+          <p:cNvSpPr/>
+          <p:nvPr/>
+        </p:nvSpPr>
+        <p:spPr>
+          <a:xfrm>
+            <a:off x="822960" y="5301242"/>
+            <a:ext cx="73152" cy="757285"/>
+          </a:xfrm>
+          <a:prstGeom prst="rect">
+            <a:avLst/>
+          </a:prstGeom>
+          <a:solidFill>
+            <a:srgbClr val="F5A524"/>
+          </a:solidFill>
+          <a:ln>
+            <a:noFill/>
+          </a:ln>
+        </p:spPr>
+        <p:txBody>
+          <a:bodyPr rtlCol="0" anchor="ctr"/>
+          <a:lstStyle/>
+          <a:p>
+            <a:pPr algn="ctr"/>
+          </a:p>
+        </p:txBody>
+      </p:sp>
+      <p:sp>
+        <p:nvSpPr>
+          <p:cNvPr id="15" name="TextBox 14"/>
+          <p:cNvSpPr txBox="1"/>
+          <p:nvPr/>
+        </p:nvSpPr>
+        <p:spPr>
+          <a:xfrm>
+            <a:off x="1188720" y="5301242"/>
+            <a:ext cx="10180015" cy="757285"/>
+          </a:xfrm>
+          <a:prstGeom prst="rect">
+            <a:avLst/>
+          </a:prstGeom>
+          <a:noFill/>
+        </p:spPr>
+        <p:txBody>
+          <a:bodyPr wrap="square" anchor="t" lIns="0" rIns="0" tIns="0" bIns="0"/>
+          <a:lstStyle/>
+          <a:p>
+            <a:pPr algn="l">
+              <a:lnSpc>
+                <a:spcPct val="112000"/>
+              </a:lnSpc>
+            </a:pPr>
+            <a:r>
+              <a:rPr sz="2200" b="1">
+                <a:solidFill>
+                  <a:srgbClr val="111111"/>
+                </a:solidFill>
+                <a:latin typeface="Inter"/>
+              </a:rPr>
+              <a:t>In real Git, each of you would have your own clone with one working directory. Here your lab shares one repo.</a:t>
+            </a:r>
+          </a:p>
+        </p:txBody>
+      </p:sp>
     </p:spTree>
   </p:cSld>
   <p:clrMapOvr>
@@ -7402,7 +7729,7 @@
                 </a:solidFill>
                 <a:latin typeface="Inter"/>
               </a:rPr>
-              <a:t>keeps a change made on one side. It stops for a person when both sides changed the same lines.</a:t>
+              <a:t>keeps a change made on one side. It stops for a person when both sides changed the same or neighbouring lines.</a:t>
             </a:r>
           </a:p>
         </p:txBody>
@@ -7416,7 +7743,7 @@
         <p:spPr>
           <a:xfrm>
             <a:off x="822960" y="4043719"/>
-            <a:ext cx="10545775" cy="1779219"/>
+            <a:ext cx="10545775" cy="2123440"/>
           </a:xfrm>
           <a:prstGeom prst="roundRect">
             <a:avLst>
@@ -7483,7 +7810,7 @@
         <p:spPr>
           <a:xfrm>
             <a:off x="3017520" y="4244887"/>
-            <a:ext cx="8122615" cy="1376883"/>
+            <a:ext cx="8122615" cy="1721104"/>
           </a:xfrm>
           <a:prstGeom prst="rect">
             <a:avLst/>
@@ -7506,7 +7833,7 @@
                 </a:solidFill>
                 <a:latin typeface="Inter"/>
               </a:rPr>
-              <a:t>Git finds the merge base (the last common commit) and compares each side with it (a 3-way merge). Then it writes a merge commit with two parents. If one side is ahead, it fast-forwards: only the label moves, and no merge commit is made.</a:t>
+              <a:t>Git finds the merge base (the last common commit) and compares each side with it (a 3-way merge), then writes a merge commit with two parents. If your branch has nothing new (the other side already contains it), Git fast-forwards: only the label moves, and no merge commit is made.</a:t>
             </a:r>
           </a:p>
         </p:txBody>

</xml_diff>

<commit_message>
Tuesday: every word rewritten in plain sentences
Plain titles (Save every version, Give each idea its own branch, Combine two
branches, Share your work through the Wall, Undo a change everyone already
has, Rewrite the shared history). Instructions are full sentences with the
Git word on first use; cards are exact; no slogans or cute labels.
Tests: 86/86 unit, full class e2e, bots rehearsal; deck rebuilt (12 slides).

Co-Authored-By: Claude Fable 5.1 <noreply@anthropic.com>
</commit_message>
<xml_diff>
--- a/slides/tuesday_app.pptx
+++ b/slides/tuesday_app.pptx
@@ -583,7 +583,7 @@
           <a:lstStyle/>
           <a:p>
             <a:r>
-              <a:t>Say: You just lived this paper. Teams at Microsoft moved to Git. Microsoft tracks code velocity: how long a change takes to reach main, along its integration path. After the squash, the Wall has no path left. The paper: for analysts, flat history is data loss. For developers it helps: a bad change is quick to find and revert.</a:t>
+              <a:t>Say: You have just lived this paper. Teams at Microsoft moved to Git. Microsoft tracks code velocity: how long a change takes to reach main, along its integration path. After the squash, the Wall has no path left. The paper's claim: for analysts, flat history is data loss. For developers it helps: a bad change is quick to find and revert.</a:t>
             </a:r>
           </a:p>
           <a:p/>
@@ -665,7 +665,7 @@
           <a:lstStyle/>
           <a:p>
             <a:r>
-              <a:t>Say: You just lived this paper. Teams at Microsoft moved to Git. Microsoft tracks code velocity: how long a change takes to reach main, along its integration path. After the squash, the Wall has no path left. The paper: for analysts, flat history is data loss. For developers it helps: a bad change is quick to find and revert.</a:t>
+              <a:t>Say: You have just lived this paper. Teams at Microsoft moved to Git. Microsoft tracks code velocity: how long a change takes to reach main, along its integration path. After the squash, the Wall has no path left. The paper's claim: for analysts, flat history is data loss. For developers it helps: a bad change is quick to find and revert.</a:t>
             </a:r>
           </a:p>
           <a:p/>
@@ -747,7 +747,7 @@
           <a:lstStyle/>
           <a:p>
             <a:r>
-              <a:t>Say: Cards never change. Sticky notes move. The Wall copies cards. That's Git. Homework: Yang et al., Sections 3.2 to 3.5. For one finding, write down what they measured.</a:t>
+              <a:t>Say: A commit never changes, a branch is a pointer that moves, and the Wall holds copies of those commits. That is the whole model. Homework: Yang et al., Sections 3.2 to 3.5. For one finding, write down what they measured.</a:t>
             </a:r>
           </a:p>
         </p:txBody>
@@ -817,7 +817,7 @@
           <a:lstStyle/>
           <a:p>
             <a:r>
-              <a:t>Say: No Git lecture today. You'll hit seven problems, and your lab invents a fix for each. Every save, merge, send and undo runs real Git.</a:t>
+              <a:t>Say: There is no Git lecture today. You will meet seven problems in turn, and your lab works out a fix for each one. Every save, merge, send and undo runs real Git on the server.</a:t>
             </a:r>
           </a:p>
         </p:txBody>
@@ -887,19 +887,19 @@
           <a:lstStyle/>
           <a:p>
             <a:r>
-              <a:t>Say: git commit stores the whole outfit, the card before, your name, the time and a message. The ID is computed from all of it, so any change makes a new card. The name and the time are whatever your laptop says.</a:t>
+              <a:t>Say: git commit stores the whole outfit, the card before it, your name, the time and a message. The ID is computed from all of that, so any change makes a new card. The name and the time are whatever your laptop says.</a:t>
             </a:r>
           </a:p>
           <a:p/>
           <a:p>
             <a:r>
-              <a:t>Ask: Why do arrows point back, never forward?</a:t>
+              <a:t>Ask: Why do the arrows point back, never forward?</a:t>
             </a:r>
           </a:p>
           <a:p/>
           <a:p>
             <a:r>
-              <a:t>Hope to hear: The next card doesn't exist yet. Cards never change.</a:t>
+              <a:t>Hope to hear: The next card does not exist yet, and cards never change.</a:t>
             </a:r>
           </a:p>
         </p:txBody>
@@ -969,7 +969,7 @@
           <a:lstStyle/>
           <a:p>
             <a:r>
-              <a:t>Say: A branch is a tiny file holding one card's ID. Your pin (HEAD) says which note you're on. Saving moves only that note.</a:t>
+              <a:t>Say: A branch is a tiny file holding one card's ID. Your pin (HEAD) says which note you are on. Saving moves only that note.</a:t>
             </a:r>
           </a:p>
           <a:p/>
@@ -1051,7 +1051,7 @@
           <a:lstStyle/>
           <a:p>
             <a:r>
-              <a:t>Say: The first merge only slid the note: a fast-forward, no new card. Then Git compared each side with the card where you split. Only TOP changed on both sides, so only TOP needed you.</a:t>
+              <a:t>Say: The first merge only moved the note forward: a fast-forward, with no new card. Then Git compared each side with the card where they split. Only TOP changed on both sides, so only TOP needed you.</a:t>
             </a:r>
           </a:p>
           <a:p/>
@@ -1063,7 +1063,7 @@
           <a:p/>
           <a:p>
             <a:r>
-              <a:t>Hope to hear: No way to tell. Git does not record the branch a commit was made on.</a:t>
+              <a:t>Hope to hear: There is no way to tell. Git does not record the branch a commit was made on.</a:t>
             </a:r>
           </a:p>
         </p:txBody>
@@ -1133,7 +1133,7 @@
           <a:lstStyle/>
           <a:p>
             <a:r>
-              <a:t>Say: The Wall is the class's shared copy, like GitHub. Your lab already has a full copy of it (that is git clone). It starts as the first lab's outfit. Put your outfit on the Wall. Before each send, predict: will the Wall accept it?</a:t>
+              <a:t>Say: The Wall is the class's shared copy, like GitHub. Your lab already holds a full copy of it, which is what git clone makes. It started from the first lab's outfit. Put your lab's change on the Wall. Before each send, predict whether the Wall will accept it.</a:t>
             </a:r>
           </a:p>
         </p:txBody>
@@ -1203,7 +1203,7 @@
           <a:lstStyle/>
           <a:p>
             <a:r>
-              <a:t>Say: The Wall only moves forward, so a refused lab gets the Wall's cards first. Combine makes a merge card with two parents (Step 3 made one too). Replay on top makes a straight line: a copy of the card with the same change, author and author time, but a new parent, snapshot, committer time and ID.</a:t>
+              <a:t>Say: The Wall only moves forward, so a refused lab gets the Wall's cards first. Combine makes a merge card with two parents, as Step 3 did. Replay on top makes a straight line: a copy of the card with the same change, author and author time, but a new parent, snapshot, committer time and ID.</a:t>
             </a:r>
           </a:p>
           <a:p/>
@@ -1285,7 +1285,7 @@
           <a:lstStyle/>
           <a:p>
             <a:r>
-              <a:t>Say: git revert adds a card that undoes the old one, so it sends like any card. git reset moves your note back, but the Wall still has the card.</a:t>
+              <a:t>Say: git revert adds a card that undoes the old one, so it is sent like any other card. git reset moves your note back, but the Wall still has the card.</a:t>
             </a:r>
           </a:p>
           <a:p/>
@@ -1297,7 +1297,7 @@
           <a:p/>
           <a:p>
             <a:r>
-              <a:t>Hope to hear: A fix card only adds. Moving back drops a shared card.</a:t>
+              <a:t>Hope to hear: A fix card only adds. Moving back drops a card other people already have.</a:t>
             </a:r>
           </a:p>
         </p:txBody>
@@ -1367,7 +1367,7 @@
           <a:lstStyle/>
           <a:p>
             <a:r>
-              <a:t>Say: The Wall no longer knows who added the boots. The other labs still do. The old cards wait in the Wall's bin.</a:t>
+              <a:t>Say: The Wall no longer knows who added the boots. The other labs still do. The old cards wait in the Wall's bin until gc removes them.</a:t>
             </a:r>
           </a:p>
           <a:p/>
@@ -4439,7 +4439,7 @@
         <p:spPr>
           <a:xfrm>
             <a:off x="822960" y="3520440"/>
-            <a:ext cx="10545775" cy="1097280"/>
+            <a:ext cx="8442655" cy="1097280"/>
           </a:xfrm>
           <a:prstGeom prst="rect">
             <a:avLst/>
@@ -4992,7 +4992,7 @@
         <p:spPr>
           <a:xfrm>
             <a:off x="822960" y="1965960"/>
-            <a:ext cx="3271418" cy="1442393"/>
+            <a:ext cx="3271418" cy="1752192"/>
           </a:xfrm>
           <a:prstGeom prst="rect">
             <a:avLst/>
@@ -5018,7 +5018,7 @@
                 </a:solidFill>
                 <a:latin typeface="Inter"/>
               </a:rPr>
-              <a:t>Cheap branches.</a:t>
+              <a:t>Branches are cheap.</a:t>
             </a:r>
           </a:p>
           <a:p>
@@ -5037,7 +5037,7 @@
                 </a:solidFill>
                 <a:latin typeface="Inter"/>
               </a:rPr>
-              <a:t>Local commits and reverts.</a:t>
+              <a:t>Commits and reverts are local.</a:t>
             </a:r>
           </a:p>
           <a:p>
@@ -5200,7 +5200,7 @@
                 </a:solidFill>
                 <a:latin typeface="Inter"/>
               </a:rPr>
-              <a:t>Squash can drop the cards — and, once the branch is deleted, even who made them.</a:t>
+              <a:t>Squash drops the individual commits. Once the branch is deleted, it drops who made them and when.</a:t>
             </a:r>
           </a:p>
         </p:txBody>
@@ -5344,7 +5344,7 @@
                 </a:solidFill>
                 <a:latin typeface="Inter"/>
               </a:rPr>
-              <a:t>Some loss cannot be recovered.</a:t>
+              <a:t>Some of the loss cannot be recovered.</a:t>
             </a:r>
           </a:p>
         </p:txBody>
@@ -5536,7 +5536,7 @@
         <p:spPr>
           <a:xfrm>
             <a:off x="822960" y="1371600"/>
-            <a:ext cx="10545775" cy="2652854"/>
+            <a:ext cx="10545775" cy="3031497"/>
           </a:xfrm>
           <a:prstGeom prst="rect">
             <a:avLst/>
@@ -5562,7 +5562,7 @@
                 </a:solidFill>
                 <a:latin typeface="Inter"/>
               </a:rPr>
-              <a:t>Step 3: after the fast-forward, you deleted fancy. No card says which cards were made on it.</a:t>
+              <a:t>Step 3: after the fast-forward, you deleted the fancy note. No card records which cards were made on it.</a:t>
             </a:r>
           </a:p>
           <a:p>
@@ -5581,7 +5581,7 @@
                 </a:solidFill>
                 <a:latin typeface="Inter"/>
               </a:rPr>
-              <a:t>Step 4: Replay on top made a copy with a new ID; the original card is not on the Wall.</a:t>
+              <a:t>Step 4: Replay on top made a copy with a new ID. The original card is not on the Wall.</a:t>
             </a:r>
           </a:p>
           <a:p>
@@ -5600,7 +5600,7 @@
                 </a:solidFill>
                 <a:latin typeface="Inter"/>
               </a:rPr>
-              <a:t>Step 6: the squash dropped the cards, and who made them.</a:t>
+              <a:t>Step 6: the squash dropped the individual cards, and with them who made each one.</a:t>
             </a:r>
           </a:p>
           <a:p>
@@ -5632,7 +5632,7 @@
         </p:nvSpPr>
         <p:spPr>
           <a:xfrm>
-            <a:off x="822960" y="4481654"/>
+            <a:off x="822960" y="4860297"/>
             <a:ext cx="10545775" cy="274320"/>
           </a:xfrm>
           <a:prstGeom prst="rect">
@@ -5669,7 +5669,7 @@
         </p:nvSpPr>
         <p:spPr>
           <a:xfrm>
-            <a:off x="822960" y="4801694"/>
+            <a:off x="822960" y="5180337"/>
             <a:ext cx="10545775" cy="826129"/>
           </a:xfrm>
           <a:prstGeom prst="rect">
@@ -6069,13 +6069,13 @@
               </a:lnSpc>
             </a:pPr>
             <a:r>
-              <a:rPr sz="6000" b="1">
+              <a:rPr sz="4800" b="1">
                 <a:solidFill>
                   <a:srgbClr val="FFFFFF"/>
                 </a:solidFill>
                 <a:latin typeface="Inter"/>
               </a:rPr>
-              <a:t>Cards never change.</a:t>
+              <a:t>A commit never changes.</a:t>
             </a:r>
           </a:p>
           <a:p>
@@ -6085,13 +6085,13 @@
               </a:lnSpc>
             </a:pPr>
             <a:r>
-              <a:rPr sz="6000" b="1">
+              <a:rPr sz="4800" b="1">
                 <a:solidFill>
                   <a:srgbClr val="FFFFFF"/>
                 </a:solidFill>
                 <a:latin typeface="Inter"/>
               </a:rPr>
-              <a:t>Sticky notes move.</a:t>
+              <a:t>A branch is a pointer that moves.</a:t>
             </a:r>
           </a:p>
           <a:p>
@@ -6101,13 +6101,13 @@
               </a:lnSpc>
             </a:pPr>
             <a:r>
-              <a:rPr sz="6000" b="1">
+              <a:rPr sz="4800" b="1">
                 <a:solidFill>
                   <a:srgbClr val="FFFFFF"/>
                 </a:solidFill>
                 <a:latin typeface="Inter"/>
               </a:rPr>
-              <a:t>The Wall copies cards.</a:t>
+              <a:t>The Wall holds copies of commits.</a:t>
             </a:r>
           </a:p>
         </p:txBody>
@@ -6330,7 +6330,7 @@
                 </a:solidFill>
                 <a:latin typeface="Inter"/>
               </a:rPr>
-              <a:t>The app picks your lab.</a:t>
+              <a:t>The app puts you in a lab.</a:t>
             </a:r>
           </a:p>
         </p:txBody>
@@ -6574,7 +6574,7 @@
                 </a:solidFill>
                 <a:latin typeface="Inter"/>
               </a:rPr>
-              <a:t>a saved snapshot of the whole project.</a:t>
+              <a:t>A saved snapshot of the whole project.</a:t>
             </a:r>
           </a:p>
         </p:txBody>
@@ -6677,7 +6677,7 @@
                 </a:solidFill>
                 <a:latin typeface="Inter"/>
               </a:rPr>
-              <a:t>records the exact state, who saved it, when, and the commit before it.</a:t>
+              <a:t>Records the exact state, who saved it, when, and the commit before it.</a:t>
             </a:r>
           </a:p>
         </p:txBody>
@@ -6781,7 +6781,7 @@
                 </a:solidFill>
                 <a:latin typeface="Inter"/>
               </a:rPr>
-              <a:t>each file is stored as a blob, the folder as a tree. A commit object = tree ID + parent ID(s) + author + committer + message. Its ID is the SHA-1 of that object, so any change gives a new ID. Nothing is edited in place.</a:t>
+              <a:t>Each file is stored as a blob, the folder as a tree. A commit holds the tree ID, parent ID(s), author, committer and message. Its ID is the SHA-1 of all that, so any change gives a new ID. Nothing is edited in place.</a:t>
             </a:r>
           </a:p>
         </p:txBody>
@@ -6847,7 +6847,7 @@
                 </a:solidFill>
                 <a:latin typeface="Inter"/>
               </a:rPr>
-              <a:t>Git stores the name and clock your laptop gives it. It checks neither.</a:t>
+              <a:t>Git records the name and clock your laptop gives it, and checks neither.</a:t>
             </a:r>
           </a:p>
         </p:txBody>
@@ -6951,7 +6951,7 @@
                 </a:solidFill>
                 <a:latin typeface="Inter"/>
               </a:rPr>
-              <a:t>Try two ideas at once</a:t>
+              <a:t>Give each idea its own branch</a:t>
             </a:r>
           </a:p>
         </p:txBody>
@@ -7091,7 +7091,7 @@
                 </a:solidFill>
                 <a:latin typeface="Inter"/>
               </a:rPr>
-              <a:t>a movable label on one commit.</a:t>
+              <a:t>A movable label on one commit.</a:t>
             </a:r>
           </a:p>
         </p:txBody>
@@ -7194,7 +7194,7 @@
                 </a:solidFill>
                 <a:latin typeface="Inter"/>
               </a:rPr>
-              <a:t>lets you try an idea without touching main.</a:t>
+              <a:t>Lets you work on an idea without touching main.</a:t>
             </a:r>
           </a:p>
         </p:txBody>
@@ -7298,7 +7298,7 @@
                 </a:solidFill>
                 <a:latin typeface="Inter"/>
               </a:rPr>
-              <a:t>a branch is a tiny file (</a:t>
+              <a:t>A branch is a tiny file (</a:t>
             </a:r>
             <a:r>
               <a:rPr sz="2000" b="0">
@@ -7382,7 +7382,7 @@
                 </a:solidFill>
                 <a:latin typeface="Inter"/>
               </a:rPr>
-              <a:t>In real Git, each of you would have your own clone with one working directory. Here your lab shares one repo.</a:t>
+              <a:t>In real Git, each of you would have your own clone with one working directory. Here your lab shares one repository.</a:t>
             </a:r>
           </a:p>
         </p:txBody>
@@ -7486,7 +7486,7 @@
                 </a:solidFill>
                 <a:latin typeface="Inter"/>
               </a:rPr>
-              <a:t>Make one outfit from both</a:t>
+              <a:t>Combine two branches</a:t>
             </a:r>
           </a:p>
         </p:txBody>
@@ -7626,7 +7626,7 @@
                 </a:solidFill>
                 <a:latin typeface="Inter"/>
               </a:rPr>
-              <a:t>combining two lines of work.</a:t>
+              <a:t>Combining two lines of work into one.</a:t>
             </a:r>
           </a:p>
         </p:txBody>
@@ -7729,7 +7729,7 @@
                 </a:solidFill>
                 <a:latin typeface="Inter"/>
               </a:rPr>
-              <a:t>keeps a change made on one side. It stops for a person when both sides changed the same or neighbouring lines.</a:t>
+              <a:t>Keeps a change made on one side. It stops for a person when both sides changed the same or neighbouring lines.</a:t>
             </a:r>
           </a:p>
         </p:txBody>
@@ -7833,7 +7833,7 @@
                 </a:solidFill>
                 <a:latin typeface="Inter"/>
               </a:rPr>
-              <a:t>Git finds the merge base (the last common commit) and compares each side with it (a 3-way merge), then writes a merge commit with two parents. If your branch has nothing new (the other side already contains it), Git fast-forwards: only the label moves, and no merge commit is made.</a:t>
+              <a:t>Git finds the merge base (the last commit both sides share), compares each side with it (a 3-way merge), and writes a merge commit with two parents. If your branch has nothing new, Git fast-forwards: only the label moves, and no merge commit is made.</a:t>
             </a:r>
           </a:p>
         </p:txBody>
@@ -7937,7 +7937,7 @@
                 </a:solidFill>
                 <a:latin typeface="Inter"/>
               </a:rPr>
-              <a:t>Put your outfit on the Wall</a:t>
+              <a:t>Share your work through the Wall</a:t>
             </a:r>
           </a:p>
         </p:txBody>
@@ -8077,7 +8077,7 @@
                 </a:solidFill>
                 <a:latin typeface="Inter"/>
               </a:rPr>
-              <a:t>sharing commits with a copy elsewhere (the Wall).</a:t>
+              <a:t>Sharing commits with a copy elsewhere, here the Wall.</a:t>
             </a:r>
           </a:p>
         </p:txBody>
@@ -8180,7 +8180,7 @@
                 </a:solidFill>
                 <a:latin typeface="Inter"/>
               </a:rPr>
-              <a:t>push sends your new commits and moves the remote branch. pull brings theirs in.</a:t>
+              <a:t>push sends your new commits and moves the remote branch. pull brings the remote's new commits into yours.</a:t>
             </a:r>
           </a:p>
         </p:txBody>
@@ -8284,7 +8284,7 @@
                 </a:solidFill>
                 <a:latin typeface="Inter"/>
               </a:rPr>
-              <a:t>copies exchange only the objects the other side lacks; IDs come from content, so copies agree without coordination. A push is accepted only if it is a fast-forward of the remote branch. Otherwise fetch first, then merge or rebase.</a:t>
+              <a:t>Copies exchange only the objects the other side lacks; IDs come from content, so copies agree without coordination. A push is accepted only if it is a fast-forward of the remote branch. Otherwise you fetch first, then merge or rebase.</a:t>
             </a:r>
           </a:p>
         </p:txBody>
@@ -8388,7 +8388,7 @@
                 </a:solidFill>
                 <a:latin typeface="Inter"/>
               </a:rPr>
-              <a:t>Put your outfit on the Wall</a:t>
+              <a:t>Share your work through the Wall</a:t>
             </a:r>
           </a:p>
         </p:txBody>
@@ -8528,7 +8528,7 @@
                 </a:solidFill>
                 <a:latin typeface="Inter"/>
               </a:rPr>
-              <a:t>replaying your commits on top of another branch.</a:t>
+              <a:t>Replaying your commits on top of another branch.</a:t>
             </a:r>
           </a:p>
         </p:txBody>
@@ -8631,7 +8631,7 @@
                 </a:solidFill>
                 <a:latin typeface="Inter"/>
               </a:rPr>
-              <a:t>gives a straight history with no merge commit.</a:t>
+              <a:t>Gives a straight history with no merge commit.</a:t>
             </a:r>
           </a:p>
         </p:txBody>
@@ -8735,7 +8735,7 @@
                 </a:solidFill>
                 <a:latin typeface="Inter"/>
               </a:rPr>
-              <a:t>for each of your commits, Git applies its change to the new base and writes a new commit. The new parent gives it a new ID. Author and author date are kept. The originals become unreachable and stay in your reflog for a while.</a:t>
+              <a:t>For each of your commits, Git applies its change to the new base and writes a new commit. The new parent gives it a new ID. The author and author date are kept; the committer date is new. The originals become unreachable and stay in your reflog for a while.</a:t>
             </a:r>
           </a:p>
         </p:txBody>
@@ -8839,7 +8839,7 @@
                 </a:solidFill>
                 <a:latin typeface="Inter"/>
               </a:rPr>
-              <a:t>Oops: undo a shared mistake</a:t>
+              <a:t>Undo a change everyone already has</a:t>
             </a:r>
           </a:p>
         </p:txBody>
@@ -8979,7 +8979,7 @@
                 </a:solidFill>
                 <a:latin typeface="Inter"/>
               </a:rPr>
-              <a:t>two kinds of undo.</a:t>
+              <a:t>Two kinds of undo.</a:t>
             </a:r>
           </a:p>
         </p:txBody>
@@ -9082,7 +9082,7 @@
                 </a:solidFill>
                 <a:latin typeface="Inter"/>
               </a:rPr>
-              <a:t>revert adds a commit that undoes an old one, and is safe on shared history. reset moves your branch label back, and is only safe if nobody else has those commits.</a:t>
+              <a:t>revert adds a commit that undoes an old one, and is safe on shared history. reset moves your branch label back, and is safe only if nobody else has the commits you leave behind.</a:t>
             </a:r>
           </a:p>
         </p:txBody>
@@ -9290,7 +9290,7 @@
                 </a:solidFill>
                 <a:latin typeface="Inter"/>
               </a:rPr>
-              <a:t>The boss wants it clean</a:t>
+              <a:t>Rewrite the shared history</a:t>
             </a:r>
           </a:p>
         </p:txBody>
@@ -9430,7 +9430,7 @@
                 </a:solidFill>
                 <a:latin typeface="Inter"/>
               </a:rPr>
-              <a:t>cleaning up history.</a:t>
+              <a:t>Cleaning up history by rewriting it.</a:t>
             </a:r>
           </a:p>
         </p:txBody>
@@ -9533,7 +9533,7 @@
                 </a:solidFill>
                 <a:latin typeface="Inter"/>
               </a:rPr>
-              <a:t>squash turns several commits into one. Force push makes the Wall accept it anyway.</a:t>
+              <a:t>Squash turns several commits into one. A force push makes the Wall accept the rewritten branch.</a:t>
             </a:r>
           </a:p>
         </p:txBody>
@@ -9637,7 +9637,7 @@
                 </a:solidFill>
                 <a:latin typeface="Inter"/>
               </a:rPr>
-              <a:t>squash writes one new commit whose tree is the final state. The originals, with their authors and times, become unreachable. </a:t>
+              <a:t>Squash writes one new commit whose tree is the final state. The originals, with their authors and times, become unreachable. </a:t>
             </a:r>
             <a:r>
               <a:rPr sz="2000" b="0">

</xml_diff>

<commit_message>
Both days rewritten in plain words; one vocabulary; no fact quizzes
Tuesday: every step opens with what is happening, your job (numbered
clicks) and the Git behind it; 'sticky note' is now 'branch' everywhere;
New branch always starts from main, and says so.
Thursday: 17 scenes, no quizzes about the study; the study is told, then
checked (8 posts, 7 comments), judged (4 claims) and designed for (undo);
every title and line is a plain sentence. Message: what people ask shows
where they get stuck, not what they can do.
Docs, one page, brief and both decks match. Tests: 96/96 unit, both days'
browser runs and bot rehearsals.

Co-Authored-By: Claude Fable 5.1 <noreply@anthropic.com>
</commit_message>
<xml_diff>
--- a/slides/tuesday_app.pptx
+++ b/slides/tuesday_app.pptx
@@ -969,7 +969,7 @@
           <a:lstStyle/>
           <a:p>
             <a:r>
-              <a:t>Say: A branch is a tiny file holding one card's ID. Your pin (HEAD) says which note you are on. Saving moves only that note.</a:t>
+              <a:t>Say: A branch is a tiny file holding one card's ID. Your pin (HEAD) says which note you are on. Saving moves only that branch.</a:t>
             </a:r>
           </a:p>
           <a:p/>
@@ -1051,7 +1051,7 @@
           <a:lstStyle/>
           <a:p>
             <a:r>
-              <a:t>Say: The first merge only moved the note forward: a fast-forward, with no new card. Then Git compared each side with the card where they split. Only TOP changed on both sides, so only TOP needed you.</a:t>
+              <a:t>Say: The first merge only moved the branch forward: a fast-forward, with no new card. Then Git compared each side with the card where they split. Only TOP changed on both sides, so only TOP needed you.</a:t>
             </a:r>
           </a:p>
           <a:p/>
@@ -1285,7 +1285,7 @@
           <a:lstStyle/>
           <a:p>
             <a:r>
-              <a:t>Say: git revert adds a card that undoes the old one, so it is sent like any other card. git reset moves your note back, but the Wall still has the card.</a:t>
+              <a:t>Say: git revert adds a card that undoes the old one, so it is sent like any other card. git reset moves your branch back, but the Wall still has the card.</a:t>
             </a:r>
           </a:p>
           <a:p/>
@@ -5562,7 +5562,7 @@
                 </a:solidFill>
                 <a:latin typeface="Inter"/>
               </a:rPr>
-              <a:t>Step 3: after the fast-forward, you deleted the fancy note. No card records which cards were made on it.</a:t>
+              <a:t>Step 3: after the fast-forward, you deleted the fancy branch. No card records which cards were made on it.</a:t>
             </a:r>
           </a:p>
           <a:p>

</xml_diff>